<commit_message>
slides and report week 6 finished
</commit_message>
<xml_diff>
--- a/Documentation/Weekly Report/week6/CMSC-4920-Group2-Week6.pptx
+++ b/Documentation/Weekly Report/week6/CMSC-4920-Group2-Week6.pptx
@@ -4,19 +4,25 @@
   <p:sldMasterIdLst>
     <p:sldMasterId id="2147483648" r:id="rId1"/>
   </p:sldMasterIdLst>
+  <p:notesMasterIdLst>
+    <p:notesMasterId r:id="rId17"/>
+  </p:notesMasterIdLst>
   <p:sldIdLst>
     <p:sldId id="256" r:id="rId2"/>
     <p:sldId id="257" r:id="rId3"/>
     <p:sldId id="265" r:id="rId4"/>
     <p:sldId id="266" r:id="rId5"/>
     <p:sldId id="258" r:id="rId6"/>
-    <p:sldId id="267" r:id="rId7"/>
-    <p:sldId id="268" r:id="rId8"/>
-    <p:sldId id="269" r:id="rId9"/>
-    <p:sldId id="270" r:id="rId10"/>
-    <p:sldId id="264" r:id="rId11"/>
-    <p:sldId id="259" r:id="rId12"/>
-    <p:sldId id="260" r:id="rId13"/>
+    <p:sldId id="271" r:id="rId7"/>
+    <p:sldId id="267" r:id="rId8"/>
+    <p:sldId id="268" r:id="rId9"/>
+    <p:sldId id="269" r:id="rId10"/>
+    <p:sldId id="270" r:id="rId11"/>
+    <p:sldId id="272" r:id="rId12"/>
+    <p:sldId id="273" r:id="rId13"/>
+    <p:sldId id="264" r:id="rId14"/>
+    <p:sldId id="259" r:id="rId15"/>
+    <p:sldId id="260" r:id="rId16"/>
   </p:sldIdLst>
   <p:sldSz cx="12192000" cy="6858000"/>
   <p:notesSz cx="6858000" cy="9144000"/>
@@ -126,7 +132,7 @@
 <file path=ppt/revisionInfo.xml><?xml version="1.0" encoding="utf-8"?>
 <p1510:revInfo xmlns:a="http://schemas.openxmlformats.org/drawingml/2006/main" xmlns:r="http://schemas.openxmlformats.org/officeDocument/2006/relationships" xmlns:p1510="http://schemas.microsoft.com/office/powerpoint/2015/10/main">
   <p1510:revLst>
-    <p1510:client id="{46B216D2-F8DA-4105-B564-CD4DC1BB17F8}" v="3" dt="2026-02-21T22:02:04.293"/>
+    <p1510:client id="{46B216D2-F8DA-4105-B564-CD4DC1BB17F8}" v="8" dt="2026-02-22T13:12:56.427"/>
   </p1510:revLst>
 </p1510:revInfo>
 </file>
@@ -160,71 +166,16 @@
   <pc:docChgLst>
     <pc:chgData name="Margo Bonal" userId="18c9fa0f-b53d-478b-9dc0-6ad88786c19f" providerId="ADAL" clId="{93D479E5-F67F-4B8A-A78F-A0B574A116B6}"/>
     <pc:docChg chg="undo custSel addSld modSld">
-      <pc:chgData name="Margo Bonal" userId="18c9fa0f-b53d-478b-9dc0-6ad88786c19f" providerId="ADAL" clId="{93D479E5-F67F-4B8A-A78F-A0B574A116B6}" dt="2026-02-21T22:02:52.738" v="1754" actId="21"/>
+      <pc:chgData name="Margo Bonal" userId="18c9fa0f-b53d-478b-9dc0-6ad88786c19f" providerId="ADAL" clId="{93D479E5-F67F-4B8A-A78F-A0B574A116B6}" dt="2026-02-22T13:31:07.022" v="2184" actId="1076"/>
       <pc:docMkLst>
         <pc:docMk/>
       </pc:docMkLst>
-      <pc:sldChg chg="addSp delSp modSp new mod setBg">
-        <pc:chgData name="Margo Bonal" userId="18c9fa0f-b53d-478b-9dc0-6ad88786c19f" providerId="ADAL" clId="{93D479E5-F67F-4B8A-A78F-A0B574A116B6}" dt="2026-01-22T19:12:02.971" v="227" actId="26606"/>
-        <pc:sldMkLst>
-          <pc:docMk/>
-          <pc:sldMk cId="1562194928" sldId="256"/>
-        </pc:sldMkLst>
-        <pc:spChg chg="mod">
-          <ac:chgData name="Margo Bonal" userId="18c9fa0f-b53d-478b-9dc0-6ad88786c19f" providerId="ADAL" clId="{93D479E5-F67F-4B8A-A78F-A0B574A116B6}" dt="2026-01-22T19:12:02.971" v="227" actId="26606"/>
-          <ac:spMkLst>
-            <pc:docMk/>
-            <pc:sldMk cId="1562194928" sldId="256"/>
-            <ac:spMk id="2" creationId="{7E1F449D-2BD2-97B5-DCE5-EA7AA820BE81}"/>
-          </ac:spMkLst>
-        </pc:spChg>
-        <pc:spChg chg="mod">
-          <ac:chgData name="Margo Bonal" userId="18c9fa0f-b53d-478b-9dc0-6ad88786c19f" providerId="ADAL" clId="{93D479E5-F67F-4B8A-A78F-A0B574A116B6}" dt="2026-01-22T19:12:02.971" v="227" actId="26606"/>
-          <ac:spMkLst>
-            <pc:docMk/>
-            <pc:sldMk cId="1562194928" sldId="256"/>
-            <ac:spMk id="3" creationId="{BFFB11B0-F653-A213-DE0D-88B0308AFCD4}"/>
-          </ac:spMkLst>
-        </pc:spChg>
-        <pc:spChg chg="add">
-          <ac:chgData name="Margo Bonal" userId="18c9fa0f-b53d-478b-9dc0-6ad88786c19f" providerId="ADAL" clId="{93D479E5-F67F-4B8A-A78F-A0B574A116B6}" dt="2026-01-22T19:12:02.971" v="227" actId="26606"/>
-          <ac:spMkLst>
-            <pc:docMk/>
-            <pc:sldMk cId="1562194928" sldId="256"/>
-            <ac:spMk id="20" creationId="{934F1179-B481-4F9E-BCA3-AFB972070F83}"/>
-          </ac:spMkLst>
-        </pc:spChg>
-        <pc:spChg chg="add">
-          <ac:chgData name="Margo Bonal" userId="18c9fa0f-b53d-478b-9dc0-6ad88786c19f" providerId="ADAL" clId="{93D479E5-F67F-4B8A-A78F-A0B574A116B6}" dt="2026-01-22T19:12:02.971" v="227" actId="26606"/>
-          <ac:spMkLst>
-            <pc:docMk/>
-            <pc:sldMk cId="1562194928" sldId="256"/>
-            <ac:spMk id="21" creationId="{827DC2C4-B485-428A-BF4A-472D2967F47F}"/>
-          </ac:spMkLst>
-        </pc:spChg>
-        <pc:spChg chg="add">
-          <ac:chgData name="Margo Bonal" userId="18c9fa0f-b53d-478b-9dc0-6ad88786c19f" providerId="ADAL" clId="{93D479E5-F67F-4B8A-A78F-A0B574A116B6}" dt="2026-01-22T19:12:02.971" v="227" actId="26606"/>
-          <ac:spMkLst>
-            <pc:docMk/>
-            <pc:sldMk cId="1562194928" sldId="256"/>
-            <ac:spMk id="22" creationId="{EE04B5EB-F158-4507-90DD-BD23620C7CC9}"/>
-          </ac:spMkLst>
-        </pc:spChg>
-      </pc:sldChg>
       <pc:sldChg chg="addSp delSp modSp new mod setBg">
         <pc:chgData name="Margo Bonal" userId="18c9fa0f-b53d-478b-9dc0-6ad88786c19f" providerId="ADAL" clId="{93D479E5-F67F-4B8A-A78F-A0B574A116B6}" dt="2026-01-23T14:29:37.986" v="725" actId="207"/>
         <pc:sldMkLst>
           <pc:docMk/>
           <pc:sldMk cId="850630602" sldId="257"/>
         </pc:sldMkLst>
-        <pc:spChg chg="mod">
-          <ac:chgData name="Margo Bonal" userId="18c9fa0f-b53d-478b-9dc0-6ad88786c19f" providerId="ADAL" clId="{93D479E5-F67F-4B8A-A78F-A0B574A116B6}" dt="2026-01-22T19:33:58.342" v="451" actId="14100"/>
-          <ac:spMkLst>
-            <pc:docMk/>
-            <pc:sldMk cId="850630602" sldId="257"/>
-            <ac:spMk id="2" creationId="{F4D47601-A3D5-5EAD-C1BB-4EBE55051F15}"/>
-          </ac:spMkLst>
-        </pc:spChg>
         <pc:spChg chg="mod">
           <ac:chgData name="Margo Bonal" userId="18c9fa0f-b53d-478b-9dc0-6ad88786c19f" providerId="ADAL" clId="{93D479E5-F67F-4B8A-A78F-A0B574A116B6}" dt="2026-01-23T14:29:37.986" v="725" actId="207"/>
           <ac:spMkLst>
@@ -233,38 +184,6 @@
             <ac:spMk id="3" creationId="{3AD821AA-AA04-E3EB-5027-44FA0EFD591D}"/>
           </ac:spMkLst>
         </pc:spChg>
-        <pc:spChg chg="add">
-          <ac:chgData name="Margo Bonal" userId="18c9fa0f-b53d-478b-9dc0-6ad88786c19f" providerId="ADAL" clId="{93D479E5-F67F-4B8A-A78F-A0B574A116B6}" dt="2026-01-22T19:33:55.456" v="450" actId="26606"/>
-          <ac:spMkLst>
-            <pc:docMk/>
-            <pc:sldMk cId="850630602" sldId="257"/>
-            <ac:spMk id="21" creationId="{9C7E0A2C-7C0A-4AAC-B3B0-6C12B2EBAE05}"/>
-          </ac:spMkLst>
-        </pc:spChg>
-        <pc:spChg chg="add">
-          <ac:chgData name="Margo Bonal" userId="18c9fa0f-b53d-478b-9dc0-6ad88786c19f" providerId="ADAL" clId="{93D479E5-F67F-4B8A-A78F-A0B574A116B6}" dt="2026-01-22T19:33:55.456" v="450" actId="26606"/>
-          <ac:spMkLst>
-            <pc:docMk/>
-            <pc:sldMk cId="850630602" sldId="257"/>
-            <ac:spMk id="22" creationId="{5EB7D2A2-F448-44D4-938C-DC84CBCB3B1E}"/>
-          </ac:spMkLst>
-        </pc:spChg>
-        <pc:spChg chg="add">
-          <ac:chgData name="Margo Bonal" userId="18c9fa0f-b53d-478b-9dc0-6ad88786c19f" providerId="ADAL" clId="{93D479E5-F67F-4B8A-A78F-A0B574A116B6}" dt="2026-01-22T19:33:55.456" v="450" actId="26606"/>
-          <ac:spMkLst>
-            <pc:docMk/>
-            <pc:sldMk cId="850630602" sldId="257"/>
-            <ac:spMk id="23" creationId="{871AEA07-1E14-44B4-8E55-64EF049CD66F}"/>
-          </ac:spMkLst>
-        </pc:spChg>
-        <pc:cxnChg chg="add">
-          <ac:chgData name="Margo Bonal" userId="18c9fa0f-b53d-478b-9dc0-6ad88786c19f" providerId="ADAL" clId="{93D479E5-F67F-4B8A-A78F-A0B574A116B6}" dt="2026-01-22T19:33:55.456" v="450" actId="26606"/>
-          <ac:cxnSpMkLst>
-            <pc:docMk/>
-            <pc:sldMk cId="850630602" sldId="257"/>
-            <ac:cxnSpMk id="25" creationId="{F7C8EA93-3210-4C62-99E9-153C275E3A87}"/>
-          </ac:cxnSpMkLst>
-        </pc:cxnChg>
       </pc:sldChg>
       <pc:sldChg chg="addSp delSp modSp new mod setBg">
         <pc:chgData name="Margo Bonal" userId="18c9fa0f-b53d-478b-9dc0-6ad88786c19f" providerId="ADAL" clId="{93D479E5-F67F-4B8A-A78F-A0B574A116B6}" dt="2026-02-21T21:31:11.749" v="1042" actId="1076"/>
@@ -272,22 +191,6 @@
           <pc:docMk/>
           <pc:sldMk cId="2065992260" sldId="258"/>
         </pc:sldMkLst>
-        <pc:spChg chg="add">
-          <ac:chgData name="Margo Bonal" userId="18c9fa0f-b53d-478b-9dc0-6ad88786c19f" providerId="ADAL" clId="{93D479E5-F67F-4B8A-A78F-A0B574A116B6}" dt="2026-01-22T19:34:58.880" v="453" actId="26606"/>
-          <ac:spMkLst>
-            <pc:docMk/>
-            <pc:sldMk cId="2065992260" sldId="258"/>
-            <ac:spMk id="5" creationId="{D5B339F4-93B9-4E04-9721-143AD6782EA9}"/>
-          </ac:spMkLst>
-        </pc:spChg>
-        <pc:spChg chg="add">
-          <ac:chgData name="Margo Bonal" userId="18c9fa0f-b53d-478b-9dc0-6ad88786c19f" providerId="ADAL" clId="{93D479E5-F67F-4B8A-A78F-A0B574A116B6}" dt="2026-01-22T19:34:58.880" v="453" actId="26606"/>
-          <ac:spMkLst>
-            <pc:docMk/>
-            <pc:sldMk cId="2065992260" sldId="258"/>
-            <ac:spMk id="14" creationId="{871AEA07-1E14-44B4-8E55-64EF049CD66F}"/>
-          </ac:spMkLst>
-        </pc:spChg>
         <pc:spChg chg="mod">
           <ac:chgData name="Margo Bonal" userId="18c9fa0f-b53d-478b-9dc0-6ad88786c19f" providerId="ADAL" clId="{93D479E5-F67F-4B8A-A78F-A0B574A116B6}" dt="2026-02-21T21:31:11.749" v="1042" actId="1076"/>
           <ac:spMkLst>
@@ -296,14 +199,6 @@
             <ac:spMk id="16" creationId="{1BFE9597-EE45-D183-9C43-FB508195BFBC}"/>
           </ac:spMkLst>
         </pc:spChg>
-        <pc:grpChg chg="add">
-          <ac:chgData name="Margo Bonal" userId="18c9fa0f-b53d-478b-9dc0-6ad88786c19f" providerId="ADAL" clId="{93D479E5-F67F-4B8A-A78F-A0B574A116B6}" dt="2026-01-22T19:34:58.880" v="453" actId="26606"/>
-          <ac:grpSpMkLst>
-            <pc:docMk/>
-            <pc:sldMk cId="2065992260" sldId="258"/>
-            <ac:grpSpMk id="6" creationId="{8734DDD3-F723-4DD3-8ABE-EC0B2AC87D74}"/>
-          </ac:grpSpMkLst>
-        </pc:grpChg>
       </pc:sldChg>
       <pc:sldChg chg="addSp delSp modSp new mod setBg">
         <pc:chgData name="Margo Bonal" userId="18c9fa0f-b53d-478b-9dc0-6ad88786c19f" providerId="ADAL" clId="{93D479E5-F67F-4B8A-A78F-A0B574A116B6}" dt="2026-01-23T14:39:22.112" v="812" actId="14100"/>
@@ -400,7 +295,7 @@
         </pc:cxnChg>
       </pc:sldChg>
       <pc:sldChg chg="modSp mod">
-        <pc:chgData name="Margo Bonal" userId="18c9fa0f-b53d-478b-9dc0-6ad88786c19f" providerId="ADAL" clId="{93D479E5-F67F-4B8A-A78F-A0B574A116B6}" dt="2026-02-20T16:43:26.197" v="1006" actId="20577"/>
+        <pc:chgData name="Margo Bonal" userId="18c9fa0f-b53d-478b-9dc0-6ad88786c19f" providerId="ADAL" clId="{93D479E5-F67F-4B8A-A78F-A0B574A116B6}" dt="2026-02-22T13:30:29.735" v="2182" actId="20577"/>
         <pc:sldMkLst>
           <pc:docMk/>
           <pc:sldMk cId="2561402868" sldId="264"/>
@@ -413,8 +308,8 @@
             <ac:spMk id="9" creationId="{D6D36DC8-D9BF-8C26-69EA-ED89E34DB644}"/>
           </ac:spMkLst>
         </pc:spChg>
-        <pc:graphicFrameChg chg="modGraphic">
-          <ac:chgData name="Margo Bonal" userId="18c9fa0f-b53d-478b-9dc0-6ad88786c19f" providerId="ADAL" clId="{93D479E5-F67F-4B8A-A78F-A0B574A116B6}" dt="2026-02-20T16:43:26.197" v="1006" actId="20577"/>
+        <pc:graphicFrameChg chg="mod modGraphic">
+          <ac:chgData name="Margo Bonal" userId="18c9fa0f-b53d-478b-9dc0-6ad88786c19f" providerId="ADAL" clId="{93D479E5-F67F-4B8A-A78F-A0B574A116B6}" dt="2026-02-22T13:30:29.735" v="2182" actId="20577"/>
           <ac:graphicFrameMkLst>
             <pc:docMk/>
             <pc:sldMk cId="2561402868" sldId="264"/>
@@ -596,7 +491,7 @@
         </pc:picChg>
       </pc:sldChg>
       <pc:sldChg chg="addSp delSp modSp new mod setBg">
-        <pc:chgData name="Margo Bonal" userId="18c9fa0f-b53d-478b-9dc0-6ad88786c19f" providerId="ADAL" clId="{93D479E5-F67F-4B8A-A78F-A0B574A116B6}" dt="2026-02-21T22:02:41.430" v="1752" actId="21"/>
+        <pc:chgData name="Margo Bonal" userId="18c9fa0f-b53d-478b-9dc0-6ad88786c19f" providerId="ADAL" clId="{93D479E5-F67F-4B8A-A78F-A0B574A116B6}" dt="2026-02-22T13:29:17.252" v="2161" actId="14100"/>
         <pc:sldMkLst>
           <pc:docMk/>
           <pc:sldMk cId="2380309321" sldId="268"/>
@@ -650,7 +545,7 @@
           </ac:spMkLst>
         </pc:spChg>
         <pc:picChg chg="add mod">
-          <ac:chgData name="Margo Bonal" userId="18c9fa0f-b53d-478b-9dc0-6ad88786c19f" providerId="ADAL" clId="{93D479E5-F67F-4B8A-A78F-A0B574A116B6}" dt="2026-02-21T22:02:35.902" v="1751" actId="1076"/>
+          <ac:chgData name="Margo Bonal" userId="18c9fa0f-b53d-478b-9dc0-6ad88786c19f" providerId="ADAL" clId="{93D479E5-F67F-4B8A-A78F-A0B574A116B6}" dt="2026-02-22T13:29:17.252" v="2161" actId="14100"/>
           <ac:picMkLst>
             <pc:docMk/>
             <pc:sldMk cId="2380309321" sldId="268"/>
@@ -659,7 +554,7 @@
         </pc:picChg>
       </pc:sldChg>
       <pc:sldChg chg="addSp delSp modSp new mod setBg">
-        <pc:chgData name="Margo Bonal" userId="18c9fa0f-b53d-478b-9dc0-6ad88786c19f" providerId="ADAL" clId="{93D479E5-F67F-4B8A-A78F-A0B574A116B6}" dt="2026-02-21T22:02:46.761" v="1753" actId="21"/>
+        <pc:chgData name="Margo Bonal" userId="18c9fa0f-b53d-478b-9dc0-6ad88786c19f" providerId="ADAL" clId="{93D479E5-F67F-4B8A-A78F-A0B574A116B6}" dt="2026-02-22T13:29:45.932" v="2167" actId="1076"/>
         <pc:sldMkLst>
           <pc:docMk/>
           <pc:sldMk cId="884354200" sldId="269"/>
@@ -712,8 +607,8 @@
             <ac:spMk id="16" creationId="{A7009A0A-BEF5-4EAC-AF15-E4F9F002E239}"/>
           </ac:spMkLst>
         </pc:spChg>
-        <pc:picChg chg="add mod">
-          <ac:chgData name="Margo Bonal" userId="18c9fa0f-b53d-478b-9dc0-6ad88786c19f" providerId="ADAL" clId="{93D479E5-F67F-4B8A-A78F-A0B574A116B6}" dt="2026-02-21T21:58:07.647" v="1681" actId="26606"/>
+        <pc:picChg chg="add mod modCrop">
+          <ac:chgData name="Margo Bonal" userId="18c9fa0f-b53d-478b-9dc0-6ad88786c19f" providerId="ADAL" clId="{93D479E5-F67F-4B8A-A78F-A0B574A116B6}" dt="2026-02-22T13:29:45.932" v="2167" actId="1076"/>
           <ac:picMkLst>
             <pc:docMk/>
             <pc:sldMk cId="884354200" sldId="269"/>
@@ -722,7 +617,7 @@
         </pc:picChg>
       </pc:sldChg>
       <pc:sldChg chg="addSp delSp modSp new mod setBg">
-        <pc:chgData name="Margo Bonal" userId="18c9fa0f-b53d-478b-9dc0-6ad88786c19f" providerId="ADAL" clId="{93D479E5-F67F-4B8A-A78F-A0B574A116B6}" dt="2026-02-21T22:02:52.738" v="1754" actId="21"/>
+        <pc:chgData name="Margo Bonal" userId="18c9fa0f-b53d-478b-9dc0-6ad88786c19f" providerId="ADAL" clId="{93D479E5-F67F-4B8A-A78F-A0B574A116B6}" dt="2026-02-22T13:29:07.025" v="2159" actId="14100"/>
         <pc:sldMkLst>
           <pc:docMk/>
           <pc:sldMk cId="3857486133" sldId="270"/>
@@ -776,11 +671,232 @@
           </ac:spMkLst>
         </pc:spChg>
         <pc:picChg chg="add mod modCrop">
-          <ac:chgData name="Margo Bonal" userId="18c9fa0f-b53d-478b-9dc0-6ad88786c19f" providerId="ADAL" clId="{93D479E5-F67F-4B8A-A78F-A0B574A116B6}" dt="2026-02-21T21:59:54.289" v="1711" actId="26606"/>
+          <ac:chgData name="Margo Bonal" userId="18c9fa0f-b53d-478b-9dc0-6ad88786c19f" providerId="ADAL" clId="{93D479E5-F67F-4B8A-A78F-A0B574A116B6}" dt="2026-02-22T13:29:07.025" v="2159" actId="14100"/>
           <ac:picMkLst>
             <pc:docMk/>
             <pc:sldMk cId="3857486133" sldId="270"/>
             <ac:picMk id="5" creationId="{6C01547A-003F-2DA0-1CB8-4E92D18977A2}"/>
+          </ac:picMkLst>
+        </pc:picChg>
+      </pc:sldChg>
+      <pc:sldChg chg="addSp modSp new mod setBg">
+        <pc:chgData name="Margo Bonal" userId="18c9fa0f-b53d-478b-9dc0-6ad88786c19f" providerId="ADAL" clId="{93D479E5-F67F-4B8A-A78F-A0B574A116B6}" dt="2026-02-22T13:31:07.022" v="2184" actId="1076"/>
+        <pc:sldMkLst>
+          <pc:docMk/>
+          <pc:sldMk cId="169300139" sldId="271"/>
+        </pc:sldMkLst>
+        <pc:spChg chg="mod">
+          <ac:chgData name="Margo Bonal" userId="18c9fa0f-b53d-478b-9dc0-6ad88786c19f" providerId="ADAL" clId="{93D479E5-F67F-4B8A-A78F-A0B574A116B6}" dt="2026-02-22T13:11:05.441" v="1915" actId="14100"/>
+          <ac:spMkLst>
+            <pc:docMk/>
+            <pc:sldMk cId="169300139" sldId="271"/>
+            <ac:spMk id="2" creationId="{EA4FDA8B-9365-0E30-6EC1-F948B642620B}"/>
+          </ac:spMkLst>
+        </pc:spChg>
+        <pc:spChg chg="mod">
+          <ac:chgData name="Margo Bonal" userId="18c9fa0f-b53d-478b-9dc0-6ad88786c19f" providerId="ADAL" clId="{93D479E5-F67F-4B8A-A78F-A0B574A116B6}" dt="2026-02-22T13:10:55.764" v="1912" actId="27636"/>
+          <ac:spMkLst>
+            <pc:docMk/>
+            <pc:sldMk cId="169300139" sldId="271"/>
+            <ac:spMk id="3" creationId="{ACEB9891-C788-8944-5568-FC81D66228D0}"/>
+          </ac:spMkLst>
+        </pc:spChg>
+        <pc:spChg chg="add">
+          <ac:chgData name="Margo Bonal" userId="18c9fa0f-b53d-478b-9dc0-6ad88786c19f" providerId="ADAL" clId="{93D479E5-F67F-4B8A-A78F-A0B574A116B6}" dt="2026-02-22T13:09:46.389" v="1789" actId="26606"/>
+          <ac:spMkLst>
+            <pc:docMk/>
+            <pc:sldMk cId="169300139" sldId="271"/>
+            <ac:spMk id="10" creationId="{A4E37431-20F0-4DD6-84A9-ED2B644943A2}"/>
+          </ac:spMkLst>
+        </pc:spChg>
+        <pc:spChg chg="add">
+          <ac:chgData name="Margo Bonal" userId="18c9fa0f-b53d-478b-9dc0-6ad88786c19f" providerId="ADAL" clId="{93D479E5-F67F-4B8A-A78F-A0B574A116B6}" dt="2026-02-22T13:09:46.389" v="1789" actId="26606"/>
+          <ac:spMkLst>
+            <pc:docMk/>
+            <pc:sldMk cId="169300139" sldId="271"/>
+            <ac:spMk id="12" creationId="{0AE98B72-66C6-4AB4-AF0D-BA830DE86393}"/>
+          </ac:spMkLst>
+        </pc:spChg>
+        <pc:spChg chg="add">
+          <ac:chgData name="Margo Bonal" userId="18c9fa0f-b53d-478b-9dc0-6ad88786c19f" providerId="ADAL" clId="{93D479E5-F67F-4B8A-A78F-A0B574A116B6}" dt="2026-02-22T13:09:46.389" v="1789" actId="26606"/>
+          <ac:spMkLst>
+            <pc:docMk/>
+            <pc:sldMk cId="169300139" sldId="271"/>
+            <ac:spMk id="14" creationId="{407EAFC6-733F-403D-BB4D-05A3A28742F1}"/>
+          </ac:spMkLst>
+        </pc:spChg>
+        <pc:spChg chg="add">
+          <ac:chgData name="Margo Bonal" userId="18c9fa0f-b53d-478b-9dc0-6ad88786c19f" providerId="ADAL" clId="{93D479E5-F67F-4B8A-A78F-A0B574A116B6}" dt="2026-02-22T13:09:46.389" v="1789" actId="26606"/>
+          <ac:spMkLst>
+            <pc:docMk/>
+            <pc:sldMk cId="169300139" sldId="271"/>
+            <ac:spMk id="16" creationId="{17A36730-4CB0-4F61-AD11-A44C9765833F}"/>
+          </ac:spMkLst>
+        </pc:spChg>
+        <pc:spChg chg="add">
+          <ac:chgData name="Margo Bonal" userId="18c9fa0f-b53d-478b-9dc0-6ad88786c19f" providerId="ADAL" clId="{93D479E5-F67F-4B8A-A78F-A0B574A116B6}" dt="2026-02-22T13:09:46.389" v="1789" actId="26606"/>
+          <ac:spMkLst>
+            <pc:docMk/>
+            <pc:sldMk cId="169300139" sldId="271"/>
+            <ac:spMk id="18" creationId="{C69C79E1-F916-4929-A4F3-DE763D4BFA57}"/>
+          </ac:spMkLst>
+        </pc:spChg>
+        <pc:spChg chg="add">
+          <ac:chgData name="Margo Bonal" userId="18c9fa0f-b53d-478b-9dc0-6ad88786c19f" providerId="ADAL" clId="{93D479E5-F67F-4B8A-A78F-A0B574A116B6}" dt="2026-02-22T13:09:46.389" v="1789" actId="26606"/>
+          <ac:spMkLst>
+            <pc:docMk/>
+            <pc:sldMk cId="169300139" sldId="271"/>
+            <ac:spMk id="20" creationId="{767334AB-16BD-4EC7-8C6B-4B5171600933}"/>
+          </ac:spMkLst>
+        </pc:spChg>
+        <pc:picChg chg="add mod modCrop">
+          <ac:chgData name="Margo Bonal" userId="18c9fa0f-b53d-478b-9dc0-6ad88786c19f" providerId="ADAL" clId="{93D479E5-F67F-4B8A-A78F-A0B574A116B6}" dt="2026-02-22T13:31:07.022" v="2184" actId="1076"/>
+          <ac:picMkLst>
+            <pc:docMk/>
+            <pc:sldMk cId="169300139" sldId="271"/>
+            <ac:picMk id="5" creationId="{04D50DDF-58B1-5FE3-AFCD-CFFF4E299495}"/>
+          </ac:picMkLst>
+        </pc:picChg>
+      </pc:sldChg>
+      <pc:sldChg chg="addSp delSp modSp new mod setBg">
+        <pc:chgData name="Margo Bonal" userId="18c9fa0f-b53d-478b-9dc0-6ad88786c19f" providerId="ADAL" clId="{93D479E5-F67F-4B8A-A78F-A0B574A116B6}" dt="2026-02-22T13:30:13.643" v="2172" actId="14100"/>
+        <pc:sldMkLst>
+          <pc:docMk/>
+          <pc:sldMk cId="1553250187" sldId="272"/>
+        </pc:sldMkLst>
+        <pc:spChg chg="mod">
+          <ac:chgData name="Margo Bonal" userId="18c9fa0f-b53d-478b-9dc0-6ad88786c19f" providerId="ADAL" clId="{93D479E5-F67F-4B8A-A78F-A0B574A116B6}" dt="2026-02-22T13:14:13.018" v="2105" actId="26606"/>
+          <ac:spMkLst>
+            <pc:docMk/>
+            <pc:sldMk cId="1553250187" sldId="272"/>
+            <ac:spMk id="2" creationId="{BCFB2890-40BC-6F61-0FD1-79775DD8B802}"/>
+          </ac:spMkLst>
+        </pc:spChg>
+        <pc:spChg chg="add del mod">
+          <ac:chgData name="Margo Bonal" userId="18c9fa0f-b53d-478b-9dc0-6ad88786c19f" providerId="ADAL" clId="{93D479E5-F67F-4B8A-A78F-A0B574A116B6}" dt="2026-02-22T13:14:42.029" v="2133" actId="20577"/>
+          <ac:spMkLst>
+            <pc:docMk/>
+            <pc:sldMk cId="1553250187" sldId="272"/>
+            <ac:spMk id="3" creationId="{73107D4C-9470-CFCD-B4FE-5152142A64F6}"/>
+          </ac:spMkLst>
+        </pc:spChg>
+        <pc:spChg chg="add del">
+          <ac:chgData name="Margo Bonal" userId="18c9fa0f-b53d-478b-9dc0-6ad88786c19f" providerId="ADAL" clId="{93D479E5-F67F-4B8A-A78F-A0B574A116B6}" dt="2026-02-22T13:14:13.007" v="2104" actId="26606"/>
+          <ac:spMkLst>
+            <pc:docMk/>
+            <pc:sldMk cId="1553250187" sldId="272"/>
+            <ac:spMk id="10" creationId="{7B1AB9FE-36F5-4FD1-9850-DB5C5AD4828F}"/>
+          </ac:spMkLst>
+        </pc:spChg>
+        <pc:spChg chg="add del">
+          <ac:chgData name="Margo Bonal" userId="18c9fa0f-b53d-478b-9dc0-6ad88786c19f" providerId="ADAL" clId="{93D479E5-F67F-4B8A-A78F-A0B574A116B6}" dt="2026-02-22T13:14:13.007" v="2104" actId="26606"/>
+          <ac:spMkLst>
+            <pc:docMk/>
+            <pc:sldMk cId="1553250187" sldId="272"/>
+            <ac:spMk id="12" creationId="{F489C2E0-4895-4B72-85EA-7EE9FAFFDC7E}"/>
+          </ac:spMkLst>
+        </pc:spChg>
+        <pc:spChg chg="add del">
+          <ac:chgData name="Margo Bonal" userId="18c9fa0f-b53d-478b-9dc0-6ad88786c19f" providerId="ADAL" clId="{93D479E5-F67F-4B8A-A78F-A0B574A116B6}" dt="2026-02-22T13:14:18.611" v="2107" actId="26606"/>
+          <ac:spMkLst>
+            <pc:docMk/>
+            <pc:sldMk cId="1553250187" sldId="272"/>
+            <ac:spMk id="14" creationId="{84A8DE83-DE75-4B41-9DB4-A7EC0B0DEC0B}"/>
+          </ac:spMkLst>
+        </pc:spChg>
+        <pc:spChg chg="add del">
+          <ac:chgData name="Margo Bonal" userId="18c9fa0f-b53d-478b-9dc0-6ad88786c19f" providerId="ADAL" clId="{93D479E5-F67F-4B8A-A78F-A0B574A116B6}" dt="2026-02-22T13:14:18.611" v="2107" actId="26606"/>
+          <ac:spMkLst>
+            <pc:docMk/>
+            <pc:sldMk cId="1553250187" sldId="272"/>
+            <ac:spMk id="15" creationId="{A8384FB5-9ADC-4DDC-881B-597D56F5B15D}"/>
+          </ac:spMkLst>
+        </pc:spChg>
+        <pc:spChg chg="add del">
+          <ac:chgData name="Margo Bonal" userId="18c9fa0f-b53d-478b-9dc0-6ad88786c19f" providerId="ADAL" clId="{93D479E5-F67F-4B8A-A78F-A0B574A116B6}" dt="2026-02-22T13:14:18.611" v="2107" actId="26606"/>
+          <ac:spMkLst>
+            <pc:docMk/>
+            <pc:sldMk cId="1553250187" sldId="272"/>
+            <ac:spMk id="16" creationId="{A7009A0A-BEF5-4EAC-AF15-E4F9F002E239}"/>
+          </ac:spMkLst>
+        </pc:spChg>
+        <pc:spChg chg="add del">
+          <ac:chgData name="Margo Bonal" userId="18c9fa0f-b53d-478b-9dc0-6ad88786c19f" providerId="ADAL" clId="{93D479E5-F67F-4B8A-A78F-A0B574A116B6}" dt="2026-02-22T13:14:18.611" v="2107" actId="26606"/>
+          <ac:spMkLst>
+            <pc:docMk/>
+            <pc:sldMk cId="1553250187" sldId="272"/>
+            <ac:spMk id="17" creationId="{1199E1B1-A8C0-4FE8-A5A8-1CB41D69F857}"/>
+          </ac:spMkLst>
+        </pc:spChg>
+        <pc:spChg chg="add">
+          <ac:chgData name="Margo Bonal" userId="18c9fa0f-b53d-478b-9dc0-6ad88786c19f" providerId="ADAL" clId="{93D479E5-F67F-4B8A-A78F-A0B574A116B6}" dt="2026-02-22T13:14:18.611" v="2107" actId="26606"/>
+          <ac:spMkLst>
+            <pc:docMk/>
+            <pc:sldMk cId="1553250187" sldId="272"/>
+            <ac:spMk id="22" creationId="{A8384FB5-9ADC-4DDC-881B-597D56F5B15D}"/>
+          </ac:spMkLst>
+        </pc:spChg>
+        <pc:spChg chg="add">
+          <ac:chgData name="Margo Bonal" userId="18c9fa0f-b53d-478b-9dc0-6ad88786c19f" providerId="ADAL" clId="{93D479E5-F67F-4B8A-A78F-A0B574A116B6}" dt="2026-02-22T13:14:18.611" v="2107" actId="26606"/>
+          <ac:spMkLst>
+            <pc:docMk/>
+            <pc:sldMk cId="1553250187" sldId="272"/>
+            <ac:spMk id="24" creationId="{1199E1B1-A8C0-4FE8-A5A8-1CB41D69F857}"/>
+          </ac:spMkLst>
+        </pc:spChg>
+        <pc:spChg chg="add">
+          <ac:chgData name="Margo Bonal" userId="18c9fa0f-b53d-478b-9dc0-6ad88786c19f" providerId="ADAL" clId="{93D479E5-F67F-4B8A-A78F-A0B574A116B6}" dt="2026-02-22T13:14:18.611" v="2107" actId="26606"/>
+          <ac:spMkLst>
+            <pc:docMk/>
+            <pc:sldMk cId="1553250187" sldId="272"/>
+            <ac:spMk id="26" creationId="{84A8DE83-DE75-4B41-9DB4-A7EC0B0DEC0B}"/>
+          </ac:spMkLst>
+        </pc:spChg>
+        <pc:spChg chg="add">
+          <ac:chgData name="Margo Bonal" userId="18c9fa0f-b53d-478b-9dc0-6ad88786c19f" providerId="ADAL" clId="{93D479E5-F67F-4B8A-A78F-A0B574A116B6}" dt="2026-02-22T13:14:18.611" v="2107" actId="26606"/>
+          <ac:spMkLst>
+            <pc:docMk/>
+            <pc:sldMk cId="1553250187" sldId="272"/>
+            <ac:spMk id="28" creationId="{A7009A0A-BEF5-4EAC-AF15-E4F9F002E239}"/>
+          </ac:spMkLst>
+        </pc:spChg>
+        <pc:picChg chg="add mod ord">
+          <ac:chgData name="Margo Bonal" userId="18c9fa0f-b53d-478b-9dc0-6ad88786c19f" providerId="ADAL" clId="{93D479E5-F67F-4B8A-A78F-A0B574A116B6}" dt="2026-02-22T13:30:13.643" v="2172" actId="14100"/>
+          <ac:picMkLst>
+            <pc:docMk/>
+            <pc:sldMk cId="1553250187" sldId="272"/>
+            <ac:picMk id="5" creationId="{6C3C1071-9787-C6F9-4218-E3342B5ED70F}"/>
+          </ac:picMkLst>
+        </pc:picChg>
+      </pc:sldChg>
+      <pc:sldChg chg="addSp delSp modSp add mod">
+        <pc:chgData name="Margo Bonal" userId="18c9fa0f-b53d-478b-9dc0-6ad88786c19f" providerId="ADAL" clId="{93D479E5-F67F-4B8A-A78F-A0B574A116B6}" dt="2026-02-22T13:15:45.664" v="2152" actId="1076"/>
+        <pc:sldMkLst>
+          <pc:docMk/>
+          <pc:sldMk cId="3338242679" sldId="273"/>
+        </pc:sldMkLst>
+        <pc:spChg chg="mod">
+          <ac:chgData name="Margo Bonal" userId="18c9fa0f-b53d-478b-9dc0-6ad88786c19f" providerId="ADAL" clId="{93D479E5-F67F-4B8A-A78F-A0B574A116B6}" dt="2026-02-22T13:14:57.545" v="2144" actId="20577"/>
+          <ac:spMkLst>
+            <pc:docMk/>
+            <pc:sldMk cId="3338242679" sldId="273"/>
+            <ac:spMk id="3" creationId="{C12646E0-2765-987C-E33B-C70E4F4125BD}"/>
+          </ac:spMkLst>
+        </pc:spChg>
+        <pc:picChg chg="del">
+          <ac:chgData name="Margo Bonal" userId="18c9fa0f-b53d-478b-9dc0-6ad88786c19f" providerId="ADAL" clId="{93D479E5-F67F-4B8A-A78F-A0B574A116B6}" dt="2026-02-22T13:15:00.144" v="2145" actId="478"/>
+          <ac:picMkLst>
+            <pc:docMk/>
+            <pc:sldMk cId="3338242679" sldId="273"/>
+            <ac:picMk id="5" creationId="{56CEC5B5-D6FC-EE99-6642-5E0795E4EC1F}"/>
+          </ac:picMkLst>
+        </pc:picChg>
+        <pc:picChg chg="add mod">
+          <ac:chgData name="Margo Bonal" userId="18c9fa0f-b53d-478b-9dc0-6ad88786c19f" providerId="ADAL" clId="{93D479E5-F67F-4B8A-A78F-A0B574A116B6}" dt="2026-02-22T13:15:45.664" v="2152" actId="1076"/>
+          <ac:picMkLst>
+            <pc:docMk/>
+            <pc:sldMk cId="3338242679" sldId="273"/>
+            <ac:picMk id="6" creationId="{81F3D153-CB3E-735A-D107-97D5A649C721}"/>
           </ac:picMkLst>
         </pc:picChg>
       </pc:sldChg>
@@ -2780,7 +2896,10 @@
         <a:bodyPr/>
         <a:lstStyle/>
         <a:p>
-          <a:endParaRPr lang="en-US" dirty="0"/>
+          <a:r>
+            <a:rPr lang="en-US" dirty="0"/>
+            <a:t>Implement Login required, can’t reroute to the dashboard manually </a:t>
+          </a:r>
         </a:p>
       </dgm:t>
     </dgm:pt>
@@ -2813,7 +2932,10 @@
         <a:bodyPr/>
         <a:lstStyle/>
         <a:p>
-          <a:endParaRPr lang="en-US" dirty="0"/>
+          <a:r>
+            <a:rPr lang="en-US" dirty="0"/>
+            <a:t>Initial beta testing for first impressions</a:t>
+          </a:r>
         </a:p>
       </dgm:t>
     </dgm:pt>
@@ -2846,7 +2968,10 @@
         <a:bodyPr/>
         <a:lstStyle/>
         <a:p>
-          <a:endParaRPr lang="en-US" dirty="0"/>
+          <a:r>
+            <a:rPr lang="en-US" dirty="0"/>
+            <a:t>Continue Challenges and Teams Development</a:t>
+          </a:r>
         </a:p>
       </dgm:t>
     </dgm:pt>
@@ -3424,12 +3549,12 @@
         <a:fontRef idx="minor"/>
       </dsp:style>
       <dsp:txBody>
-        <a:bodyPr spcFirstLastPara="0" vert="horz" wrap="square" lIns="247650" tIns="247650" rIns="247650" bIns="247650" numCol="1" spcCol="1270" anchor="ctr" anchorCtr="0">
+        <a:bodyPr spcFirstLastPara="0" vert="horz" wrap="square" lIns="87630" tIns="87630" rIns="87630" bIns="87630" numCol="1" spcCol="1270" anchor="ctr" anchorCtr="0">
           <a:noAutofit/>
         </a:bodyPr>
         <a:lstStyle/>
         <a:p>
-          <a:pPr marL="0" lvl="0" indent="0" algn="ctr" defTabSz="2889250">
+          <a:pPr marL="0" lvl="0" indent="0" algn="ctr" defTabSz="1022350">
             <a:lnSpc>
               <a:spcPct val="90000"/>
             </a:lnSpc>
@@ -3441,7 +3566,10 @@
             </a:spcAft>
             <a:buNone/>
           </a:pPr>
-          <a:endParaRPr lang="en-US" sz="6500" kern="1200" dirty="0"/>
+          <a:r>
+            <a:rPr lang="en-US" sz="2300" kern="1200" dirty="0"/>
+            <a:t>Implement Login required, can’t reroute to the dashboard manually </a:t>
+          </a:r>
         </a:p>
       </dsp:txBody>
       <dsp:txXfrm>
@@ -3552,12 +3680,12 @@
         <a:fontRef idx="minor"/>
       </dsp:style>
       <dsp:txBody>
-        <a:bodyPr spcFirstLastPara="0" vert="horz" wrap="square" lIns="247650" tIns="247650" rIns="247650" bIns="247650" numCol="1" spcCol="1270" anchor="ctr" anchorCtr="0">
+        <a:bodyPr spcFirstLastPara="0" vert="horz" wrap="square" lIns="87630" tIns="87630" rIns="87630" bIns="87630" numCol="1" spcCol="1270" anchor="ctr" anchorCtr="0">
           <a:noAutofit/>
         </a:bodyPr>
         <a:lstStyle/>
         <a:p>
-          <a:pPr marL="0" lvl="0" indent="0" algn="ctr" defTabSz="2889250">
+          <a:pPr marL="0" lvl="0" indent="0" algn="ctr" defTabSz="1022350">
             <a:lnSpc>
               <a:spcPct val="90000"/>
             </a:lnSpc>
@@ -3569,7 +3697,10 @@
             </a:spcAft>
             <a:buNone/>
           </a:pPr>
-          <a:endParaRPr lang="en-US" sz="6500" kern="1200" dirty="0"/>
+          <a:r>
+            <a:rPr lang="en-US" sz="2300" kern="1200" dirty="0"/>
+            <a:t>Initial beta testing for first impressions</a:t>
+          </a:r>
         </a:p>
       </dsp:txBody>
       <dsp:txXfrm>
@@ -3680,12 +3811,12 @@
         <a:fontRef idx="minor"/>
       </dsp:style>
       <dsp:txBody>
-        <a:bodyPr spcFirstLastPara="0" vert="horz" wrap="square" lIns="247650" tIns="247650" rIns="247650" bIns="247650" numCol="1" spcCol="1270" anchor="ctr" anchorCtr="0">
+        <a:bodyPr spcFirstLastPara="0" vert="horz" wrap="square" lIns="87630" tIns="87630" rIns="87630" bIns="87630" numCol="1" spcCol="1270" anchor="ctr" anchorCtr="0">
           <a:noAutofit/>
         </a:bodyPr>
         <a:lstStyle/>
         <a:p>
-          <a:pPr marL="0" lvl="0" indent="0" algn="ctr" defTabSz="2889250">
+          <a:pPr marL="0" lvl="0" indent="0" algn="ctr" defTabSz="1022350">
             <a:lnSpc>
               <a:spcPct val="90000"/>
             </a:lnSpc>
@@ -3697,7 +3828,10 @@
             </a:spcAft>
             <a:buNone/>
           </a:pPr>
-          <a:endParaRPr lang="en-US" sz="6500" kern="1200" dirty="0"/>
+          <a:r>
+            <a:rPr lang="en-US" sz="2300" kern="1200" dirty="0"/>
+            <a:t>Continue Challenges and Teams Development</a:t>
+          </a:r>
         </a:p>
       </dsp:txBody>
       <dsp:txXfrm>
@@ -6555,6 +6689,439 @@
 </dgm:styleDef>
 </file>
 
+<file path=ppt/notesMasters/notesMaster1.xml><?xml version="1.0" encoding="utf-8"?>
+<p:notesMaster xmlns:a="http://schemas.openxmlformats.org/drawingml/2006/main" xmlns:r="http://schemas.openxmlformats.org/officeDocument/2006/relationships" xmlns:p="http://schemas.openxmlformats.org/presentationml/2006/main">
+  <p:cSld>
+    <p:bg>
+      <p:bgRef idx="1001">
+        <a:schemeClr val="bg1"/>
+      </p:bgRef>
+    </p:bg>
+    <p:spTree>
+      <p:nvGrpSpPr>
+        <p:cNvPr id="1" name=""/>
+        <p:cNvGrpSpPr/>
+        <p:nvPr/>
+      </p:nvGrpSpPr>
+      <p:grpSpPr>
+        <a:xfrm>
+          <a:off x="0" y="0"/>
+          <a:ext cx="0" cy="0"/>
+          <a:chOff x="0" y="0"/>
+          <a:chExt cx="0" cy="0"/>
+        </a:xfrm>
+      </p:grpSpPr>
+      <p:sp>
+        <p:nvSpPr>
+          <p:cNvPr id="2" name="Header Placeholder 1"/>
+          <p:cNvSpPr>
+            <a:spLocks noGrp="1"/>
+          </p:cNvSpPr>
+          <p:nvPr>
+            <p:ph type="hdr" sz="quarter"/>
+          </p:nvPr>
+        </p:nvSpPr>
+        <p:spPr>
+          <a:xfrm>
+            <a:off x="0" y="0"/>
+            <a:ext cx="2971800" cy="458788"/>
+          </a:xfrm>
+          <a:prstGeom prst="rect">
+            <a:avLst/>
+          </a:prstGeom>
+        </p:spPr>
+        <p:txBody>
+          <a:bodyPr vert="horz" lIns="91440" tIns="45720" rIns="91440" bIns="45720" rtlCol="0"/>
+          <a:lstStyle>
+            <a:lvl1pPr algn="l">
+              <a:defRPr sz="1200"/>
+            </a:lvl1pPr>
+          </a:lstStyle>
+          <a:p>
+            <a:endParaRPr lang="en-US"/>
+          </a:p>
+        </p:txBody>
+      </p:sp>
+      <p:sp>
+        <p:nvSpPr>
+          <p:cNvPr id="3" name="Date Placeholder 2"/>
+          <p:cNvSpPr>
+            <a:spLocks noGrp="1"/>
+          </p:cNvSpPr>
+          <p:nvPr>
+            <p:ph type="dt" idx="1"/>
+          </p:nvPr>
+        </p:nvSpPr>
+        <p:spPr>
+          <a:xfrm>
+            <a:off x="3884613" y="0"/>
+            <a:ext cx="2971800" cy="458788"/>
+          </a:xfrm>
+          <a:prstGeom prst="rect">
+            <a:avLst/>
+          </a:prstGeom>
+        </p:spPr>
+        <p:txBody>
+          <a:bodyPr vert="horz" lIns="91440" tIns="45720" rIns="91440" bIns="45720" rtlCol="0"/>
+          <a:lstStyle>
+            <a:lvl1pPr algn="r">
+              <a:defRPr sz="1200"/>
+            </a:lvl1pPr>
+          </a:lstStyle>
+          <a:p>
+            <a:fld id="{B1F2A6E6-BB86-4722-837C-048EA2408876}" type="datetimeFigureOut">
+              <a:rPr lang="en-US" smtClean="0"/>
+              <a:t>2/22/2026</a:t>
+            </a:fld>
+            <a:endParaRPr lang="en-US"/>
+          </a:p>
+        </p:txBody>
+      </p:sp>
+      <p:sp>
+        <p:nvSpPr>
+          <p:cNvPr id="4" name="Slide Image Placeholder 3"/>
+          <p:cNvSpPr>
+            <a:spLocks noGrp="1" noRot="1" noChangeAspect="1"/>
+          </p:cNvSpPr>
+          <p:nvPr>
+            <p:ph type="sldImg" idx="2"/>
+          </p:nvPr>
+        </p:nvSpPr>
+        <p:spPr>
+          <a:xfrm>
+            <a:off x="685800" y="1143000"/>
+            <a:ext cx="5486400" cy="3086100"/>
+          </a:xfrm>
+          <a:prstGeom prst="rect">
+            <a:avLst/>
+          </a:prstGeom>
+          <a:noFill/>
+          <a:ln w="12700">
+            <a:solidFill>
+              <a:prstClr val="black"/>
+            </a:solidFill>
+          </a:ln>
+        </p:spPr>
+        <p:txBody>
+          <a:bodyPr vert="horz" lIns="91440" tIns="45720" rIns="91440" bIns="45720" rtlCol="0" anchor="ctr"/>
+          <a:lstStyle/>
+          <a:p>
+            <a:endParaRPr lang="en-US"/>
+          </a:p>
+        </p:txBody>
+      </p:sp>
+      <p:sp>
+        <p:nvSpPr>
+          <p:cNvPr id="5" name="Notes Placeholder 4"/>
+          <p:cNvSpPr>
+            <a:spLocks noGrp="1"/>
+          </p:cNvSpPr>
+          <p:nvPr>
+            <p:ph type="body" sz="quarter" idx="3"/>
+          </p:nvPr>
+        </p:nvSpPr>
+        <p:spPr>
+          <a:xfrm>
+            <a:off x="685800" y="4400550"/>
+            <a:ext cx="5486400" cy="3600450"/>
+          </a:xfrm>
+          <a:prstGeom prst="rect">
+            <a:avLst/>
+          </a:prstGeom>
+        </p:spPr>
+        <p:txBody>
+          <a:bodyPr vert="horz" lIns="91440" tIns="45720" rIns="91440" bIns="45720" rtlCol="0"/>
+          <a:lstStyle/>
+          <a:p>
+            <a:pPr lvl="0"/>
+            <a:r>
+              <a:rPr lang="en-US"/>
+              <a:t>Click to edit Master text styles</a:t>
+            </a:r>
+          </a:p>
+          <a:p>
+            <a:pPr lvl="1"/>
+            <a:r>
+              <a:rPr lang="en-US"/>
+              <a:t>Second level</a:t>
+            </a:r>
+          </a:p>
+          <a:p>
+            <a:pPr lvl="2"/>
+            <a:r>
+              <a:rPr lang="en-US"/>
+              <a:t>Third level</a:t>
+            </a:r>
+          </a:p>
+          <a:p>
+            <a:pPr lvl="3"/>
+            <a:r>
+              <a:rPr lang="en-US"/>
+              <a:t>Fourth level</a:t>
+            </a:r>
+          </a:p>
+          <a:p>
+            <a:pPr lvl="4"/>
+            <a:r>
+              <a:rPr lang="en-US"/>
+              <a:t>Fifth level</a:t>
+            </a:r>
+          </a:p>
+        </p:txBody>
+      </p:sp>
+      <p:sp>
+        <p:nvSpPr>
+          <p:cNvPr id="6" name="Footer Placeholder 5"/>
+          <p:cNvSpPr>
+            <a:spLocks noGrp="1"/>
+          </p:cNvSpPr>
+          <p:nvPr>
+            <p:ph type="ftr" sz="quarter" idx="4"/>
+          </p:nvPr>
+        </p:nvSpPr>
+        <p:spPr>
+          <a:xfrm>
+            <a:off x="0" y="8685213"/>
+            <a:ext cx="2971800" cy="458787"/>
+          </a:xfrm>
+          <a:prstGeom prst="rect">
+            <a:avLst/>
+          </a:prstGeom>
+        </p:spPr>
+        <p:txBody>
+          <a:bodyPr vert="horz" lIns="91440" tIns="45720" rIns="91440" bIns="45720" rtlCol="0" anchor="b"/>
+          <a:lstStyle>
+            <a:lvl1pPr algn="l">
+              <a:defRPr sz="1200"/>
+            </a:lvl1pPr>
+          </a:lstStyle>
+          <a:p>
+            <a:endParaRPr lang="en-US"/>
+          </a:p>
+        </p:txBody>
+      </p:sp>
+      <p:sp>
+        <p:nvSpPr>
+          <p:cNvPr id="7" name="Slide Number Placeholder 6"/>
+          <p:cNvSpPr>
+            <a:spLocks noGrp="1"/>
+          </p:cNvSpPr>
+          <p:nvPr>
+            <p:ph type="sldNum" sz="quarter" idx="5"/>
+          </p:nvPr>
+        </p:nvSpPr>
+        <p:spPr>
+          <a:xfrm>
+            <a:off x="3884613" y="8685213"/>
+            <a:ext cx="2971800" cy="458787"/>
+          </a:xfrm>
+          <a:prstGeom prst="rect">
+            <a:avLst/>
+          </a:prstGeom>
+        </p:spPr>
+        <p:txBody>
+          <a:bodyPr vert="horz" lIns="91440" tIns="45720" rIns="91440" bIns="45720" rtlCol="0" anchor="b"/>
+          <a:lstStyle>
+            <a:lvl1pPr algn="r">
+              <a:defRPr sz="1200"/>
+            </a:lvl1pPr>
+          </a:lstStyle>
+          <a:p>
+            <a:fld id="{DBA3B6B7-4283-4814-95B1-8D2476E93965}" type="slidenum">
+              <a:rPr lang="en-US" smtClean="0"/>
+              <a:t>‹#›</a:t>
+            </a:fld>
+            <a:endParaRPr lang="en-US"/>
+          </a:p>
+        </p:txBody>
+      </p:sp>
+    </p:spTree>
+    <p:extLst>
+      <p:ext uri="{BB962C8B-B14F-4D97-AF65-F5344CB8AC3E}">
+        <p14:creationId xmlns:p14="http://schemas.microsoft.com/office/powerpoint/2010/main" val="538583710"/>
+      </p:ext>
+    </p:extLst>
+  </p:cSld>
+  <p:clrMap bg1="lt1" tx1="dk1" bg2="lt2" tx2="dk2" accent1="accent1" accent2="accent2" accent3="accent3" accent4="accent4" accent5="accent5" accent6="accent6" hlink="hlink" folHlink="folHlink"/>
+  <p:notesStyle>
+    <a:lvl1pPr marL="0" algn="l" defTabSz="914400" rtl="0" eaLnBrk="1" latinLnBrk="0" hangingPunct="1">
+      <a:defRPr sz="1200" kern="1200">
+        <a:solidFill>
+          <a:schemeClr val="tx1"/>
+        </a:solidFill>
+        <a:latin typeface="+mn-lt"/>
+        <a:ea typeface="+mn-ea"/>
+        <a:cs typeface="+mn-cs"/>
+      </a:defRPr>
+    </a:lvl1pPr>
+    <a:lvl2pPr marL="457200" algn="l" defTabSz="914400" rtl="0" eaLnBrk="1" latinLnBrk="0" hangingPunct="1">
+      <a:defRPr sz="1200" kern="1200">
+        <a:solidFill>
+          <a:schemeClr val="tx1"/>
+        </a:solidFill>
+        <a:latin typeface="+mn-lt"/>
+        <a:ea typeface="+mn-ea"/>
+        <a:cs typeface="+mn-cs"/>
+      </a:defRPr>
+    </a:lvl2pPr>
+    <a:lvl3pPr marL="914400" algn="l" defTabSz="914400" rtl="0" eaLnBrk="1" latinLnBrk="0" hangingPunct="1">
+      <a:defRPr sz="1200" kern="1200">
+        <a:solidFill>
+          <a:schemeClr val="tx1"/>
+        </a:solidFill>
+        <a:latin typeface="+mn-lt"/>
+        <a:ea typeface="+mn-ea"/>
+        <a:cs typeface="+mn-cs"/>
+      </a:defRPr>
+    </a:lvl3pPr>
+    <a:lvl4pPr marL="1371600" algn="l" defTabSz="914400" rtl="0" eaLnBrk="1" latinLnBrk="0" hangingPunct="1">
+      <a:defRPr sz="1200" kern="1200">
+        <a:solidFill>
+          <a:schemeClr val="tx1"/>
+        </a:solidFill>
+        <a:latin typeface="+mn-lt"/>
+        <a:ea typeface="+mn-ea"/>
+        <a:cs typeface="+mn-cs"/>
+      </a:defRPr>
+    </a:lvl4pPr>
+    <a:lvl5pPr marL="1828800" algn="l" defTabSz="914400" rtl="0" eaLnBrk="1" latinLnBrk="0" hangingPunct="1">
+      <a:defRPr sz="1200" kern="1200">
+        <a:solidFill>
+          <a:schemeClr val="tx1"/>
+        </a:solidFill>
+        <a:latin typeface="+mn-lt"/>
+        <a:ea typeface="+mn-ea"/>
+        <a:cs typeface="+mn-cs"/>
+      </a:defRPr>
+    </a:lvl5pPr>
+    <a:lvl6pPr marL="2286000" algn="l" defTabSz="914400" rtl="0" eaLnBrk="1" latinLnBrk="0" hangingPunct="1">
+      <a:defRPr sz="1200" kern="1200">
+        <a:solidFill>
+          <a:schemeClr val="tx1"/>
+        </a:solidFill>
+        <a:latin typeface="+mn-lt"/>
+        <a:ea typeface="+mn-ea"/>
+        <a:cs typeface="+mn-cs"/>
+      </a:defRPr>
+    </a:lvl6pPr>
+    <a:lvl7pPr marL="2743200" algn="l" defTabSz="914400" rtl="0" eaLnBrk="1" latinLnBrk="0" hangingPunct="1">
+      <a:defRPr sz="1200" kern="1200">
+        <a:solidFill>
+          <a:schemeClr val="tx1"/>
+        </a:solidFill>
+        <a:latin typeface="+mn-lt"/>
+        <a:ea typeface="+mn-ea"/>
+        <a:cs typeface="+mn-cs"/>
+      </a:defRPr>
+    </a:lvl7pPr>
+    <a:lvl8pPr marL="3200400" algn="l" defTabSz="914400" rtl="0" eaLnBrk="1" latinLnBrk="0" hangingPunct="1">
+      <a:defRPr sz="1200" kern="1200">
+        <a:solidFill>
+          <a:schemeClr val="tx1"/>
+        </a:solidFill>
+        <a:latin typeface="+mn-lt"/>
+        <a:ea typeface="+mn-ea"/>
+        <a:cs typeface="+mn-cs"/>
+      </a:defRPr>
+    </a:lvl8pPr>
+    <a:lvl9pPr marL="3657600" algn="l" defTabSz="914400" rtl="0" eaLnBrk="1" latinLnBrk="0" hangingPunct="1">
+      <a:defRPr sz="1200" kern="1200">
+        <a:solidFill>
+          <a:schemeClr val="tx1"/>
+        </a:solidFill>
+        <a:latin typeface="+mn-lt"/>
+        <a:ea typeface="+mn-ea"/>
+        <a:cs typeface="+mn-cs"/>
+      </a:defRPr>
+    </a:lvl9pPr>
+  </p:notesStyle>
+</p:notesMaster>
+</file>
+
+<file path=ppt/notesSlides/notesSlide1.xml><?xml version="1.0" encoding="utf-8"?>
+<p:notes xmlns:a="http://schemas.openxmlformats.org/drawingml/2006/main" xmlns:r="http://schemas.openxmlformats.org/officeDocument/2006/relationships" xmlns:p="http://schemas.openxmlformats.org/presentationml/2006/main">
+  <p:cSld>
+    <p:spTree>
+      <p:nvGrpSpPr>
+        <p:cNvPr id="1" name=""/>
+        <p:cNvGrpSpPr/>
+        <p:nvPr/>
+      </p:nvGrpSpPr>
+      <p:grpSpPr>
+        <a:xfrm>
+          <a:off x="0" y="0"/>
+          <a:ext cx="0" cy="0"/>
+          <a:chOff x="0" y="0"/>
+          <a:chExt cx="0" cy="0"/>
+        </a:xfrm>
+      </p:grpSpPr>
+      <p:sp>
+        <p:nvSpPr>
+          <p:cNvPr id="2" name="Slide Image Placeholder 1"/>
+          <p:cNvSpPr>
+            <a:spLocks noGrp="1" noRot="1" noChangeAspect="1"/>
+          </p:cNvSpPr>
+          <p:nvPr>
+            <p:ph type="sldImg"/>
+          </p:nvPr>
+        </p:nvSpPr>
+        <p:spPr/>
+      </p:sp>
+      <p:sp>
+        <p:nvSpPr>
+          <p:cNvPr id="3" name="Notes Placeholder 2"/>
+          <p:cNvSpPr>
+            <a:spLocks noGrp="1"/>
+          </p:cNvSpPr>
+          <p:nvPr>
+            <p:ph type="body" idx="1"/>
+          </p:nvPr>
+        </p:nvSpPr>
+        <p:spPr/>
+        <p:txBody>
+          <a:bodyPr/>
+          <a:lstStyle/>
+          <a:p>
+            <a:endParaRPr lang="en-US" dirty="0"/>
+          </a:p>
+        </p:txBody>
+      </p:sp>
+      <p:sp>
+        <p:nvSpPr>
+          <p:cNvPr id="4" name="Slide Number Placeholder 3"/>
+          <p:cNvSpPr>
+            <a:spLocks noGrp="1"/>
+          </p:cNvSpPr>
+          <p:nvPr>
+            <p:ph type="sldNum" sz="quarter" idx="5"/>
+          </p:nvPr>
+        </p:nvSpPr>
+        <p:spPr/>
+        <p:txBody>
+          <a:bodyPr/>
+          <a:lstStyle/>
+          <a:p>
+            <a:fld id="{DBA3B6B7-4283-4814-95B1-8D2476E93965}" type="slidenum">
+              <a:rPr lang="en-US" smtClean="0"/>
+              <a:t>9</a:t>
+            </a:fld>
+            <a:endParaRPr lang="en-US"/>
+          </a:p>
+        </p:txBody>
+      </p:sp>
+    </p:spTree>
+    <p:extLst>
+      <p:ext uri="{BB962C8B-B14F-4D97-AF65-F5344CB8AC3E}">
+        <p14:creationId xmlns:p14="http://schemas.microsoft.com/office/powerpoint/2010/main" val="2757532756"/>
+      </p:ext>
+    </p:extLst>
+  </p:cSld>
+  <p:clrMapOvr>
+    <a:masterClrMapping/>
+  </p:clrMapOvr>
+</p:notes>
+</file>
+
 <file path=ppt/slideLayouts/slideLayout1.xml><?xml version="1.0" encoding="utf-8"?>
 <p:sldLayout xmlns:a="http://schemas.openxmlformats.org/drawingml/2006/main" xmlns:r="http://schemas.openxmlformats.org/officeDocument/2006/relationships" xmlns:p="http://schemas.openxmlformats.org/presentationml/2006/main" type="title" preserve="1">
   <p:cSld name="Title Slide">
@@ -6702,7 +7269,7 @@
           <a:p>
             <a:fld id="{C882E6FB-EB88-4936-BED9-9E37159958CA}" type="datetimeFigureOut">
               <a:rPr lang="en-US" smtClean="0"/>
-              <a:t>2/21/2026</a:t>
+              <a:t>2/22/2026</a:t>
             </a:fld>
             <a:endParaRPr lang="en-US"/>
           </a:p>
@@ -6900,7 +7467,7 @@
           <a:p>
             <a:fld id="{C882E6FB-EB88-4936-BED9-9E37159958CA}" type="datetimeFigureOut">
               <a:rPr lang="en-US" smtClean="0"/>
-              <a:t>2/21/2026</a:t>
+              <a:t>2/22/2026</a:t>
             </a:fld>
             <a:endParaRPr lang="en-US"/>
           </a:p>
@@ -7108,7 +7675,7 @@
           <a:p>
             <a:fld id="{C882E6FB-EB88-4936-BED9-9E37159958CA}" type="datetimeFigureOut">
               <a:rPr lang="en-US" smtClean="0"/>
-              <a:t>2/21/2026</a:t>
+              <a:t>2/22/2026</a:t>
             </a:fld>
             <a:endParaRPr lang="en-US"/>
           </a:p>
@@ -7306,7 +7873,7 @@
           <a:p>
             <a:fld id="{C882E6FB-EB88-4936-BED9-9E37159958CA}" type="datetimeFigureOut">
               <a:rPr lang="en-US" smtClean="0"/>
-              <a:t>2/21/2026</a:t>
+              <a:t>2/22/2026</a:t>
             </a:fld>
             <a:endParaRPr lang="en-US"/>
           </a:p>
@@ -7581,7 +8148,7 @@
           <a:p>
             <a:fld id="{C882E6FB-EB88-4936-BED9-9E37159958CA}" type="datetimeFigureOut">
               <a:rPr lang="en-US" smtClean="0"/>
-              <a:t>2/21/2026</a:t>
+              <a:t>2/22/2026</a:t>
             </a:fld>
             <a:endParaRPr lang="en-US"/>
           </a:p>
@@ -7846,7 +8413,7 @@
           <a:p>
             <a:fld id="{C882E6FB-EB88-4936-BED9-9E37159958CA}" type="datetimeFigureOut">
               <a:rPr lang="en-US" smtClean="0"/>
-              <a:t>2/21/2026</a:t>
+              <a:t>2/22/2026</a:t>
             </a:fld>
             <a:endParaRPr lang="en-US"/>
           </a:p>
@@ -8258,7 +8825,7 @@
           <a:p>
             <a:fld id="{C882E6FB-EB88-4936-BED9-9E37159958CA}" type="datetimeFigureOut">
               <a:rPr lang="en-US" smtClean="0"/>
-              <a:t>2/21/2026</a:t>
+              <a:t>2/22/2026</a:t>
             </a:fld>
             <a:endParaRPr lang="en-US"/>
           </a:p>
@@ -8399,7 +8966,7 @@
           <a:p>
             <a:fld id="{C882E6FB-EB88-4936-BED9-9E37159958CA}" type="datetimeFigureOut">
               <a:rPr lang="en-US" smtClean="0"/>
-              <a:t>2/21/2026</a:t>
+              <a:t>2/22/2026</a:t>
             </a:fld>
             <a:endParaRPr lang="en-US"/>
           </a:p>
@@ -8512,7 +9079,7 @@
           <a:p>
             <a:fld id="{C882E6FB-EB88-4936-BED9-9E37159958CA}" type="datetimeFigureOut">
               <a:rPr lang="en-US" smtClean="0"/>
-              <a:t>2/21/2026</a:t>
+              <a:t>2/22/2026</a:t>
             </a:fld>
             <a:endParaRPr lang="en-US"/>
           </a:p>
@@ -8823,7 +9390,7 @@
           <a:p>
             <a:fld id="{C882E6FB-EB88-4936-BED9-9E37159958CA}" type="datetimeFigureOut">
               <a:rPr lang="en-US" smtClean="0"/>
-              <a:t>2/21/2026</a:t>
+              <a:t>2/22/2026</a:t>
             </a:fld>
             <a:endParaRPr lang="en-US"/>
           </a:p>
@@ -9111,7 +9678,7 @@
           <a:p>
             <a:fld id="{C882E6FB-EB88-4936-BED9-9E37159958CA}" type="datetimeFigureOut">
               <a:rPr lang="en-US" smtClean="0"/>
-              <a:t>2/21/2026</a:t>
+              <a:t>2/22/2026</a:t>
             </a:fld>
             <a:endParaRPr lang="en-US"/>
           </a:p>
@@ -9352,7 +9919,7 @@
           <a:p>
             <a:fld id="{C882E6FB-EB88-4936-BED9-9E37159958CA}" type="datetimeFigureOut">
               <a:rPr lang="en-US" smtClean="0"/>
-              <a:t>2/21/2026</a:t>
+              <a:t>2/22/2026</a:t>
             </a:fld>
             <a:endParaRPr lang="en-US"/>
           </a:p>
@@ -10078,6 +10645,1344 @@
     </p:bg>
     <p:spTree>
       <p:nvGrpSpPr>
+        <p:cNvPr id="1" name=""/>
+        <p:cNvGrpSpPr/>
+        <p:nvPr/>
+      </p:nvGrpSpPr>
+      <p:grpSpPr>
+        <a:xfrm>
+          <a:off x="0" y="0"/>
+          <a:ext cx="0" cy="0"/>
+          <a:chOff x="0" y="0"/>
+          <a:chExt cx="0" cy="0"/>
+        </a:xfrm>
+      </p:grpSpPr>
+      <p:sp useBgFill="1">
+        <p:nvSpPr>
+          <p:cNvPr id="10" name="Rectangle 9">
+            <a:extLst>
+              <a:ext uri="{FF2B5EF4-FFF2-40B4-BE49-F238E27FC236}">
+                <a16:creationId xmlns:a16="http://schemas.microsoft.com/office/drawing/2014/main" id="{A8384FB5-9ADC-4DDC-881B-597D56F5B15D}"/>
+              </a:ext>
+              <a:ext uri="{C183D7F6-B498-43B3-948B-1728B52AA6E4}">
+                <adec:decorative xmlns:adec="http://schemas.microsoft.com/office/drawing/2017/decorative" val="1"/>
+              </a:ext>
+            </a:extLst>
+          </p:cNvPr>
+          <p:cNvSpPr>
+            <a:spLocks noGrp="1" noRot="1" noChangeAspect="1" noMove="1" noResize="1" noEditPoints="1" noAdjustHandles="1" noChangeArrowheads="1" noChangeShapeType="1" noTextEdit="1"/>
+          </p:cNvSpPr>
+          <p:nvPr>
+            <p:extLst>
+              <p:ext uri="{386F3935-93C4-4BCD-93E2-E3B085C9AB24}">
+                <p16:designElem xmlns:p16="http://schemas.microsoft.com/office/powerpoint/2015/main" val="1"/>
+              </p:ext>
+            </p:extLst>
+          </p:nvPr>
+        </p:nvSpPr>
+        <p:spPr>
+          <a:xfrm>
+            <a:off x="0" y="0"/>
+            <a:ext cx="12192000" cy="6858000"/>
+          </a:xfrm>
+          <a:prstGeom prst="rect">
+            <a:avLst/>
+          </a:prstGeom>
+          <a:ln w="12700" cap="flat" cmpd="sng" algn="ctr">
+            <a:noFill/>
+            <a:prstDash val="solid"/>
+            <a:miter lim="800000"/>
+          </a:ln>
+          <a:effectLst/>
+          <a:extLst>
+            <a:ext uri="{91240B29-F687-4F45-9708-019B960494DF}">
+              <a14:hiddenLine xmlns:a14="http://schemas.microsoft.com/office/drawing/2010/main" w="12700" cap="flat" cmpd="sng" algn="ctr">
+                <a:solidFill>
+                  <a:schemeClr val="accent1">
+                    <a:shade val="50000"/>
+                  </a:schemeClr>
+                </a:solidFill>
+                <a:prstDash val="solid"/>
+                <a:miter lim="800000"/>
+              </a14:hiddenLine>
+            </a:ext>
+          </a:extLst>
+        </p:spPr>
+        <p:style>
+          <a:lnRef idx="2">
+            <a:schemeClr val="accent1">
+              <a:shade val="50000"/>
+            </a:schemeClr>
+          </a:lnRef>
+          <a:fillRef idx="1">
+            <a:schemeClr val="accent1"/>
+          </a:fillRef>
+          <a:effectRef idx="0">
+            <a:schemeClr val="accent1"/>
+          </a:effectRef>
+          <a:fontRef idx="minor">
+            <a:schemeClr val="lt1"/>
+          </a:fontRef>
+        </p:style>
+        <p:txBody>
+          <a:bodyPr rtlCol="0" anchor="ctr"/>
+          <a:lstStyle/>
+          <a:p>
+            <a:pPr algn="ctr"/>
+            <a:endParaRPr lang="en-US"/>
+          </a:p>
+        </p:txBody>
+      </p:sp>
+      <p:sp>
+        <p:nvSpPr>
+          <p:cNvPr id="12" name="Rectangle 11">
+            <a:extLst>
+              <a:ext uri="{FF2B5EF4-FFF2-40B4-BE49-F238E27FC236}">
+                <a16:creationId xmlns:a16="http://schemas.microsoft.com/office/drawing/2014/main" id="{1199E1B1-A8C0-4FE8-A5A8-1CB41D69F857}"/>
+              </a:ext>
+              <a:ext uri="{C183D7F6-B498-43B3-948B-1728B52AA6E4}">
+                <adec:decorative xmlns:adec="http://schemas.microsoft.com/office/drawing/2017/decorative" val="1"/>
+              </a:ext>
+            </a:extLst>
+          </p:cNvPr>
+          <p:cNvSpPr>
+            <a:spLocks noGrp="1" noRot="1" noChangeAspect="1" noMove="1" noResize="1" noEditPoints="1" noAdjustHandles="1" noChangeArrowheads="1" noChangeShapeType="1" noTextEdit="1"/>
+          </p:cNvSpPr>
+          <p:nvPr>
+            <p:extLst>
+              <p:ext uri="{386F3935-93C4-4BCD-93E2-E3B085C9AB24}">
+                <p16:designElem xmlns:p16="http://schemas.microsoft.com/office/powerpoint/2015/main" val="1"/>
+              </p:ext>
+            </p:extLst>
+          </p:nvPr>
+        </p:nvSpPr>
+        <p:spPr>
+          <a:xfrm rot="10800000" flipH="1">
+            <a:off x="2" y="0"/>
+            <a:ext cx="12191998" cy="1575955"/>
+          </a:xfrm>
+          <a:prstGeom prst="rect">
+            <a:avLst/>
+          </a:prstGeom>
+          <a:gradFill>
+            <a:gsLst>
+              <a:gs pos="0">
+                <a:srgbClr val="000000">
+                  <a:alpha val="96000"/>
+                </a:srgbClr>
+              </a:gs>
+              <a:gs pos="100000">
+                <a:schemeClr val="accent1">
+                  <a:lumMod val="75000"/>
+                </a:schemeClr>
+              </a:gs>
+            </a:gsLst>
+            <a:lin ang="6000000" scaled="0"/>
+          </a:gradFill>
+          <a:ln>
+            <a:noFill/>
+          </a:ln>
+        </p:spPr>
+        <p:style>
+          <a:lnRef idx="2">
+            <a:schemeClr val="accent1">
+              <a:shade val="50000"/>
+            </a:schemeClr>
+          </a:lnRef>
+          <a:fillRef idx="1">
+            <a:schemeClr val="accent1"/>
+          </a:fillRef>
+          <a:effectRef idx="0">
+            <a:schemeClr val="accent1"/>
+          </a:effectRef>
+          <a:fontRef idx="minor">
+            <a:schemeClr val="lt1"/>
+          </a:fontRef>
+        </p:style>
+        <p:txBody>
+          <a:bodyPr rtlCol="0" anchor="ctr"/>
+          <a:lstStyle/>
+          <a:p>
+            <a:pPr algn="ctr"/>
+            <a:endParaRPr lang="en-US"/>
+          </a:p>
+        </p:txBody>
+      </p:sp>
+      <p:sp>
+        <p:nvSpPr>
+          <p:cNvPr id="14" name="Rectangle 13">
+            <a:extLst>
+              <a:ext uri="{FF2B5EF4-FFF2-40B4-BE49-F238E27FC236}">
+                <a16:creationId xmlns:a16="http://schemas.microsoft.com/office/drawing/2014/main" id="{84A8DE83-DE75-4B41-9DB4-A7EC0B0DEC0B}"/>
+              </a:ext>
+              <a:ext uri="{C183D7F6-B498-43B3-948B-1728B52AA6E4}">
+                <adec:decorative xmlns:adec="http://schemas.microsoft.com/office/drawing/2017/decorative" val="1"/>
+              </a:ext>
+            </a:extLst>
+          </p:cNvPr>
+          <p:cNvSpPr>
+            <a:spLocks noGrp="1" noRot="1" noChangeAspect="1" noMove="1" noResize="1" noEditPoints="1" noAdjustHandles="1" noChangeArrowheads="1" noChangeShapeType="1" noTextEdit="1"/>
+          </p:cNvSpPr>
+          <p:nvPr>
+            <p:extLst>
+              <p:ext uri="{386F3935-93C4-4BCD-93E2-E3B085C9AB24}">
+                <p16:designElem xmlns:p16="http://schemas.microsoft.com/office/powerpoint/2015/main" val="1"/>
+              </p:ext>
+            </p:extLst>
+          </p:nvPr>
+        </p:nvSpPr>
+        <p:spPr>
+          <a:xfrm>
+            <a:off x="0" y="0"/>
+            <a:ext cx="8128856" cy="1575461"/>
+          </a:xfrm>
+          <a:prstGeom prst="rect">
+            <a:avLst/>
+          </a:prstGeom>
+          <a:gradFill>
+            <a:gsLst>
+              <a:gs pos="0">
+                <a:schemeClr val="accent1">
+                  <a:alpha val="41000"/>
+                </a:schemeClr>
+              </a:gs>
+              <a:gs pos="74000">
+                <a:schemeClr val="accent1">
+                  <a:lumMod val="60000"/>
+                  <a:lumOff val="40000"/>
+                  <a:alpha val="0"/>
+                </a:schemeClr>
+              </a:gs>
+            </a:gsLst>
+            <a:lin ang="8400000" scaled="0"/>
+          </a:gradFill>
+          <a:ln>
+            <a:noFill/>
+          </a:ln>
+        </p:spPr>
+        <p:style>
+          <a:lnRef idx="2">
+            <a:schemeClr val="accent1">
+              <a:shade val="50000"/>
+            </a:schemeClr>
+          </a:lnRef>
+          <a:fillRef idx="1">
+            <a:schemeClr val="accent1"/>
+          </a:fillRef>
+          <a:effectRef idx="0">
+            <a:schemeClr val="accent1"/>
+          </a:effectRef>
+          <a:fontRef idx="minor">
+            <a:schemeClr val="lt1"/>
+          </a:fontRef>
+        </p:style>
+        <p:txBody>
+          <a:bodyPr rtlCol="0" anchor="ctr"/>
+          <a:lstStyle/>
+          <a:p>
+            <a:pPr algn="ctr"/>
+            <a:endParaRPr lang="en-US"/>
+          </a:p>
+        </p:txBody>
+      </p:sp>
+      <p:sp>
+        <p:nvSpPr>
+          <p:cNvPr id="16" name="Rectangle 15">
+            <a:extLst>
+              <a:ext uri="{FF2B5EF4-FFF2-40B4-BE49-F238E27FC236}">
+                <a16:creationId xmlns:a16="http://schemas.microsoft.com/office/drawing/2014/main" id="{A7009A0A-BEF5-4EAC-AF15-E4F9F002E239}"/>
+              </a:ext>
+              <a:ext uri="{C183D7F6-B498-43B3-948B-1728B52AA6E4}">
+                <adec:decorative xmlns:adec="http://schemas.microsoft.com/office/drawing/2017/decorative" val="1"/>
+              </a:ext>
+            </a:extLst>
+          </p:cNvPr>
+          <p:cNvSpPr>
+            <a:spLocks noGrp="1" noRot="1" noChangeAspect="1" noMove="1" noResize="1" noEditPoints="1" noAdjustHandles="1" noChangeArrowheads="1" noChangeShapeType="1" noTextEdit="1"/>
+          </p:cNvSpPr>
+          <p:nvPr>
+            <p:extLst>
+              <p:ext uri="{386F3935-93C4-4BCD-93E2-E3B085C9AB24}">
+                <p16:designElem xmlns:p16="http://schemas.microsoft.com/office/powerpoint/2015/main" val="1"/>
+              </p:ext>
+            </p:extLst>
+          </p:nvPr>
+        </p:nvSpPr>
+        <p:spPr>
+          <a:xfrm flipH="1">
+            <a:off x="-3" y="-1"/>
+            <a:ext cx="12192002" cy="1574311"/>
+          </a:xfrm>
+          <a:prstGeom prst="rect">
+            <a:avLst/>
+          </a:prstGeom>
+          <a:gradFill>
+            <a:gsLst>
+              <a:gs pos="0">
+                <a:srgbClr val="000000">
+                  <a:alpha val="63000"/>
+                </a:srgbClr>
+              </a:gs>
+              <a:gs pos="78000">
+                <a:schemeClr val="accent1">
+                  <a:alpha val="15000"/>
+                </a:schemeClr>
+              </a:gs>
+            </a:gsLst>
+            <a:lin ang="15600000" scaled="0"/>
+          </a:gradFill>
+          <a:ln>
+            <a:noFill/>
+          </a:ln>
+        </p:spPr>
+        <p:style>
+          <a:lnRef idx="2">
+            <a:schemeClr val="accent1">
+              <a:shade val="50000"/>
+            </a:schemeClr>
+          </a:lnRef>
+          <a:fillRef idx="1">
+            <a:schemeClr val="accent1"/>
+          </a:fillRef>
+          <a:effectRef idx="0">
+            <a:schemeClr val="accent1"/>
+          </a:effectRef>
+          <a:fontRef idx="minor">
+            <a:schemeClr val="lt1"/>
+          </a:fontRef>
+        </p:style>
+        <p:txBody>
+          <a:bodyPr rtlCol="0" anchor="ctr"/>
+          <a:lstStyle/>
+          <a:p>
+            <a:pPr algn="ctr"/>
+            <a:endParaRPr lang="en-US"/>
+          </a:p>
+        </p:txBody>
+      </p:sp>
+      <p:sp>
+        <p:nvSpPr>
+          <p:cNvPr id="2" name="Title 1">
+            <a:extLst>
+              <a:ext uri="{FF2B5EF4-FFF2-40B4-BE49-F238E27FC236}">
+                <a16:creationId xmlns:a16="http://schemas.microsoft.com/office/drawing/2014/main" id="{943F0D26-C404-6E35-D4F7-10155F5D3A98}"/>
+              </a:ext>
+            </a:extLst>
+          </p:cNvPr>
+          <p:cNvSpPr>
+            <a:spLocks noGrp="1"/>
+          </p:cNvSpPr>
+          <p:nvPr>
+            <p:ph type="title"/>
+          </p:nvPr>
+        </p:nvSpPr>
+        <p:spPr>
+          <a:xfrm>
+            <a:off x="699713" y="248038"/>
+            <a:ext cx="7063721" cy="1159200"/>
+          </a:xfrm>
+        </p:spPr>
+        <p:txBody>
+          <a:bodyPr vert="horz" lIns="91440" tIns="45720" rIns="91440" bIns="45720" rtlCol="0" anchor="ctr">
+            <a:normAutofit/>
+          </a:bodyPr>
+          <a:lstStyle/>
+          <a:p>
+            <a:r>
+              <a:rPr lang="en-US" sz="4000" kern="1200" dirty="0">
+                <a:solidFill>
+                  <a:srgbClr val="FFFFFF"/>
+                </a:solidFill>
+                <a:latin typeface="+mj-lt"/>
+                <a:ea typeface="+mj-ea"/>
+                <a:cs typeface="+mj-cs"/>
+              </a:rPr>
+              <a:t>Clubs and Likes</a:t>
+            </a:r>
+          </a:p>
+        </p:txBody>
+      </p:sp>
+      <p:pic>
+        <p:nvPicPr>
+          <p:cNvPr id="5" name="Picture 4">
+            <a:extLst>
+              <a:ext uri="{FF2B5EF4-FFF2-40B4-BE49-F238E27FC236}">
+                <a16:creationId xmlns:a16="http://schemas.microsoft.com/office/drawing/2014/main" id="{6C01547A-003F-2DA0-1CB8-4E92D18977A2}"/>
+              </a:ext>
+            </a:extLst>
+          </p:cNvPr>
+          <p:cNvPicPr>
+            <a:picLocks noChangeAspect="1"/>
+          </p:cNvPicPr>
+          <p:nvPr/>
+        </p:nvPicPr>
+        <p:blipFill>
+          <a:blip r:embed="rId2"/>
+          <a:srcRect b="2997"/>
+          <a:stretch>
+            <a:fillRect/>
+          </a:stretch>
+        </p:blipFill>
+        <p:spPr>
+          <a:xfrm>
+            <a:off x="-4" y="1574310"/>
+            <a:ext cx="12192003" cy="5238273"/>
+          </a:xfrm>
+          <a:prstGeom prst="rect">
+            <a:avLst/>
+          </a:prstGeom>
+        </p:spPr>
+      </p:pic>
+    </p:spTree>
+    <p:extLst>
+      <p:ext uri="{BB962C8B-B14F-4D97-AF65-F5344CB8AC3E}">
+        <p14:creationId xmlns:p14="http://schemas.microsoft.com/office/powerpoint/2010/main" val="3857486133"/>
+      </p:ext>
+    </p:extLst>
+  </p:cSld>
+  <p:clrMapOvr>
+    <a:masterClrMapping/>
+  </p:clrMapOvr>
+</p:sld>
+</file>
+
+<file path=ppt/slides/slide11.xml><?xml version="1.0" encoding="utf-8"?>
+<p:sld xmlns:a="http://schemas.openxmlformats.org/drawingml/2006/main" xmlns:r="http://schemas.openxmlformats.org/officeDocument/2006/relationships" xmlns:p="http://schemas.openxmlformats.org/presentationml/2006/main">
+  <p:cSld>
+    <p:bg>
+      <p:bgPr>
+        <a:solidFill>
+          <a:schemeClr val="bg1"/>
+        </a:solidFill>
+        <a:effectLst/>
+      </p:bgPr>
+    </p:bg>
+    <p:spTree>
+      <p:nvGrpSpPr>
+        <p:cNvPr id="1" name=""/>
+        <p:cNvGrpSpPr/>
+        <p:nvPr/>
+      </p:nvGrpSpPr>
+      <p:grpSpPr>
+        <a:xfrm>
+          <a:off x="0" y="0"/>
+          <a:ext cx="0" cy="0"/>
+          <a:chOff x="0" y="0"/>
+          <a:chExt cx="0" cy="0"/>
+        </a:xfrm>
+      </p:grpSpPr>
+      <p:sp useBgFill="1">
+        <p:nvSpPr>
+          <p:cNvPr id="22" name="Rectangle 21">
+            <a:extLst>
+              <a:ext uri="{FF2B5EF4-FFF2-40B4-BE49-F238E27FC236}">
+                <a16:creationId xmlns:a16="http://schemas.microsoft.com/office/drawing/2014/main" id="{A8384FB5-9ADC-4DDC-881B-597D56F5B15D}"/>
+              </a:ext>
+              <a:ext uri="{C183D7F6-B498-43B3-948B-1728B52AA6E4}">
+                <adec:decorative xmlns:adec="http://schemas.microsoft.com/office/drawing/2017/decorative" val="1"/>
+              </a:ext>
+            </a:extLst>
+          </p:cNvPr>
+          <p:cNvSpPr>
+            <a:spLocks noGrp="1" noRot="1" noChangeAspect="1" noMove="1" noResize="1" noEditPoints="1" noAdjustHandles="1" noChangeArrowheads="1" noChangeShapeType="1" noTextEdit="1"/>
+          </p:cNvSpPr>
+          <p:nvPr>
+            <p:extLst>
+              <p:ext uri="{386F3935-93C4-4BCD-93E2-E3B085C9AB24}">
+                <p16:designElem xmlns:p16="http://schemas.microsoft.com/office/powerpoint/2015/main" val="1"/>
+              </p:ext>
+            </p:extLst>
+          </p:nvPr>
+        </p:nvSpPr>
+        <p:spPr>
+          <a:xfrm>
+            <a:off x="0" y="0"/>
+            <a:ext cx="12192000" cy="6858000"/>
+          </a:xfrm>
+          <a:prstGeom prst="rect">
+            <a:avLst/>
+          </a:prstGeom>
+          <a:ln w="12700" cap="flat" cmpd="sng" algn="ctr">
+            <a:noFill/>
+            <a:prstDash val="solid"/>
+            <a:miter lim="800000"/>
+          </a:ln>
+          <a:effectLst/>
+          <a:extLst>
+            <a:ext uri="{91240B29-F687-4F45-9708-019B960494DF}">
+              <a14:hiddenLine xmlns:a14="http://schemas.microsoft.com/office/drawing/2010/main" w="12700" cap="flat" cmpd="sng" algn="ctr">
+                <a:solidFill>
+                  <a:schemeClr val="accent1">
+                    <a:shade val="50000"/>
+                  </a:schemeClr>
+                </a:solidFill>
+                <a:prstDash val="solid"/>
+                <a:miter lim="800000"/>
+              </a14:hiddenLine>
+            </a:ext>
+          </a:extLst>
+        </p:spPr>
+        <p:style>
+          <a:lnRef idx="2">
+            <a:schemeClr val="accent1">
+              <a:shade val="50000"/>
+            </a:schemeClr>
+          </a:lnRef>
+          <a:fillRef idx="1">
+            <a:schemeClr val="accent1"/>
+          </a:fillRef>
+          <a:effectRef idx="0">
+            <a:schemeClr val="accent1"/>
+          </a:effectRef>
+          <a:fontRef idx="minor">
+            <a:schemeClr val="lt1"/>
+          </a:fontRef>
+        </p:style>
+        <p:txBody>
+          <a:bodyPr rtlCol="0" anchor="ctr"/>
+          <a:lstStyle/>
+          <a:p>
+            <a:pPr algn="ctr"/>
+            <a:endParaRPr lang="en-US"/>
+          </a:p>
+        </p:txBody>
+      </p:sp>
+      <p:sp>
+        <p:nvSpPr>
+          <p:cNvPr id="24" name="Rectangle 23">
+            <a:extLst>
+              <a:ext uri="{FF2B5EF4-FFF2-40B4-BE49-F238E27FC236}">
+                <a16:creationId xmlns:a16="http://schemas.microsoft.com/office/drawing/2014/main" id="{1199E1B1-A8C0-4FE8-A5A8-1CB41D69F857}"/>
+              </a:ext>
+              <a:ext uri="{C183D7F6-B498-43B3-948B-1728B52AA6E4}">
+                <adec:decorative xmlns:adec="http://schemas.microsoft.com/office/drawing/2017/decorative" val="1"/>
+              </a:ext>
+            </a:extLst>
+          </p:cNvPr>
+          <p:cNvSpPr>
+            <a:spLocks noGrp="1" noRot="1" noChangeAspect="1" noMove="1" noResize="1" noEditPoints="1" noAdjustHandles="1" noChangeArrowheads="1" noChangeShapeType="1" noTextEdit="1"/>
+          </p:cNvSpPr>
+          <p:nvPr>
+            <p:extLst>
+              <p:ext uri="{386F3935-93C4-4BCD-93E2-E3B085C9AB24}">
+                <p16:designElem xmlns:p16="http://schemas.microsoft.com/office/powerpoint/2015/main" val="1"/>
+              </p:ext>
+            </p:extLst>
+          </p:nvPr>
+        </p:nvSpPr>
+        <p:spPr>
+          <a:xfrm rot="10800000" flipH="1">
+            <a:off x="2" y="0"/>
+            <a:ext cx="12191998" cy="1575955"/>
+          </a:xfrm>
+          <a:prstGeom prst="rect">
+            <a:avLst/>
+          </a:prstGeom>
+          <a:gradFill>
+            <a:gsLst>
+              <a:gs pos="0">
+                <a:srgbClr val="000000">
+                  <a:alpha val="96000"/>
+                </a:srgbClr>
+              </a:gs>
+              <a:gs pos="100000">
+                <a:schemeClr val="accent1">
+                  <a:lumMod val="75000"/>
+                </a:schemeClr>
+              </a:gs>
+            </a:gsLst>
+            <a:lin ang="6000000" scaled="0"/>
+          </a:gradFill>
+          <a:ln>
+            <a:noFill/>
+          </a:ln>
+        </p:spPr>
+        <p:style>
+          <a:lnRef idx="2">
+            <a:schemeClr val="accent1">
+              <a:shade val="50000"/>
+            </a:schemeClr>
+          </a:lnRef>
+          <a:fillRef idx="1">
+            <a:schemeClr val="accent1"/>
+          </a:fillRef>
+          <a:effectRef idx="0">
+            <a:schemeClr val="accent1"/>
+          </a:effectRef>
+          <a:fontRef idx="minor">
+            <a:schemeClr val="lt1"/>
+          </a:fontRef>
+        </p:style>
+        <p:txBody>
+          <a:bodyPr rtlCol="0" anchor="ctr"/>
+          <a:lstStyle/>
+          <a:p>
+            <a:pPr algn="ctr"/>
+            <a:endParaRPr lang="en-US"/>
+          </a:p>
+        </p:txBody>
+      </p:sp>
+      <p:sp>
+        <p:nvSpPr>
+          <p:cNvPr id="26" name="Rectangle 25">
+            <a:extLst>
+              <a:ext uri="{FF2B5EF4-FFF2-40B4-BE49-F238E27FC236}">
+                <a16:creationId xmlns:a16="http://schemas.microsoft.com/office/drawing/2014/main" id="{84A8DE83-DE75-4B41-9DB4-A7EC0B0DEC0B}"/>
+              </a:ext>
+              <a:ext uri="{C183D7F6-B498-43B3-948B-1728B52AA6E4}">
+                <adec:decorative xmlns:adec="http://schemas.microsoft.com/office/drawing/2017/decorative" val="1"/>
+              </a:ext>
+            </a:extLst>
+          </p:cNvPr>
+          <p:cNvSpPr>
+            <a:spLocks noGrp="1" noRot="1" noChangeAspect="1" noMove="1" noResize="1" noEditPoints="1" noAdjustHandles="1" noChangeArrowheads="1" noChangeShapeType="1" noTextEdit="1"/>
+          </p:cNvSpPr>
+          <p:nvPr>
+            <p:extLst>
+              <p:ext uri="{386F3935-93C4-4BCD-93E2-E3B085C9AB24}">
+                <p16:designElem xmlns:p16="http://schemas.microsoft.com/office/powerpoint/2015/main" val="1"/>
+              </p:ext>
+            </p:extLst>
+          </p:nvPr>
+        </p:nvSpPr>
+        <p:spPr>
+          <a:xfrm>
+            <a:off x="0" y="0"/>
+            <a:ext cx="8128856" cy="1575461"/>
+          </a:xfrm>
+          <a:prstGeom prst="rect">
+            <a:avLst/>
+          </a:prstGeom>
+          <a:gradFill>
+            <a:gsLst>
+              <a:gs pos="0">
+                <a:schemeClr val="accent1">
+                  <a:alpha val="41000"/>
+                </a:schemeClr>
+              </a:gs>
+              <a:gs pos="74000">
+                <a:schemeClr val="accent1">
+                  <a:lumMod val="60000"/>
+                  <a:lumOff val="40000"/>
+                  <a:alpha val="0"/>
+                </a:schemeClr>
+              </a:gs>
+            </a:gsLst>
+            <a:lin ang="8400000" scaled="0"/>
+          </a:gradFill>
+          <a:ln>
+            <a:noFill/>
+          </a:ln>
+        </p:spPr>
+        <p:style>
+          <a:lnRef idx="2">
+            <a:schemeClr val="accent1">
+              <a:shade val="50000"/>
+            </a:schemeClr>
+          </a:lnRef>
+          <a:fillRef idx="1">
+            <a:schemeClr val="accent1"/>
+          </a:fillRef>
+          <a:effectRef idx="0">
+            <a:schemeClr val="accent1"/>
+          </a:effectRef>
+          <a:fontRef idx="minor">
+            <a:schemeClr val="lt1"/>
+          </a:fontRef>
+        </p:style>
+        <p:txBody>
+          <a:bodyPr rtlCol="0" anchor="ctr"/>
+          <a:lstStyle/>
+          <a:p>
+            <a:pPr algn="ctr"/>
+            <a:endParaRPr lang="en-US"/>
+          </a:p>
+        </p:txBody>
+      </p:sp>
+      <p:sp>
+        <p:nvSpPr>
+          <p:cNvPr id="28" name="Rectangle 27">
+            <a:extLst>
+              <a:ext uri="{FF2B5EF4-FFF2-40B4-BE49-F238E27FC236}">
+                <a16:creationId xmlns:a16="http://schemas.microsoft.com/office/drawing/2014/main" id="{A7009A0A-BEF5-4EAC-AF15-E4F9F002E239}"/>
+              </a:ext>
+              <a:ext uri="{C183D7F6-B498-43B3-948B-1728B52AA6E4}">
+                <adec:decorative xmlns:adec="http://schemas.microsoft.com/office/drawing/2017/decorative" val="1"/>
+              </a:ext>
+            </a:extLst>
+          </p:cNvPr>
+          <p:cNvSpPr>
+            <a:spLocks noGrp="1" noRot="1" noChangeAspect="1" noMove="1" noResize="1" noEditPoints="1" noAdjustHandles="1" noChangeArrowheads="1" noChangeShapeType="1" noTextEdit="1"/>
+          </p:cNvSpPr>
+          <p:nvPr>
+            <p:extLst>
+              <p:ext uri="{386F3935-93C4-4BCD-93E2-E3B085C9AB24}">
+                <p16:designElem xmlns:p16="http://schemas.microsoft.com/office/powerpoint/2015/main" val="1"/>
+              </p:ext>
+            </p:extLst>
+          </p:nvPr>
+        </p:nvSpPr>
+        <p:spPr>
+          <a:xfrm flipH="1">
+            <a:off x="-3" y="-1"/>
+            <a:ext cx="12192002" cy="1574311"/>
+          </a:xfrm>
+          <a:prstGeom prst="rect">
+            <a:avLst/>
+          </a:prstGeom>
+          <a:gradFill>
+            <a:gsLst>
+              <a:gs pos="0">
+                <a:srgbClr val="000000">
+                  <a:alpha val="63000"/>
+                </a:srgbClr>
+              </a:gs>
+              <a:gs pos="78000">
+                <a:schemeClr val="accent1">
+                  <a:alpha val="15000"/>
+                </a:schemeClr>
+              </a:gs>
+            </a:gsLst>
+            <a:lin ang="15600000" scaled="0"/>
+          </a:gradFill>
+          <a:ln>
+            <a:noFill/>
+          </a:ln>
+        </p:spPr>
+        <p:style>
+          <a:lnRef idx="2">
+            <a:schemeClr val="accent1">
+              <a:shade val="50000"/>
+            </a:schemeClr>
+          </a:lnRef>
+          <a:fillRef idx="1">
+            <a:schemeClr val="accent1"/>
+          </a:fillRef>
+          <a:effectRef idx="0">
+            <a:schemeClr val="accent1"/>
+          </a:effectRef>
+          <a:fontRef idx="minor">
+            <a:schemeClr val="lt1"/>
+          </a:fontRef>
+        </p:style>
+        <p:txBody>
+          <a:bodyPr rtlCol="0" anchor="ctr"/>
+          <a:lstStyle/>
+          <a:p>
+            <a:pPr algn="ctr"/>
+            <a:endParaRPr lang="en-US"/>
+          </a:p>
+        </p:txBody>
+      </p:sp>
+      <p:sp>
+        <p:nvSpPr>
+          <p:cNvPr id="2" name="Title 1">
+            <a:extLst>
+              <a:ext uri="{FF2B5EF4-FFF2-40B4-BE49-F238E27FC236}">
+                <a16:creationId xmlns:a16="http://schemas.microsoft.com/office/drawing/2014/main" id="{BCFB2890-40BC-6F61-0FD1-79775DD8B802}"/>
+              </a:ext>
+            </a:extLst>
+          </p:cNvPr>
+          <p:cNvSpPr>
+            <a:spLocks noGrp="1"/>
+          </p:cNvSpPr>
+          <p:nvPr>
+            <p:ph type="title"/>
+          </p:nvPr>
+        </p:nvSpPr>
+        <p:spPr>
+          <a:xfrm>
+            <a:off x="699713" y="248038"/>
+            <a:ext cx="7063721" cy="1159200"/>
+          </a:xfrm>
+        </p:spPr>
+        <p:txBody>
+          <a:bodyPr vert="horz" lIns="91440" tIns="45720" rIns="91440" bIns="45720" rtlCol="0" anchor="ctr">
+            <a:normAutofit/>
+          </a:bodyPr>
+          <a:lstStyle/>
+          <a:p>
+            <a:r>
+              <a:rPr lang="en-US" sz="4000" kern="1200">
+                <a:solidFill>
+                  <a:srgbClr val="FFFFFF"/>
+                </a:solidFill>
+                <a:latin typeface="+mj-lt"/>
+                <a:ea typeface="+mj-ea"/>
+                <a:cs typeface="+mj-cs"/>
+              </a:rPr>
+              <a:t>Teams Page </a:t>
+            </a:r>
+          </a:p>
+        </p:txBody>
+      </p:sp>
+      <p:sp>
+        <p:nvSpPr>
+          <p:cNvPr id="3" name="Text Placeholder 2">
+            <a:extLst>
+              <a:ext uri="{FF2B5EF4-FFF2-40B4-BE49-F238E27FC236}">
+                <a16:creationId xmlns:a16="http://schemas.microsoft.com/office/drawing/2014/main" id="{73107D4C-9470-CFCD-B4FE-5152142A64F6}"/>
+              </a:ext>
+            </a:extLst>
+          </p:cNvPr>
+          <p:cNvSpPr>
+            <a:spLocks noGrp="1"/>
+          </p:cNvSpPr>
+          <p:nvPr>
+            <p:ph type="body" idx="1"/>
+          </p:nvPr>
+        </p:nvSpPr>
+        <p:spPr>
+          <a:xfrm>
+            <a:off x="8572499" y="390832"/>
+            <a:ext cx="3233585" cy="873612"/>
+          </a:xfrm>
+        </p:spPr>
+        <p:txBody>
+          <a:bodyPr vert="horz" lIns="91440" tIns="45720" rIns="91440" bIns="45720" rtlCol="0" anchor="ctr">
+            <a:normAutofit/>
+          </a:bodyPr>
+          <a:lstStyle/>
+          <a:p>
+            <a:r>
+              <a:rPr lang="en-US" sz="2000" kern="1200" dirty="0">
+                <a:solidFill>
+                  <a:srgbClr val="FFFFFF"/>
+                </a:solidFill>
+                <a:latin typeface="+mn-lt"/>
+                <a:ea typeface="+mn-ea"/>
+                <a:cs typeface="+mn-cs"/>
+              </a:rPr>
+              <a:t>Men’s Sports Teams</a:t>
+            </a:r>
+          </a:p>
+        </p:txBody>
+      </p:sp>
+      <p:pic>
+        <p:nvPicPr>
+          <p:cNvPr id="5" name="Picture 4">
+            <a:extLst>
+              <a:ext uri="{FF2B5EF4-FFF2-40B4-BE49-F238E27FC236}">
+                <a16:creationId xmlns:a16="http://schemas.microsoft.com/office/drawing/2014/main" id="{6C3C1071-9787-C6F9-4218-E3342B5ED70F}"/>
+              </a:ext>
+            </a:extLst>
+          </p:cNvPr>
+          <p:cNvPicPr>
+            <a:picLocks noChangeAspect="1"/>
+          </p:cNvPicPr>
+          <p:nvPr/>
+        </p:nvPicPr>
+        <p:blipFill>
+          <a:blip r:embed="rId2"/>
+          <a:stretch>
+            <a:fillRect/>
+          </a:stretch>
+        </p:blipFill>
+        <p:spPr>
+          <a:xfrm>
+            <a:off x="0" y="1501796"/>
+            <a:ext cx="12191997" cy="5286564"/>
+          </a:xfrm>
+          <a:prstGeom prst="rect">
+            <a:avLst/>
+          </a:prstGeom>
+        </p:spPr>
+      </p:pic>
+    </p:spTree>
+    <p:extLst>
+      <p:ext uri="{BB962C8B-B14F-4D97-AF65-F5344CB8AC3E}">
+        <p14:creationId xmlns:p14="http://schemas.microsoft.com/office/powerpoint/2010/main" val="1553250187"/>
+      </p:ext>
+    </p:extLst>
+  </p:cSld>
+  <p:clrMapOvr>
+    <a:masterClrMapping/>
+  </p:clrMapOvr>
+</p:sld>
+</file>
+
+<file path=ppt/slides/slide12.xml><?xml version="1.0" encoding="utf-8"?>
+<p:sld xmlns:a="http://schemas.openxmlformats.org/drawingml/2006/main" xmlns:r="http://schemas.openxmlformats.org/officeDocument/2006/relationships" xmlns:p="http://schemas.openxmlformats.org/presentationml/2006/main">
+  <p:cSld>
+    <p:bg>
+      <p:bgPr>
+        <a:solidFill>
+          <a:schemeClr val="bg1"/>
+        </a:solidFill>
+        <a:effectLst/>
+      </p:bgPr>
+    </p:bg>
+    <p:spTree>
+      <p:nvGrpSpPr>
+        <p:cNvPr id="1" name="">
+          <a:extLst>
+            <a:ext uri="{FF2B5EF4-FFF2-40B4-BE49-F238E27FC236}">
+              <a16:creationId xmlns:a16="http://schemas.microsoft.com/office/drawing/2014/main" id="{3AA3AC05-75C4-DA89-70FB-10BAC497FB66}"/>
+            </a:ext>
+          </a:extLst>
+        </p:cNvPr>
+        <p:cNvGrpSpPr/>
+        <p:nvPr/>
+      </p:nvGrpSpPr>
+      <p:grpSpPr>
+        <a:xfrm>
+          <a:off x="0" y="0"/>
+          <a:ext cx="0" cy="0"/>
+          <a:chOff x="0" y="0"/>
+          <a:chExt cx="0" cy="0"/>
+        </a:xfrm>
+      </p:grpSpPr>
+      <p:sp useBgFill="1">
+        <p:nvSpPr>
+          <p:cNvPr id="22" name="Rectangle 21">
+            <a:extLst>
+              <a:ext uri="{FF2B5EF4-FFF2-40B4-BE49-F238E27FC236}">
+                <a16:creationId xmlns:a16="http://schemas.microsoft.com/office/drawing/2014/main" id="{477B430E-4EC0-3EF7-CB25-D99C6A71613E}"/>
+              </a:ext>
+              <a:ext uri="{C183D7F6-B498-43B3-948B-1728B52AA6E4}">
+                <adec:decorative xmlns:adec="http://schemas.microsoft.com/office/drawing/2017/decorative" val="1"/>
+              </a:ext>
+            </a:extLst>
+          </p:cNvPr>
+          <p:cNvSpPr>
+            <a:spLocks noGrp="1" noRot="1" noChangeAspect="1" noMove="1" noResize="1" noEditPoints="1" noAdjustHandles="1" noChangeArrowheads="1" noChangeShapeType="1" noTextEdit="1"/>
+          </p:cNvSpPr>
+          <p:nvPr>
+            <p:extLst>
+              <p:ext uri="{386F3935-93C4-4BCD-93E2-E3B085C9AB24}">
+                <p16:designElem xmlns:p16="http://schemas.microsoft.com/office/powerpoint/2015/main" val="1"/>
+              </p:ext>
+            </p:extLst>
+          </p:nvPr>
+        </p:nvSpPr>
+        <p:spPr>
+          <a:xfrm>
+            <a:off x="0" y="0"/>
+            <a:ext cx="12192000" cy="6858000"/>
+          </a:xfrm>
+          <a:prstGeom prst="rect">
+            <a:avLst/>
+          </a:prstGeom>
+          <a:ln w="12700" cap="flat" cmpd="sng" algn="ctr">
+            <a:noFill/>
+            <a:prstDash val="solid"/>
+            <a:miter lim="800000"/>
+          </a:ln>
+          <a:effectLst/>
+          <a:extLst>
+            <a:ext uri="{91240B29-F687-4F45-9708-019B960494DF}">
+              <a14:hiddenLine xmlns:a14="http://schemas.microsoft.com/office/drawing/2010/main" w="12700" cap="flat" cmpd="sng" algn="ctr">
+                <a:solidFill>
+                  <a:schemeClr val="accent1">
+                    <a:shade val="50000"/>
+                  </a:schemeClr>
+                </a:solidFill>
+                <a:prstDash val="solid"/>
+                <a:miter lim="800000"/>
+              </a14:hiddenLine>
+            </a:ext>
+          </a:extLst>
+        </p:spPr>
+        <p:style>
+          <a:lnRef idx="2">
+            <a:schemeClr val="accent1">
+              <a:shade val="50000"/>
+            </a:schemeClr>
+          </a:lnRef>
+          <a:fillRef idx="1">
+            <a:schemeClr val="accent1"/>
+          </a:fillRef>
+          <a:effectRef idx="0">
+            <a:schemeClr val="accent1"/>
+          </a:effectRef>
+          <a:fontRef idx="minor">
+            <a:schemeClr val="lt1"/>
+          </a:fontRef>
+        </p:style>
+        <p:txBody>
+          <a:bodyPr rtlCol="0" anchor="ctr"/>
+          <a:lstStyle/>
+          <a:p>
+            <a:pPr algn="ctr"/>
+            <a:endParaRPr lang="en-US"/>
+          </a:p>
+        </p:txBody>
+      </p:sp>
+      <p:sp>
+        <p:nvSpPr>
+          <p:cNvPr id="24" name="Rectangle 23">
+            <a:extLst>
+              <a:ext uri="{FF2B5EF4-FFF2-40B4-BE49-F238E27FC236}">
+                <a16:creationId xmlns:a16="http://schemas.microsoft.com/office/drawing/2014/main" id="{048F62DB-78E9-623C-AED3-6A22D1AB07D2}"/>
+              </a:ext>
+              <a:ext uri="{C183D7F6-B498-43B3-948B-1728B52AA6E4}">
+                <adec:decorative xmlns:adec="http://schemas.microsoft.com/office/drawing/2017/decorative" val="1"/>
+              </a:ext>
+            </a:extLst>
+          </p:cNvPr>
+          <p:cNvSpPr>
+            <a:spLocks noGrp="1" noRot="1" noChangeAspect="1" noMove="1" noResize="1" noEditPoints="1" noAdjustHandles="1" noChangeArrowheads="1" noChangeShapeType="1" noTextEdit="1"/>
+          </p:cNvSpPr>
+          <p:nvPr>
+            <p:extLst>
+              <p:ext uri="{386F3935-93C4-4BCD-93E2-E3B085C9AB24}">
+                <p16:designElem xmlns:p16="http://schemas.microsoft.com/office/powerpoint/2015/main" val="1"/>
+              </p:ext>
+            </p:extLst>
+          </p:nvPr>
+        </p:nvSpPr>
+        <p:spPr>
+          <a:xfrm rot="10800000" flipH="1">
+            <a:off x="2" y="0"/>
+            <a:ext cx="12191998" cy="1575955"/>
+          </a:xfrm>
+          <a:prstGeom prst="rect">
+            <a:avLst/>
+          </a:prstGeom>
+          <a:gradFill>
+            <a:gsLst>
+              <a:gs pos="0">
+                <a:srgbClr val="000000">
+                  <a:alpha val="96000"/>
+                </a:srgbClr>
+              </a:gs>
+              <a:gs pos="100000">
+                <a:schemeClr val="accent1">
+                  <a:lumMod val="75000"/>
+                </a:schemeClr>
+              </a:gs>
+            </a:gsLst>
+            <a:lin ang="6000000" scaled="0"/>
+          </a:gradFill>
+          <a:ln>
+            <a:noFill/>
+          </a:ln>
+        </p:spPr>
+        <p:style>
+          <a:lnRef idx="2">
+            <a:schemeClr val="accent1">
+              <a:shade val="50000"/>
+            </a:schemeClr>
+          </a:lnRef>
+          <a:fillRef idx="1">
+            <a:schemeClr val="accent1"/>
+          </a:fillRef>
+          <a:effectRef idx="0">
+            <a:schemeClr val="accent1"/>
+          </a:effectRef>
+          <a:fontRef idx="minor">
+            <a:schemeClr val="lt1"/>
+          </a:fontRef>
+        </p:style>
+        <p:txBody>
+          <a:bodyPr rtlCol="0" anchor="ctr"/>
+          <a:lstStyle/>
+          <a:p>
+            <a:pPr algn="ctr"/>
+            <a:endParaRPr lang="en-US"/>
+          </a:p>
+        </p:txBody>
+      </p:sp>
+      <p:sp>
+        <p:nvSpPr>
+          <p:cNvPr id="26" name="Rectangle 25">
+            <a:extLst>
+              <a:ext uri="{FF2B5EF4-FFF2-40B4-BE49-F238E27FC236}">
+                <a16:creationId xmlns:a16="http://schemas.microsoft.com/office/drawing/2014/main" id="{A6D123AA-0793-BFC2-2B03-3321361CC512}"/>
+              </a:ext>
+              <a:ext uri="{C183D7F6-B498-43B3-948B-1728B52AA6E4}">
+                <adec:decorative xmlns:adec="http://schemas.microsoft.com/office/drawing/2017/decorative" val="1"/>
+              </a:ext>
+            </a:extLst>
+          </p:cNvPr>
+          <p:cNvSpPr>
+            <a:spLocks noGrp="1" noRot="1" noChangeAspect="1" noMove="1" noResize="1" noEditPoints="1" noAdjustHandles="1" noChangeArrowheads="1" noChangeShapeType="1" noTextEdit="1"/>
+          </p:cNvSpPr>
+          <p:nvPr>
+            <p:extLst>
+              <p:ext uri="{386F3935-93C4-4BCD-93E2-E3B085C9AB24}">
+                <p16:designElem xmlns:p16="http://schemas.microsoft.com/office/powerpoint/2015/main" val="1"/>
+              </p:ext>
+            </p:extLst>
+          </p:nvPr>
+        </p:nvSpPr>
+        <p:spPr>
+          <a:xfrm>
+            <a:off x="0" y="0"/>
+            <a:ext cx="8128856" cy="1575461"/>
+          </a:xfrm>
+          <a:prstGeom prst="rect">
+            <a:avLst/>
+          </a:prstGeom>
+          <a:gradFill>
+            <a:gsLst>
+              <a:gs pos="0">
+                <a:schemeClr val="accent1">
+                  <a:alpha val="41000"/>
+                </a:schemeClr>
+              </a:gs>
+              <a:gs pos="74000">
+                <a:schemeClr val="accent1">
+                  <a:lumMod val="60000"/>
+                  <a:lumOff val="40000"/>
+                  <a:alpha val="0"/>
+                </a:schemeClr>
+              </a:gs>
+            </a:gsLst>
+            <a:lin ang="8400000" scaled="0"/>
+          </a:gradFill>
+          <a:ln>
+            <a:noFill/>
+          </a:ln>
+        </p:spPr>
+        <p:style>
+          <a:lnRef idx="2">
+            <a:schemeClr val="accent1">
+              <a:shade val="50000"/>
+            </a:schemeClr>
+          </a:lnRef>
+          <a:fillRef idx="1">
+            <a:schemeClr val="accent1"/>
+          </a:fillRef>
+          <a:effectRef idx="0">
+            <a:schemeClr val="accent1"/>
+          </a:effectRef>
+          <a:fontRef idx="minor">
+            <a:schemeClr val="lt1"/>
+          </a:fontRef>
+        </p:style>
+        <p:txBody>
+          <a:bodyPr rtlCol="0" anchor="ctr"/>
+          <a:lstStyle/>
+          <a:p>
+            <a:pPr algn="ctr"/>
+            <a:endParaRPr lang="en-US"/>
+          </a:p>
+        </p:txBody>
+      </p:sp>
+      <p:sp>
+        <p:nvSpPr>
+          <p:cNvPr id="28" name="Rectangle 27">
+            <a:extLst>
+              <a:ext uri="{FF2B5EF4-FFF2-40B4-BE49-F238E27FC236}">
+                <a16:creationId xmlns:a16="http://schemas.microsoft.com/office/drawing/2014/main" id="{E6E9994B-17B4-9B26-64FB-901CBB1B3E7E}"/>
+              </a:ext>
+              <a:ext uri="{C183D7F6-B498-43B3-948B-1728B52AA6E4}">
+                <adec:decorative xmlns:adec="http://schemas.microsoft.com/office/drawing/2017/decorative" val="1"/>
+              </a:ext>
+            </a:extLst>
+          </p:cNvPr>
+          <p:cNvSpPr>
+            <a:spLocks noGrp="1" noRot="1" noChangeAspect="1" noMove="1" noResize="1" noEditPoints="1" noAdjustHandles="1" noChangeArrowheads="1" noChangeShapeType="1" noTextEdit="1"/>
+          </p:cNvSpPr>
+          <p:nvPr>
+            <p:extLst>
+              <p:ext uri="{386F3935-93C4-4BCD-93E2-E3B085C9AB24}">
+                <p16:designElem xmlns:p16="http://schemas.microsoft.com/office/powerpoint/2015/main" val="1"/>
+              </p:ext>
+            </p:extLst>
+          </p:nvPr>
+        </p:nvSpPr>
+        <p:spPr>
+          <a:xfrm flipH="1">
+            <a:off x="-3" y="-1"/>
+            <a:ext cx="12192002" cy="1574311"/>
+          </a:xfrm>
+          <a:prstGeom prst="rect">
+            <a:avLst/>
+          </a:prstGeom>
+          <a:gradFill>
+            <a:gsLst>
+              <a:gs pos="0">
+                <a:srgbClr val="000000">
+                  <a:alpha val="63000"/>
+                </a:srgbClr>
+              </a:gs>
+              <a:gs pos="78000">
+                <a:schemeClr val="accent1">
+                  <a:alpha val="15000"/>
+                </a:schemeClr>
+              </a:gs>
+            </a:gsLst>
+            <a:lin ang="15600000" scaled="0"/>
+          </a:gradFill>
+          <a:ln>
+            <a:noFill/>
+          </a:ln>
+        </p:spPr>
+        <p:style>
+          <a:lnRef idx="2">
+            <a:schemeClr val="accent1">
+              <a:shade val="50000"/>
+            </a:schemeClr>
+          </a:lnRef>
+          <a:fillRef idx="1">
+            <a:schemeClr val="accent1"/>
+          </a:fillRef>
+          <a:effectRef idx="0">
+            <a:schemeClr val="accent1"/>
+          </a:effectRef>
+          <a:fontRef idx="minor">
+            <a:schemeClr val="lt1"/>
+          </a:fontRef>
+        </p:style>
+        <p:txBody>
+          <a:bodyPr rtlCol="0" anchor="ctr"/>
+          <a:lstStyle/>
+          <a:p>
+            <a:pPr algn="ctr"/>
+            <a:endParaRPr lang="en-US"/>
+          </a:p>
+        </p:txBody>
+      </p:sp>
+      <p:sp>
+        <p:nvSpPr>
+          <p:cNvPr id="2" name="Title 1">
+            <a:extLst>
+              <a:ext uri="{FF2B5EF4-FFF2-40B4-BE49-F238E27FC236}">
+                <a16:creationId xmlns:a16="http://schemas.microsoft.com/office/drawing/2014/main" id="{084C28AE-E5BA-561A-064B-5D2A6DD0CF28}"/>
+              </a:ext>
+            </a:extLst>
+          </p:cNvPr>
+          <p:cNvSpPr>
+            <a:spLocks noGrp="1"/>
+          </p:cNvSpPr>
+          <p:nvPr>
+            <p:ph type="title"/>
+          </p:nvPr>
+        </p:nvSpPr>
+        <p:spPr>
+          <a:xfrm>
+            <a:off x="699713" y="248038"/>
+            <a:ext cx="7063721" cy="1159200"/>
+          </a:xfrm>
+        </p:spPr>
+        <p:txBody>
+          <a:bodyPr vert="horz" lIns="91440" tIns="45720" rIns="91440" bIns="45720" rtlCol="0" anchor="ctr">
+            <a:normAutofit/>
+          </a:bodyPr>
+          <a:lstStyle/>
+          <a:p>
+            <a:r>
+              <a:rPr lang="en-US" sz="4000" kern="1200">
+                <a:solidFill>
+                  <a:srgbClr val="FFFFFF"/>
+                </a:solidFill>
+                <a:latin typeface="+mj-lt"/>
+                <a:ea typeface="+mj-ea"/>
+                <a:cs typeface="+mj-cs"/>
+              </a:rPr>
+              <a:t>Teams Page </a:t>
+            </a:r>
+          </a:p>
+        </p:txBody>
+      </p:sp>
+      <p:sp>
+        <p:nvSpPr>
+          <p:cNvPr id="3" name="Text Placeholder 2">
+            <a:extLst>
+              <a:ext uri="{FF2B5EF4-FFF2-40B4-BE49-F238E27FC236}">
+                <a16:creationId xmlns:a16="http://schemas.microsoft.com/office/drawing/2014/main" id="{C12646E0-2765-987C-E33B-C70E4F4125BD}"/>
+              </a:ext>
+            </a:extLst>
+          </p:cNvPr>
+          <p:cNvSpPr>
+            <a:spLocks noGrp="1"/>
+          </p:cNvSpPr>
+          <p:nvPr>
+            <p:ph type="body" idx="1"/>
+          </p:nvPr>
+        </p:nvSpPr>
+        <p:spPr>
+          <a:xfrm>
+            <a:off x="8572499" y="390832"/>
+            <a:ext cx="3233585" cy="873612"/>
+          </a:xfrm>
+        </p:spPr>
+        <p:txBody>
+          <a:bodyPr vert="horz" lIns="91440" tIns="45720" rIns="91440" bIns="45720" rtlCol="0" anchor="ctr">
+            <a:normAutofit/>
+          </a:bodyPr>
+          <a:lstStyle/>
+          <a:p>
+            <a:r>
+              <a:rPr lang="en-US" sz="2000" dirty="0">
+                <a:solidFill>
+                  <a:srgbClr val="FFFFFF"/>
+                </a:solidFill>
+              </a:rPr>
+              <a:t>Women</a:t>
+            </a:r>
+            <a:r>
+              <a:rPr lang="en-US" sz="2000" kern="1200" dirty="0">
+                <a:solidFill>
+                  <a:srgbClr val="FFFFFF"/>
+                </a:solidFill>
+                <a:latin typeface="+mn-lt"/>
+                <a:ea typeface="+mn-ea"/>
+                <a:cs typeface="+mn-cs"/>
+              </a:rPr>
+              <a:t>’s Sports Teams</a:t>
+            </a:r>
+          </a:p>
+        </p:txBody>
+      </p:sp>
+      <p:pic>
+        <p:nvPicPr>
+          <p:cNvPr id="6" name="Picture 5">
+            <a:extLst>
+              <a:ext uri="{FF2B5EF4-FFF2-40B4-BE49-F238E27FC236}">
+                <a16:creationId xmlns:a16="http://schemas.microsoft.com/office/drawing/2014/main" id="{81F3D153-CB3E-735A-D107-97D5A649C721}"/>
+              </a:ext>
+            </a:extLst>
+          </p:cNvPr>
+          <p:cNvPicPr>
+            <a:picLocks noChangeAspect="1"/>
+          </p:cNvPicPr>
+          <p:nvPr/>
+        </p:nvPicPr>
+        <p:blipFill>
+          <a:blip r:embed="rId2"/>
+          <a:stretch>
+            <a:fillRect/>
+          </a:stretch>
+        </p:blipFill>
+        <p:spPr>
+          <a:xfrm>
+            <a:off x="-4" y="1289677"/>
+            <a:ext cx="12192000" cy="5651859"/>
+          </a:xfrm>
+          <a:prstGeom prst="rect">
+            <a:avLst/>
+          </a:prstGeom>
+        </p:spPr>
+      </p:pic>
+    </p:spTree>
+    <p:extLst>
+      <p:ext uri="{BB962C8B-B14F-4D97-AF65-F5344CB8AC3E}">
+        <p14:creationId xmlns:p14="http://schemas.microsoft.com/office/powerpoint/2010/main" val="3338242679"/>
+      </p:ext>
+    </p:extLst>
+  </p:cSld>
+  <p:clrMapOvr>
+    <a:masterClrMapping/>
+  </p:clrMapOvr>
+</p:sld>
+</file>
+
+<file path=ppt/slides/slide13.xml><?xml version="1.0" encoding="utf-8"?>
+<p:sld xmlns:a="http://schemas.openxmlformats.org/drawingml/2006/main" xmlns:r="http://schemas.openxmlformats.org/officeDocument/2006/relationships" xmlns:p="http://schemas.openxmlformats.org/presentationml/2006/main">
+  <p:cSld>
+    <p:bg>
+      <p:bgPr>
+        <a:solidFill>
+          <a:schemeClr val="bg1"/>
+        </a:solidFill>
+        <a:effectLst/>
+      </p:bgPr>
+    </p:bg>
+    <p:spTree>
+      <p:nvGrpSpPr>
         <p:cNvPr id="1" name="">
           <a:extLst>
             <a:ext uri="{FF2B5EF4-FFF2-40B4-BE49-F238E27FC236}">
@@ -10387,7 +12292,7 @@
           <p:nvPr>
             <p:extLst>
               <p:ext uri="{D42A27DB-BD31-4B8C-83A1-F6EECF244321}">
-                <p14:modId xmlns:p14="http://schemas.microsoft.com/office/powerpoint/2010/main" val="3627196459"/>
+                <p14:modId xmlns:p14="http://schemas.microsoft.com/office/powerpoint/2010/main" val="3765866303"/>
               </p:ext>
             </p:extLst>
           </p:nvPr>
@@ -10415,7 +12320,7 @@
 </p:sld>
 </file>
 
-<file path=ppt/slides/slide11.xml><?xml version="1.0" encoding="utf-8"?>
+<file path=ppt/slides/slide14.xml><?xml version="1.0" encoding="utf-8"?>
 <p:sld xmlns:a="http://schemas.openxmlformats.org/drawingml/2006/main" xmlns:r="http://schemas.openxmlformats.org/officeDocument/2006/relationships" xmlns:p="http://schemas.openxmlformats.org/presentationml/2006/main">
   <p:cSld>
     <p:bg>
@@ -10804,7 +12709,7 @@
 </p:sld>
 </file>
 
-<file path=ppt/slides/slide12.xml><?xml version="1.0" encoding="utf-8"?>
+<file path=ppt/slides/slide15.xml><?xml version="1.0" encoding="utf-8"?>
 <p:sld xmlns:a="http://schemas.openxmlformats.org/drawingml/2006/main" xmlns:r="http://schemas.openxmlformats.org/officeDocument/2006/relationships" xmlns:p="http://schemas.openxmlformats.org/presentationml/2006/main">
   <p:cSld>
     <p:bg>
@@ -13644,6 +15549,657 @@
       </p:grpSpPr>
       <p:sp useBgFill="1">
         <p:nvSpPr>
+          <p:cNvPr id="10" name="Rectangle 9">
+            <a:extLst>
+              <a:ext uri="{FF2B5EF4-FFF2-40B4-BE49-F238E27FC236}">
+                <a16:creationId xmlns:a16="http://schemas.microsoft.com/office/drawing/2014/main" id="{A4E37431-20F0-4DD6-84A9-ED2B644943A2}"/>
+              </a:ext>
+              <a:ext uri="{C183D7F6-B498-43B3-948B-1728B52AA6E4}">
+                <adec:decorative xmlns:adec="http://schemas.microsoft.com/office/drawing/2017/decorative" val="1"/>
+              </a:ext>
+            </a:extLst>
+          </p:cNvPr>
+          <p:cNvSpPr>
+            <a:spLocks noGrp="1" noRot="1" noChangeAspect="1" noMove="1" noResize="1" noEditPoints="1" noAdjustHandles="1" noChangeArrowheads="1" noChangeShapeType="1" noTextEdit="1"/>
+          </p:cNvSpPr>
+          <p:nvPr>
+            <p:extLst>
+              <p:ext uri="{386F3935-93C4-4BCD-93E2-E3B085C9AB24}">
+                <p16:designElem xmlns:p16="http://schemas.microsoft.com/office/powerpoint/2015/main" val="1"/>
+              </p:ext>
+            </p:extLst>
+          </p:nvPr>
+        </p:nvSpPr>
+        <p:spPr>
+          <a:xfrm>
+            <a:off x="0" y="0"/>
+            <a:ext cx="12192000" cy="6858000"/>
+          </a:xfrm>
+          <a:prstGeom prst="rect">
+            <a:avLst/>
+          </a:prstGeom>
+          <a:ln w="12700" cap="flat" cmpd="sng" algn="ctr">
+            <a:noFill/>
+            <a:prstDash val="solid"/>
+            <a:miter lim="800000"/>
+          </a:ln>
+          <a:effectLst/>
+          <a:extLst>
+            <a:ext uri="{91240B29-F687-4F45-9708-019B960494DF}">
+              <a14:hiddenLine xmlns:a14="http://schemas.microsoft.com/office/drawing/2010/main" w="12700" cap="flat" cmpd="sng" algn="ctr">
+                <a:solidFill>
+                  <a:schemeClr val="accent1">
+                    <a:shade val="50000"/>
+                  </a:schemeClr>
+                </a:solidFill>
+                <a:prstDash val="solid"/>
+                <a:miter lim="800000"/>
+              </a14:hiddenLine>
+            </a:ext>
+          </a:extLst>
+        </p:spPr>
+        <p:style>
+          <a:lnRef idx="2">
+            <a:schemeClr val="accent1">
+              <a:shade val="50000"/>
+            </a:schemeClr>
+          </a:lnRef>
+          <a:fillRef idx="1">
+            <a:schemeClr val="accent1"/>
+          </a:fillRef>
+          <a:effectRef idx="0">
+            <a:schemeClr val="accent1"/>
+          </a:effectRef>
+          <a:fontRef idx="minor">
+            <a:schemeClr val="lt1"/>
+          </a:fontRef>
+        </p:style>
+        <p:txBody>
+          <a:bodyPr rtlCol="0" anchor="ctr"/>
+          <a:lstStyle/>
+          <a:p>
+            <a:pPr algn="ctr"/>
+            <a:endParaRPr lang="en-US"/>
+          </a:p>
+        </p:txBody>
+      </p:sp>
+      <p:sp>
+        <p:nvSpPr>
+          <p:cNvPr id="12" name="Rectangle 11">
+            <a:extLst>
+              <a:ext uri="{FF2B5EF4-FFF2-40B4-BE49-F238E27FC236}">
+                <a16:creationId xmlns:a16="http://schemas.microsoft.com/office/drawing/2014/main" id="{0AE98B72-66C6-4AB4-AF0D-BA830DE86393}"/>
+              </a:ext>
+              <a:ext uri="{C183D7F6-B498-43B3-948B-1728B52AA6E4}">
+                <adec:decorative xmlns:adec="http://schemas.microsoft.com/office/drawing/2017/decorative" val="1"/>
+              </a:ext>
+            </a:extLst>
+          </p:cNvPr>
+          <p:cNvSpPr>
+            <a:spLocks noGrp="1" noRot="1" noChangeAspect="1" noMove="1" noResize="1" noEditPoints="1" noAdjustHandles="1" noChangeArrowheads="1" noChangeShapeType="1" noTextEdit="1"/>
+          </p:cNvSpPr>
+          <p:nvPr>
+            <p:extLst>
+              <p:ext uri="{386F3935-93C4-4BCD-93E2-E3B085C9AB24}">
+                <p16:designElem xmlns:p16="http://schemas.microsoft.com/office/powerpoint/2015/main" val="1"/>
+              </p:ext>
+            </p:extLst>
+          </p:nvPr>
+        </p:nvSpPr>
+        <p:spPr>
+          <a:xfrm rot="5400000" flipH="1">
+            <a:off x="-638515" y="639280"/>
+            <a:ext cx="6858000" cy="5579440"/>
+          </a:xfrm>
+          <a:prstGeom prst="rect">
+            <a:avLst/>
+          </a:prstGeom>
+          <a:gradFill>
+            <a:gsLst>
+              <a:gs pos="8000">
+                <a:srgbClr val="000000"/>
+              </a:gs>
+              <a:gs pos="100000">
+                <a:schemeClr val="accent1">
+                  <a:lumMod val="75000"/>
+                </a:schemeClr>
+              </a:gs>
+            </a:gsLst>
+            <a:lin ang="3000000" scaled="0"/>
+          </a:gradFill>
+          <a:ln>
+            <a:noFill/>
+          </a:ln>
+        </p:spPr>
+        <p:style>
+          <a:lnRef idx="2">
+            <a:schemeClr val="accent1">
+              <a:shade val="50000"/>
+            </a:schemeClr>
+          </a:lnRef>
+          <a:fillRef idx="1">
+            <a:schemeClr val="accent1"/>
+          </a:fillRef>
+          <a:effectRef idx="0">
+            <a:schemeClr val="accent1"/>
+          </a:effectRef>
+          <a:fontRef idx="minor">
+            <a:schemeClr val="lt1"/>
+          </a:fontRef>
+        </p:style>
+        <p:txBody>
+          <a:bodyPr rtlCol="0" anchor="ctr"/>
+          <a:lstStyle/>
+          <a:p>
+            <a:pPr algn="ctr"/>
+            <a:endParaRPr lang="en-US"/>
+          </a:p>
+        </p:txBody>
+      </p:sp>
+      <p:sp>
+        <p:nvSpPr>
+          <p:cNvPr id="14" name="Rectangle 13">
+            <a:extLst>
+              <a:ext uri="{FF2B5EF4-FFF2-40B4-BE49-F238E27FC236}">
+                <a16:creationId xmlns:a16="http://schemas.microsoft.com/office/drawing/2014/main" id="{407EAFC6-733F-403D-BB4D-05A3A28742F1}"/>
+              </a:ext>
+              <a:ext uri="{C183D7F6-B498-43B3-948B-1728B52AA6E4}">
+                <adec:decorative xmlns:adec="http://schemas.microsoft.com/office/drawing/2017/decorative" val="1"/>
+              </a:ext>
+            </a:extLst>
+          </p:cNvPr>
+          <p:cNvSpPr>
+            <a:spLocks noGrp="1" noRot="1" noChangeAspect="1" noMove="1" noResize="1" noEditPoints="1" noAdjustHandles="1" noChangeArrowheads="1" noChangeShapeType="1" noTextEdit="1"/>
+          </p:cNvSpPr>
+          <p:nvPr>
+            <p:extLst>
+              <p:ext uri="{386F3935-93C4-4BCD-93E2-E3B085C9AB24}">
+                <p16:designElem xmlns:p16="http://schemas.microsoft.com/office/powerpoint/2015/main" val="1"/>
+              </p:ext>
+            </p:extLst>
+          </p:nvPr>
+        </p:nvSpPr>
+        <p:spPr>
+          <a:xfrm rot="5400000" flipH="1">
+            <a:off x="-393206" y="395206"/>
+            <a:ext cx="6346209" cy="5576080"/>
+          </a:xfrm>
+          <a:prstGeom prst="rect">
+            <a:avLst/>
+          </a:prstGeom>
+          <a:gradFill>
+            <a:gsLst>
+              <a:gs pos="0">
+                <a:srgbClr val="000000">
+                  <a:alpha val="0"/>
+                </a:srgbClr>
+              </a:gs>
+              <a:gs pos="99000">
+                <a:schemeClr val="accent1">
+                  <a:alpha val="0"/>
+                </a:schemeClr>
+              </a:gs>
+            </a:gsLst>
+            <a:lin ang="1800000" scaled="0"/>
+          </a:gradFill>
+          <a:ln>
+            <a:noFill/>
+          </a:ln>
+        </p:spPr>
+        <p:style>
+          <a:lnRef idx="2">
+            <a:schemeClr val="accent1">
+              <a:shade val="50000"/>
+            </a:schemeClr>
+          </a:lnRef>
+          <a:fillRef idx="1">
+            <a:schemeClr val="accent1"/>
+          </a:fillRef>
+          <a:effectRef idx="0">
+            <a:schemeClr val="accent1"/>
+          </a:effectRef>
+          <a:fontRef idx="minor">
+            <a:schemeClr val="lt1"/>
+          </a:fontRef>
+        </p:style>
+        <p:txBody>
+          <a:bodyPr rtlCol="0" anchor="ctr"/>
+          <a:lstStyle/>
+          <a:p>
+            <a:pPr algn="ctr"/>
+            <a:endParaRPr lang="en-US"/>
+          </a:p>
+        </p:txBody>
+      </p:sp>
+      <p:sp>
+        <p:nvSpPr>
+          <p:cNvPr id="16" name="Rectangle 15">
+            <a:extLst>
+              <a:ext uri="{FF2B5EF4-FFF2-40B4-BE49-F238E27FC236}">
+                <a16:creationId xmlns:a16="http://schemas.microsoft.com/office/drawing/2014/main" id="{17A36730-4CB0-4F61-AD11-A44C9765833F}"/>
+              </a:ext>
+              <a:ext uri="{C183D7F6-B498-43B3-948B-1728B52AA6E4}">
+                <adec:decorative xmlns:adec="http://schemas.microsoft.com/office/drawing/2017/decorative" val="1"/>
+              </a:ext>
+            </a:extLst>
+          </p:cNvPr>
+          <p:cNvSpPr>
+            <a:spLocks noGrp="1" noRot="1" noChangeAspect="1" noMove="1" noResize="1" noEditPoints="1" noAdjustHandles="1" noChangeArrowheads="1" noChangeShapeType="1" noTextEdit="1"/>
+          </p:cNvSpPr>
+          <p:nvPr>
+            <p:extLst>
+              <p:ext uri="{386F3935-93C4-4BCD-93E2-E3B085C9AB24}">
+                <p16:designElem xmlns:p16="http://schemas.microsoft.com/office/powerpoint/2015/main" val="1"/>
+              </p:ext>
+            </p:extLst>
+          </p:nvPr>
+        </p:nvSpPr>
+        <p:spPr>
+          <a:xfrm rot="5400000" flipH="1">
+            <a:off x="1528907" y="2818967"/>
+            <a:ext cx="2501979" cy="5576080"/>
+          </a:xfrm>
+          <a:prstGeom prst="rect">
+            <a:avLst/>
+          </a:prstGeom>
+          <a:gradFill>
+            <a:gsLst>
+              <a:gs pos="2000">
+                <a:schemeClr val="accent1">
+                  <a:alpha val="29000"/>
+                </a:schemeClr>
+              </a:gs>
+              <a:gs pos="100000">
+                <a:srgbClr val="000000">
+                  <a:alpha val="30000"/>
+                </a:srgbClr>
+              </a:gs>
+            </a:gsLst>
+            <a:lin ang="7800000" scaled="0"/>
+          </a:gradFill>
+          <a:ln>
+            <a:noFill/>
+          </a:ln>
+        </p:spPr>
+        <p:style>
+          <a:lnRef idx="2">
+            <a:schemeClr val="accent1">
+              <a:shade val="50000"/>
+            </a:schemeClr>
+          </a:lnRef>
+          <a:fillRef idx="1">
+            <a:schemeClr val="accent1"/>
+          </a:fillRef>
+          <a:effectRef idx="0">
+            <a:schemeClr val="accent1"/>
+          </a:effectRef>
+          <a:fontRef idx="minor">
+            <a:schemeClr val="lt1"/>
+          </a:fontRef>
+        </p:style>
+        <p:txBody>
+          <a:bodyPr rtlCol="0" anchor="ctr"/>
+          <a:lstStyle/>
+          <a:p>
+            <a:pPr algn="ctr"/>
+            <a:endParaRPr lang="en-US" dirty="0"/>
+          </a:p>
+        </p:txBody>
+      </p:sp>
+      <p:sp>
+        <p:nvSpPr>
+          <p:cNvPr id="18" name="Rectangle 17">
+            <a:extLst>
+              <a:ext uri="{FF2B5EF4-FFF2-40B4-BE49-F238E27FC236}">
+                <a16:creationId xmlns:a16="http://schemas.microsoft.com/office/drawing/2014/main" id="{C69C79E1-F916-4929-A4F3-DE763D4BFA57}"/>
+              </a:ext>
+              <a:ext uri="{C183D7F6-B498-43B3-948B-1728B52AA6E4}">
+                <adec:decorative xmlns:adec="http://schemas.microsoft.com/office/drawing/2017/decorative" val="1"/>
+              </a:ext>
+            </a:extLst>
+          </p:cNvPr>
+          <p:cNvSpPr>
+            <a:spLocks noGrp="1" noRot="1" noChangeAspect="1" noMove="1" noResize="1" noEditPoints="1" noAdjustHandles="1" noChangeArrowheads="1" noChangeShapeType="1" noTextEdit="1"/>
+          </p:cNvSpPr>
+          <p:nvPr>
+            <p:extLst>
+              <p:ext uri="{386F3935-93C4-4BCD-93E2-E3B085C9AB24}">
+                <p16:designElem xmlns:p16="http://schemas.microsoft.com/office/powerpoint/2015/main" val="1"/>
+              </p:ext>
+            </p:extLst>
+          </p:nvPr>
+        </p:nvSpPr>
+        <p:spPr>
+          <a:xfrm rot="5400000" flipH="1">
+            <a:off x="-425002" y="852793"/>
+            <a:ext cx="6858001" cy="5152412"/>
+          </a:xfrm>
+          <a:prstGeom prst="rect">
+            <a:avLst/>
+          </a:prstGeom>
+          <a:gradFill>
+            <a:gsLst>
+              <a:gs pos="0">
+                <a:srgbClr val="000000">
+                  <a:alpha val="0"/>
+                </a:srgbClr>
+              </a:gs>
+              <a:gs pos="99000">
+                <a:schemeClr val="accent1">
+                  <a:alpha val="11000"/>
+                </a:schemeClr>
+              </a:gs>
+            </a:gsLst>
+            <a:lin ang="7800000" scaled="0"/>
+          </a:gradFill>
+          <a:ln>
+            <a:noFill/>
+          </a:ln>
+        </p:spPr>
+        <p:style>
+          <a:lnRef idx="2">
+            <a:schemeClr val="accent1">
+              <a:shade val="50000"/>
+            </a:schemeClr>
+          </a:lnRef>
+          <a:fillRef idx="1">
+            <a:schemeClr val="accent1"/>
+          </a:fillRef>
+          <a:effectRef idx="0">
+            <a:schemeClr val="accent1"/>
+          </a:effectRef>
+          <a:fontRef idx="minor">
+            <a:schemeClr val="lt1"/>
+          </a:fontRef>
+        </p:style>
+        <p:txBody>
+          <a:bodyPr rtlCol="0" anchor="ctr"/>
+          <a:lstStyle/>
+          <a:p>
+            <a:pPr algn="ctr"/>
+            <a:endParaRPr lang="en-US"/>
+          </a:p>
+        </p:txBody>
+      </p:sp>
+      <p:sp>
+        <p:nvSpPr>
+          <p:cNvPr id="20" name="Oval 19">
+            <a:extLst>
+              <a:ext uri="{FF2B5EF4-FFF2-40B4-BE49-F238E27FC236}">
+                <a16:creationId xmlns:a16="http://schemas.microsoft.com/office/drawing/2014/main" id="{767334AB-16BD-4EC7-8C6B-4B5171600933}"/>
+              </a:ext>
+              <a:ext uri="{C183D7F6-B498-43B3-948B-1728B52AA6E4}">
+                <adec:decorative xmlns:adec="http://schemas.microsoft.com/office/drawing/2017/decorative" val="1"/>
+              </a:ext>
+            </a:extLst>
+          </p:cNvPr>
+          <p:cNvSpPr>
+            <a:spLocks noGrp="1" noRot="1" noChangeAspect="1" noMove="1" noResize="1" noEditPoints="1" noAdjustHandles="1" noChangeArrowheads="1" noChangeShapeType="1" noTextEdit="1"/>
+          </p:cNvSpPr>
+          <p:nvPr>
+            <p:extLst>
+              <p:ext uri="{386F3935-93C4-4BCD-93E2-E3B085C9AB24}">
+                <p16:designElem xmlns:p16="http://schemas.microsoft.com/office/powerpoint/2015/main" val="1"/>
+              </p:ext>
+            </p:extLst>
+          </p:nvPr>
+        </p:nvSpPr>
+        <p:spPr>
+          <a:xfrm rot="6097846">
+            <a:off x="818753" y="1128497"/>
+            <a:ext cx="4318303" cy="4318303"/>
+          </a:xfrm>
+          <a:prstGeom prst="ellipse">
+            <a:avLst/>
+          </a:prstGeom>
+          <a:gradFill>
+            <a:gsLst>
+              <a:gs pos="39000">
+                <a:schemeClr val="accent1">
+                  <a:alpha val="0"/>
+                </a:schemeClr>
+              </a:gs>
+              <a:gs pos="100000">
+                <a:schemeClr val="accent1">
+                  <a:lumMod val="60000"/>
+                  <a:lumOff val="40000"/>
+                  <a:alpha val="15000"/>
+                </a:schemeClr>
+              </a:gs>
+            </a:gsLst>
+            <a:lin ang="17400000" scaled="0"/>
+          </a:gradFill>
+          <a:ln>
+            <a:noFill/>
+          </a:ln>
+        </p:spPr>
+        <p:style>
+          <a:lnRef idx="2">
+            <a:schemeClr val="accent1">
+              <a:shade val="50000"/>
+            </a:schemeClr>
+          </a:lnRef>
+          <a:fillRef idx="1">
+            <a:schemeClr val="accent1"/>
+          </a:fillRef>
+          <a:effectRef idx="0">
+            <a:schemeClr val="accent1"/>
+          </a:effectRef>
+          <a:fontRef idx="minor">
+            <a:schemeClr val="lt1"/>
+          </a:fontRef>
+        </p:style>
+        <p:txBody>
+          <a:bodyPr rtlCol="0" anchor="ctr"/>
+          <a:lstStyle/>
+          <a:p>
+            <a:pPr algn="ctr"/>
+            <a:endParaRPr lang="en-US" dirty="0"/>
+          </a:p>
+        </p:txBody>
+      </p:sp>
+      <p:sp>
+        <p:nvSpPr>
+          <p:cNvPr id="2" name="Title 1">
+            <a:extLst>
+              <a:ext uri="{FF2B5EF4-FFF2-40B4-BE49-F238E27FC236}">
+                <a16:creationId xmlns:a16="http://schemas.microsoft.com/office/drawing/2014/main" id="{EA4FDA8B-9365-0E30-6EC1-F948B642620B}"/>
+              </a:ext>
+            </a:extLst>
+          </p:cNvPr>
+          <p:cNvSpPr>
+            <a:spLocks noGrp="1"/>
+          </p:cNvSpPr>
+          <p:nvPr>
+            <p:ph type="title"/>
+          </p:nvPr>
+        </p:nvSpPr>
+        <p:spPr>
+          <a:xfrm>
+            <a:off x="660042" y="891652"/>
+            <a:ext cx="4412021" cy="1718324"/>
+          </a:xfrm>
+        </p:spPr>
+        <p:txBody>
+          <a:bodyPr vert="horz" lIns="91440" tIns="45720" rIns="91440" bIns="45720" rtlCol="0" anchor="b">
+            <a:normAutofit/>
+          </a:bodyPr>
+          <a:lstStyle/>
+          <a:p>
+            <a:pPr algn="ctr"/>
+            <a:r>
+              <a:rPr lang="en-US" sz="4000" kern="1200" dirty="0">
+                <a:solidFill>
+                  <a:srgbClr val="FFFFFF"/>
+                </a:solidFill>
+                <a:latin typeface="+mj-lt"/>
+                <a:ea typeface="+mj-ea"/>
+                <a:cs typeface="+mj-cs"/>
+              </a:rPr>
+              <a:t>Additon of Email Field </a:t>
+            </a:r>
+          </a:p>
+        </p:txBody>
+      </p:sp>
+      <p:sp>
+        <p:nvSpPr>
+          <p:cNvPr id="3" name="Text Placeholder 2">
+            <a:extLst>
+              <a:ext uri="{FF2B5EF4-FFF2-40B4-BE49-F238E27FC236}">
+                <a16:creationId xmlns:a16="http://schemas.microsoft.com/office/drawing/2014/main" id="{ACEB9891-C788-8944-5568-FC81D66228D0}"/>
+              </a:ext>
+            </a:extLst>
+          </p:cNvPr>
+          <p:cNvSpPr>
+            <a:spLocks noGrp="1"/>
+          </p:cNvSpPr>
+          <p:nvPr>
+            <p:ph type="body" idx="1"/>
+          </p:nvPr>
+        </p:nvSpPr>
+        <p:spPr>
+          <a:xfrm>
+            <a:off x="727348" y="4552929"/>
+            <a:ext cx="4425991" cy="2077985"/>
+          </a:xfrm>
+        </p:spPr>
+        <p:txBody>
+          <a:bodyPr vert="horz" lIns="91440" tIns="45720" rIns="91440" bIns="45720" rtlCol="0">
+            <a:normAutofit/>
+          </a:bodyPr>
+          <a:lstStyle/>
+          <a:p>
+            <a:pPr marL="342900" indent="-342900">
+              <a:buFont typeface="Arial" panose="020B0604020202020204" pitchFamily="34" charset="0"/>
+              <a:buChar char="•"/>
+            </a:pPr>
+            <a:r>
+              <a:rPr lang="en-US" sz="2400" kern="1200" dirty="0">
+                <a:solidFill>
+                  <a:srgbClr val="FFFFFF"/>
+                </a:solidFill>
+                <a:latin typeface="+mn-lt"/>
+                <a:ea typeface="+mn-ea"/>
+                <a:cs typeface="+mn-cs"/>
+              </a:rPr>
+              <a:t>Stores properly in database</a:t>
+            </a:r>
+          </a:p>
+          <a:p>
+            <a:pPr marL="342900" indent="-342900">
+              <a:buFont typeface="Arial" panose="020B0604020202020204" pitchFamily="34" charset="0"/>
+              <a:buChar char="•"/>
+            </a:pPr>
+            <a:r>
+              <a:rPr lang="en-US" sz="2400" kern="1200" dirty="0">
+                <a:solidFill>
+                  <a:srgbClr val="FFFFFF"/>
+                </a:solidFill>
+                <a:latin typeface="+mn-lt"/>
+                <a:ea typeface="+mn-ea"/>
+                <a:cs typeface="+mn-cs"/>
+              </a:rPr>
+              <a:t>Ensures @pennwest.edu email</a:t>
+            </a:r>
+          </a:p>
+          <a:p>
+            <a:pPr marL="342900" indent="-342900">
+              <a:buFont typeface="Arial" panose="020B0604020202020204" pitchFamily="34" charset="0"/>
+              <a:buChar char="•"/>
+            </a:pPr>
+            <a:r>
+              <a:rPr lang="en-US" dirty="0">
+                <a:solidFill>
+                  <a:srgbClr val="FFFFFF"/>
+                </a:solidFill>
+              </a:rPr>
+              <a:t>Needs further development for password recovery</a:t>
+            </a:r>
+          </a:p>
+          <a:p>
+            <a:pPr algn="r"/>
+            <a:endParaRPr lang="en-US" sz="2400" kern="1200" dirty="0">
+              <a:solidFill>
+                <a:srgbClr val="FFFFFF"/>
+              </a:solidFill>
+              <a:latin typeface="+mn-lt"/>
+              <a:ea typeface="+mn-ea"/>
+              <a:cs typeface="+mn-cs"/>
+            </a:endParaRPr>
+          </a:p>
+        </p:txBody>
+      </p:sp>
+      <p:pic>
+        <p:nvPicPr>
+          <p:cNvPr id="5" name="Picture 4">
+            <a:extLst>
+              <a:ext uri="{FF2B5EF4-FFF2-40B4-BE49-F238E27FC236}">
+                <a16:creationId xmlns:a16="http://schemas.microsoft.com/office/drawing/2014/main" id="{04D50DDF-58B1-5FE3-AFCD-CFFF4E299495}"/>
+              </a:ext>
+            </a:extLst>
+          </p:cNvPr>
+          <p:cNvPicPr>
+            <a:picLocks noChangeAspect="1"/>
+          </p:cNvPicPr>
+          <p:nvPr/>
+        </p:nvPicPr>
+        <p:blipFill>
+          <a:blip r:embed="rId2"/>
+          <a:srcRect r="8654"/>
+          <a:stretch>
+            <a:fillRect/>
+          </a:stretch>
+        </p:blipFill>
+        <p:spPr>
+          <a:xfrm>
+            <a:off x="6376626" y="205820"/>
+            <a:ext cx="4886845" cy="6544147"/>
+          </a:xfrm>
+          <a:prstGeom prst="rect">
+            <a:avLst/>
+          </a:prstGeom>
+        </p:spPr>
+      </p:pic>
+    </p:spTree>
+    <p:extLst>
+      <p:ext uri="{BB962C8B-B14F-4D97-AF65-F5344CB8AC3E}">
+        <p14:creationId xmlns:p14="http://schemas.microsoft.com/office/powerpoint/2010/main" val="169300139"/>
+      </p:ext>
+    </p:extLst>
+  </p:cSld>
+  <p:clrMapOvr>
+    <a:masterClrMapping/>
+  </p:clrMapOvr>
+</p:sld>
+</file>
+
+<file path=ppt/slides/slide7.xml><?xml version="1.0" encoding="utf-8"?>
+<p:sld xmlns:a="http://schemas.openxmlformats.org/drawingml/2006/main" xmlns:r="http://schemas.openxmlformats.org/officeDocument/2006/relationships" xmlns:p="http://schemas.openxmlformats.org/presentationml/2006/main">
+  <p:cSld>
+    <p:bg>
+      <p:bgPr>
+        <a:solidFill>
+          <a:schemeClr val="bg1"/>
+        </a:solidFill>
+        <a:effectLst/>
+      </p:bgPr>
+    </p:bg>
+    <p:spTree>
+      <p:nvGrpSpPr>
+        <p:cNvPr id="1" name=""/>
+        <p:cNvGrpSpPr/>
+        <p:nvPr/>
+      </p:nvGrpSpPr>
+      <p:grpSpPr>
+        <a:xfrm>
+          <a:off x="0" y="0"/>
+          <a:ext cx="0" cy="0"/>
+          <a:chOff x="0" y="0"/>
+          <a:chExt cx="0" cy="0"/>
+        </a:xfrm>
+      </p:grpSpPr>
+      <p:sp useBgFill="1">
+        <p:nvSpPr>
           <p:cNvPr id="20" name="Rectangle 19">
             <a:extLst>
               <a:ext uri="{FF2B5EF4-FFF2-40B4-BE49-F238E27FC236}">
@@ -14185,7 +16741,7 @@
 </p:sld>
 </file>
 
-<file path=ppt/slides/slide7.xml><?xml version="1.0" encoding="utf-8"?>
+<file path=ppt/slides/slide8.xml><?xml version="1.0" encoding="utf-8"?>
 <p:sld xmlns:a="http://schemas.openxmlformats.org/drawingml/2006/main" xmlns:r="http://schemas.openxmlformats.org/officeDocument/2006/relationships" xmlns:p="http://schemas.openxmlformats.org/presentationml/2006/main">
   <p:cSld>
     <p:bg>
@@ -14577,8 +17133,8 @@
         </p:blipFill>
         <p:spPr>
           <a:xfrm>
-            <a:off x="1489030" y="1623025"/>
-            <a:ext cx="9451983" cy="4844143"/>
+            <a:off x="0" y="1574310"/>
+            <a:ext cx="12191998" cy="5213125"/>
           </a:xfrm>
           <a:prstGeom prst="rect">
             <a:avLst/>
@@ -14598,7 +17154,7 @@
 </p:sld>
 </file>
 
-<file path=ppt/slides/slide8.xml><?xml version="1.0" encoding="utf-8"?>
+<file path=ppt/slides/slide9.xml><?xml version="1.0" encoding="utf-8"?>
 <p:sld xmlns:a="http://schemas.openxmlformats.org/drawingml/2006/main" xmlns:r="http://schemas.openxmlformats.org/officeDocument/2006/relationships" xmlns:p="http://schemas.openxmlformats.org/presentationml/2006/main">
   <p:cSld>
     <p:bg>
@@ -14983,15 +17539,16 @@
           <p:nvPr/>
         </p:nvPicPr>
         <p:blipFill>
-          <a:blip r:embed="rId2"/>
+          <a:blip r:embed="rId3"/>
+          <a:srcRect l="-692" t="-1557" r="692" b="1557"/>
           <a:stretch>
             <a:fillRect/>
           </a:stretch>
         </p:blipFill>
         <p:spPr>
           <a:xfrm>
-            <a:off x="432225" y="2394124"/>
-            <a:ext cx="11327549" cy="3596497"/>
+            <a:off x="96889" y="1949914"/>
+            <a:ext cx="11851515" cy="3762856"/>
           </a:xfrm>
           <a:prstGeom prst="rect">
             <a:avLst/>
@@ -15002,420 +17559,6 @@
     <p:extLst>
       <p:ext uri="{BB962C8B-B14F-4D97-AF65-F5344CB8AC3E}">
         <p14:creationId xmlns:p14="http://schemas.microsoft.com/office/powerpoint/2010/main" val="884354200"/>
-      </p:ext>
-    </p:extLst>
-  </p:cSld>
-  <p:clrMapOvr>
-    <a:masterClrMapping/>
-  </p:clrMapOvr>
-</p:sld>
-</file>
-
-<file path=ppt/slides/slide9.xml><?xml version="1.0" encoding="utf-8"?>
-<p:sld xmlns:a="http://schemas.openxmlformats.org/drawingml/2006/main" xmlns:r="http://schemas.openxmlformats.org/officeDocument/2006/relationships" xmlns:p="http://schemas.openxmlformats.org/presentationml/2006/main">
-  <p:cSld>
-    <p:bg>
-      <p:bgPr>
-        <a:solidFill>
-          <a:schemeClr val="bg1"/>
-        </a:solidFill>
-        <a:effectLst/>
-      </p:bgPr>
-    </p:bg>
-    <p:spTree>
-      <p:nvGrpSpPr>
-        <p:cNvPr id="1" name=""/>
-        <p:cNvGrpSpPr/>
-        <p:nvPr/>
-      </p:nvGrpSpPr>
-      <p:grpSpPr>
-        <a:xfrm>
-          <a:off x="0" y="0"/>
-          <a:ext cx="0" cy="0"/>
-          <a:chOff x="0" y="0"/>
-          <a:chExt cx="0" cy="0"/>
-        </a:xfrm>
-      </p:grpSpPr>
-      <p:sp useBgFill="1">
-        <p:nvSpPr>
-          <p:cNvPr id="10" name="Rectangle 9">
-            <a:extLst>
-              <a:ext uri="{FF2B5EF4-FFF2-40B4-BE49-F238E27FC236}">
-                <a16:creationId xmlns:a16="http://schemas.microsoft.com/office/drawing/2014/main" id="{A8384FB5-9ADC-4DDC-881B-597D56F5B15D}"/>
-              </a:ext>
-              <a:ext uri="{C183D7F6-B498-43B3-948B-1728B52AA6E4}">
-                <adec:decorative xmlns:adec="http://schemas.microsoft.com/office/drawing/2017/decorative" val="1"/>
-              </a:ext>
-            </a:extLst>
-          </p:cNvPr>
-          <p:cNvSpPr>
-            <a:spLocks noGrp="1" noRot="1" noChangeAspect="1" noMove="1" noResize="1" noEditPoints="1" noAdjustHandles="1" noChangeArrowheads="1" noChangeShapeType="1" noTextEdit="1"/>
-          </p:cNvSpPr>
-          <p:nvPr>
-            <p:extLst>
-              <p:ext uri="{386F3935-93C4-4BCD-93E2-E3B085C9AB24}">
-                <p16:designElem xmlns:p16="http://schemas.microsoft.com/office/powerpoint/2015/main" val="1"/>
-              </p:ext>
-            </p:extLst>
-          </p:nvPr>
-        </p:nvSpPr>
-        <p:spPr>
-          <a:xfrm>
-            <a:off x="0" y="0"/>
-            <a:ext cx="12192000" cy="6858000"/>
-          </a:xfrm>
-          <a:prstGeom prst="rect">
-            <a:avLst/>
-          </a:prstGeom>
-          <a:ln w="12700" cap="flat" cmpd="sng" algn="ctr">
-            <a:noFill/>
-            <a:prstDash val="solid"/>
-            <a:miter lim="800000"/>
-          </a:ln>
-          <a:effectLst/>
-          <a:extLst>
-            <a:ext uri="{91240B29-F687-4F45-9708-019B960494DF}">
-              <a14:hiddenLine xmlns:a14="http://schemas.microsoft.com/office/drawing/2010/main" w="12700" cap="flat" cmpd="sng" algn="ctr">
-                <a:solidFill>
-                  <a:schemeClr val="accent1">
-                    <a:shade val="50000"/>
-                  </a:schemeClr>
-                </a:solidFill>
-                <a:prstDash val="solid"/>
-                <a:miter lim="800000"/>
-              </a14:hiddenLine>
-            </a:ext>
-          </a:extLst>
-        </p:spPr>
-        <p:style>
-          <a:lnRef idx="2">
-            <a:schemeClr val="accent1">
-              <a:shade val="50000"/>
-            </a:schemeClr>
-          </a:lnRef>
-          <a:fillRef idx="1">
-            <a:schemeClr val="accent1"/>
-          </a:fillRef>
-          <a:effectRef idx="0">
-            <a:schemeClr val="accent1"/>
-          </a:effectRef>
-          <a:fontRef idx="minor">
-            <a:schemeClr val="lt1"/>
-          </a:fontRef>
-        </p:style>
-        <p:txBody>
-          <a:bodyPr rtlCol="0" anchor="ctr"/>
-          <a:lstStyle/>
-          <a:p>
-            <a:pPr algn="ctr"/>
-            <a:endParaRPr lang="en-US"/>
-          </a:p>
-        </p:txBody>
-      </p:sp>
-      <p:sp>
-        <p:nvSpPr>
-          <p:cNvPr id="12" name="Rectangle 11">
-            <a:extLst>
-              <a:ext uri="{FF2B5EF4-FFF2-40B4-BE49-F238E27FC236}">
-                <a16:creationId xmlns:a16="http://schemas.microsoft.com/office/drawing/2014/main" id="{1199E1B1-A8C0-4FE8-A5A8-1CB41D69F857}"/>
-              </a:ext>
-              <a:ext uri="{C183D7F6-B498-43B3-948B-1728B52AA6E4}">
-                <adec:decorative xmlns:adec="http://schemas.microsoft.com/office/drawing/2017/decorative" val="1"/>
-              </a:ext>
-            </a:extLst>
-          </p:cNvPr>
-          <p:cNvSpPr>
-            <a:spLocks noGrp="1" noRot="1" noChangeAspect="1" noMove="1" noResize="1" noEditPoints="1" noAdjustHandles="1" noChangeArrowheads="1" noChangeShapeType="1" noTextEdit="1"/>
-          </p:cNvSpPr>
-          <p:nvPr>
-            <p:extLst>
-              <p:ext uri="{386F3935-93C4-4BCD-93E2-E3B085C9AB24}">
-                <p16:designElem xmlns:p16="http://schemas.microsoft.com/office/powerpoint/2015/main" val="1"/>
-              </p:ext>
-            </p:extLst>
-          </p:nvPr>
-        </p:nvSpPr>
-        <p:spPr>
-          <a:xfrm rot="10800000" flipH="1">
-            <a:off x="2" y="0"/>
-            <a:ext cx="12191998" cy="1575955"/>
-          </a:xfrm>
-          <a:prstGeom prst="rect">
-            <a:avLst/>
-          </a:prstGeom>
-          <a:gradFill>
-            <a:gsLst>
-              <a:gs pos="0">
-                <a:srgbClr val="000000">
-                  <a:alpha val="96000"/>
-                </a:srgbClr>
-              </a:gs>
-              <a:gs pos="100000">
-                <a:schemeClr val="accent1">
-                  <a:lumMod val="75000"/>
-                </a:schemeClr>
-              </a:gs>
-            </a:gsLst>
-            <a:lin ang="6000000" scaled="0"/>
-          </a:gradFill>
-          <a:ln>
-            <a:noFill/>
-          </a:ln>
-        </p:spPr>
-        <p:style>
-          <a:lnRef idx="2">
-            <a:schemeClr val="accent1">
-              <a:shade val="50000"/>
-            </a:schemeClr>
-          </a:lnRef>
-          <a:fillRef idx="1">
-            <a:schemeClr val="accent1"/>
-          </a:fillRef>
-          <a:effectRef idx="0">
-            <a:schemeClr val="accent1"/>
-          </a:effectRef>
-          <a:fontRef idx="minor">
-            <a:schemeClr val="lt1"/>
-          </a:fontRef>
-        </p:style>
-        <p:txBody>
-          <a:bodyPr rtlCol="0" anchor="ctr"/>
-          <a:lstStyle/>
-          <a:p>
-            <a:pPr algn="ctr"/>
-            <a:endParaRPr lang="en-US"/>
-          </a:p>
-        </p:txBody>
-      </p:sp>
-      <p:sp>
-        <p:nvSpPr>
-          <p:cNvPr id="14" name="Rectangle 13">
-            <a:extLst>
-              <a:ext uri="{FF2B5EF4-FFF2-40B4-BE49-F238E27FC236}">
-                <a16:creationId xmlns:a16="http://schemas.microsoft.com/office/drawing/2014/main" id="{84A8DE83-DE75-4B41-9DB4-A7EC0B0DEC0B}"/>
-              </a:ext>
-              <a:ext uri="{C183D7F6-B498-43B3-948B-1728B52AA6E4}">
-                <adec:decorative xmlns:adec="http://schemas.microsoft.com/office/drawing/2017/decorative" val="1"/>
-              </a:ext>
-            </a:extLst>
-          </p:cNvPr>
-          <p:cNvSpPr>
-            <a:spLocks noGrp="1" noRot="1" noChangeAspect="1" noMove="1" noResize="1" noEditPoints="1" noAdjustHandles="1" noChangeArrowheads="1" noChangeShapeType="1" noTextEdit="1"/>
-          </p:cNvSpPr>
-          <p:nvPr>
-            <p:extLst>
-              <p:ext uri="{386F3935-93C4-4BCD-93E2-E3B085C9AB24}">
-                <p16:designElem xmlns:p16="http://schemas.microsoft.com/office/powerpoint/2015/main" val="1"/>
-              </p:ext>
-            </p:extLst>
-          </p:nvPr>
-        </p:nvSpPr>
-        <p:spPr>
-          <a:xfrm>
-            <a:off x="0" y="0"/>
-            <a:ext cx="8128856" cy="1575461"/>
-          </a:xfrm>
-          <a:prstGeom prst="rect">
-            <a:avLst/>
-          </a:prstGeom>
-          <a:gradFill>
-            <a:gsLst>
-              <a:gs pos="0">
-                <a:schemeClr val="accent1">
-                  <a:alpha val="41000"/>
-                </a:schemeClr>
-              </a:gs>
-              <a:gs pos="74000">
-                <a:schemeClr val="accent1">
-                  <a:lumMod val="60000"/>
-                  <a:lumOff val="40000"/>
-                  <a:alpha val="0"/>
-                </a:schemeClr>
-              </a:gs>
-            </a:gsLst>
-            <a:lin ang="8400000" scaled="0"/>
-          </a:gradFill>
-          <a:ln>
-            <a:noFill/>
-          </a:ln>
-        </p:spPr>
-        <p:style>
-          <a:lnRef idx="2">
-            <a:schemeClr val="accent1">
-              <a:shade val="50000"/>
-            </a:schemeClr>
-          </a:lnRef>
-          <a:fillRef idx="1">
-            <a:schemeClr val="accent1"/>
-          </a:fillRef>
-          <a:effectRef idx="0">
-            <a:schemeClr val="accent1"/>
-          </a:effectRef>
-          <a:fontRef idx="minor">
-            <a:schemeClr val="lt1"/>
-          </a:fontRef>
-        </p:style>
-        <p:txBody>
-          <a:bodyPr rtlCol="0" anchor="ctr"/>
-          <a:lstStyle/>
-          <a:p>
-            <a:pPr algn="ctr"/>
-            <a:endParaRPr lang="en-US"/>
-          </a:p>
-        </p:txBody>
-      </p:sp>
-      <p:sp>
-        <p:nvSpPr>
-          <p:cNvPr id="16" name="Rectangle 15">
-            <a:extLst>
-              <a:ext uri="{FF2B5EF4-FFF2-40B4-BE49-F238E27FC236}">
-                <a16:creationId xmlns:a16="http://schemas.microsoft.com/office/drawing/2014/main" id="{A7009A0A-BEF5-4EAC-AF15-E4F9F002E239}"/>
-              </a:ext>
-              <a:ext uri="{C183D7F6-B498-43B3-948B-1728B52AA6E4}">
-                <adec:decorative xmlns:adec="http://schemas.microsoft.com/office/drawing/2017/decorative" val="1"/>
-              </a:ext>
-            </a:extLst>
-          </p:cNvPr>
-          <p:cNvSpPr>
-            <a:spLocks noGrp="1" noRot="1" noChangeAspect="1" noMove="1" noResize="1" noEditPoints="1" noAdjustHandles="1" noChangeArrowheads="1" noChangeShapeType="1" noTextEdit="1"/>
-          </p:cNvSpPr>
-          <p:nvPr>
-            <p:extLst>
-              <p:ext uri="{386F3935-93C4-4BCD-93E2-E3B085C9AB24}">
-                <p16:designElem xmlns:p16="http://schemas.microsoft.com/office/powerpoint/2015/main" val="1"/>
-              </p:ext>
-            </p:extLst>
-          </p:nvPr>
-        </p:nvSpPr>
-        <p:spPr>
-          <a:xfrm flipH="1">
-            <a:off x="-3" y="-1"/>
-            <a:ext cx="12192002" cy="1574311"/>
-          </a:xfrm>
-          <a:prstGeom prst="rect">
-            <a:avLst/>
-          </a:prstGeom>
-          <a:gradFill>
-            <a:gsLst>
-              <a:gs pos="0">
-                <a:srgbClr val="000000">
-                  <a:alpha val="63000"/>
-                </a:srgbClr>
-              </a:gs>
-              <a:gs pos="78000">
-                <a:schemeClr val="accent1">
-                  <a:alpha val="15000"/>
-                </a:schemeClr>
-              </a:gs>
-            </a:gsLst>
-            <a:lin ang="15600000" scaled="0"/>
-          </a:gradFill>
-          <a:ln>
-            <a:noFill/>
-          </a:ln>
-        </p:spPr>
-        <p:style>
-          <a:lnRef idx="2">
-            <a:schemeClr val="accent1">
-              <a:shade val="50000"/>
-            </a:schemeClr>
-          </a:lnRef>
-          <a:fillRef idx="1">
-            <a:schemeClr val="accent1"/>
-          </a:fillRef>
-          <a:effectRef idx="0">
-            <a:schemeClr val="accent1"/>
-          </a:effectRef>
-          <a:fontRef idx="minor">
-            <a:schemeClr val="lt1"/>
-          </a:fontRef>
-        </p:style>
-        <p:txBody>
-          <a:bodyPr rtlCol="0" anchor="ctr"/>
-          <a:lstStyle/>
-          <a:p>
-            <a:pPr algn="ctr"/>
-            <a:endParaRPr lang="en-US"/>
-          </a:p>
-        </p:txBody>
-      </p:sp>
-      <p:sp>
-        <p:nvSpPr>
-          <p:cNvPr id="2" name="Title 1">
-            <a:extLst>
-              <a:ext uri="{FF2B5EF4-FFF2-40B4-BE49-F238E27FC236}">
-                <a16:creationId xmlns:a16="http://schemas.microsoft.com/office/drawing/2014/main" id="{943F0D26-C404-6E35-D4F7-10155F5D3A98}"/>
-              </a:ext>
-            </a:extLst>
-          </p:cNvPr>
-          <p:cNvSpPr>
-            <a:spLocks noGrp="1"/>
-          </p:cNvSpPr>
-          <p:nvPr>
-            <p:ph type="title"/>
-          </p:nvPr>
-        </p:nvSpPr>
-        <p:spPr>
-          <a:xfrm>
-            <a:off x="699713" y="248038"/>
-            <a:ext cx="7063721" cy="1159200"/>
-          </a:xfrm>
-        </p:spPr>
-        <p:txBody>
-          <a:bodyPr vert="horz" lIns="91440" tIns="45720" rIns="91440" bIns="45720" rtlCol="0" anchor="ctr">
-            <a:normAutofit/>
-          </a:bodyPr>
-          <a:lstStyle/>
-          <a:p>
-            <a:r>
-              <a:rPr lang="en-US" sz="4000" kern="1200" dirty="0">
-                <a:solidFill>
-                  <a:srgbClr val="FFFFFF"/>
-                </a:solidFill>
-                <a:latin typeface="+mj-lt"/>
-                <a:ea typeface="+mj-ea"/>
-                <a:cs typeface="+mj-cs"/>
-              </a:rPr>
-              <a:t>Clubs and Likes</a:t>
-            </a:r>
-          </a:p>
-        </p:txBody>
-      </p:sp>
-      <p:pic>
-        <p:nvPicPr>
-          <p:cNvPr id="5" name="Picture 4">
-            <a:extLst>
-              <a:ext uri="{FF2B5EF4-FFF2-40B4-BE49-F238E27FC236}">
-                <a16:creationId xmlns:a16="http://schemas.microsoft.com/office/drawing/2014/main" id="{6C01547A-003F-2DA0-1CB8-4E92D18977A2}"/>
-              </a:ext>
-            </a:extLst>
-          </p:cNvPr>
-          <p:cNvPicPr>
-            <a:picLocks noChangeAspect="1"/>
-          </p:cNvPicPr>
-          <p:nvPr/>
-        </p:nvPicPr>
-        <p:blipFill>
-          <a:blip r:embed="rId2"/>
-          <a:srcRect b="2997"/>
-          <a:stretch>
-            <a:fillRect/>
-          </a:stretch>
-        </p:blipFill>
-        <p:spPr>
-          <a:xfrm>
-            <a:off x="1643839" y="1966293"/>
-            <a:ext cx="8904320" cy="4452160"/>
-          </a:xfrm>
-          <a:prstGeom prst="rect">
-            <a:avLst/>
-          </a:prstGeom>
-        </p:spPr>
-      </p:pic>
-    </p:spTree>
-    <p:extLst>
-      <p:ext uri="{BB962C8B-B14F-4D97-AF65-F5344CB8AC3E}">
-        <p14:creationId xmlns:p14="http://schemas.microsoft.com/office/powerpoint/2010/main" val="3857486133"/>
       </p:ext>
     </p:extLst>
   </p:cSld>
@@ -15738,4 +17881,319 @@
     </a:ext>
   </a:extLst>
 </a:theme>
+</file>
+
+<file path=ppt/theme/theme2.xml><?xml version="1.0" encoding="utf-8"?>
+<a:theme xmlns:a="http://schemas.openxmlformats.org/drawingml/2006/main" name="Office Theme">
+  <a:themeElements>
+    <a:clrScheme name="Office">
+      <a:dk1>
+        <a:sysClr val="windowText" lastClr="000000"/>
+      </a:dk1>
+      <a:lt1>
+        <a:sysClr val="window" lastClr="FFFFFF"/>
+      </a:lt1>
+      <a:dk2>
+        <a:srgbClr val="0E2841"/>
+      </a:dk2>
+      <a:lt2>
+        <a:srgbClr val="E8E8E8"/>
+      </a:lt2>
+      <a:accent1>
+        <a:srgbClr val="156082"/>
+      </a:accent1>
+      <a:accent2>
+        <a:srgbClr val="E97132"/>
+      </a:accent2>
+      <a:accent3>
+        <a:srgbClr val="196B24"/>
+      </a:accent3>
+      <a:accent4>
+        <a:srgbClr val="0F9ED5"/>
+      </a:accent4>
+      <a:accent5>
+        <a:srgbClr val="A02B93"/>
+      </a:accent5>
+      <a:accent6>
+        <a:srgbClr val="4EA72E"/>
+      </a:accent6>
+      <a:hlink>
+        <a:srgbClr val="467886"/>
+      </a:hlink>
+      <a:folHlink>
+        <a:srgbClr val="96607D"/>
+      </a:folHlink>
+    </a:clrScheme>
+    <a:fontScheme name="Office">
+      <a:majorFont>
+        <a:latin typeface="Aptos Display" panose="02110004020202020204"/>
+        <a:ea typeface=""/>
+        <a:cs typeface=""/>
+        <a:font script="Jpan" typeface="游ゴシック Light"/>
+        <a:font script="Hang" typeface="맑은 고딕"/>
+        <a:font script="Hans" typeface="等线 Light"/>
+        <a:font script="Hant" typeface="新細明體"/>
+        <a:font script="Arab" typeface="Times New Roman"/>
+        <a:font script="Hebr" typeface="Times New Roman"/>
+        <a:font script="Thai" typeface="Angsana New"/>
+        <a:font script="Ethi" typeface="Nyala"/>
+        <a:font script="Beng" typeface="Vrinda"/>
+        <a:font script="Gujr" typeface="Shruti"/>
+        <a:font script="Khmr" typeface="MoolBoran"/>
+        <a:font script="Knda" typeface="Tunga"/>
+        <a:font script="Guru" typeface="Raavi"/>
+        <a:font script="Cans" typeface="Euphemia"/>
+        <a:font script="Cher" typeface="Plantagenet Cherokee"/>
+        <a:font script="Yiii" typeface="Microsoft Yi Baiti"/>
+        <a:font script="Tibt" typeface="Microsoft Himalaya"/>
+        <a:font script="Thaa" typeface="MV Boli"/>
+        <a:font script="Deva" typeface="Mangal"/>
+        <a:font script="Telu" typeface="Gautami"/>
+        <a:font script="Taml" typeface="Latha"/>
+        <a:font script="Syrc" typeface="Estrangelo Edessa"/>
+        <a:font script="Orya" typeface="Kalinga"/>
+        <a:font script="Mlym" typeface="Kartika"/>
+        <a:font script="Laoo" typeface="DokChampa"/>
+        <a:font script="Sinh" typeface="Iskoola Pota"/>
+        <a:font script="Mong" typeface="Mongolian Baiti"/>
+        <a:font script="Viet" typeface="Times New Roman"/>
+        <a:font script="Uigh" typeface="Microsoft Uighur"/>
+        <a:font script="Geor" typeface="Sylfaen"/>
+        <a:font script="Armn" typeface="Arial"/>
+        <a:font script="Bugi" typeface="Leelawadee UI"/>
+        <a:font script="Bopo" typeface="Microsoft JhengHei"/>
+        <a:font script="Java" typeface="Javanese Text"/>
+        <a:font script="Lisu" typeface="Segoe UI"/>
+        <a:font script="Mymr" typeface="Myanmar Text"/>
+        <a:font script="Nkoo" typeface="Ebrima"/>
+        <a:font script="Olck" typeface="Nirmala UI"/>
+        <a:font script="Osma" typeface="Ebrima"/>
+        <a:font script="Phag" typeface="Phagspa"/>
+        <a:font script="Syrn" typeface="Estrangelo Edessa"/>
+        <a:font script="Syrj" typeface="Estrangelo Edessa"/>
+        <a:font script="Syre" typeface="Estrangelo Edessa"/>
+        <a:font script="Sora" typeface="Nirmala UI"/>
+        <a:font script="Tale" typeface="Microsoft Tai Le"/>
+        <a:font script="Talu" typeface="Microsoft New Tai Lue"/>
+        <a:font script="Tfng" typeface="Ebrima"/>
+      </a:majorFont>
+      <a:minorFont>
+        <a:latin typeface="Aptos" panose="02110004020202020204"/>
+        <a:ea typeface=""/>
+        <a:cs typeface=""/>
+        <a:font script="Jpan" typeface="游ゴシック"/>
+        <a:font script="Hang" typeface="맑은 고딕"/>
+        <a:font script="Hans" typeface="等线"/>
+        <a:font script="Hant" typeface="新細明體"/>
+        <a:font script="Arab" typeface="Arial"/>
+        <a:font script="Hebr" typeface="Arial"/>
+        <a:font script="Thai" typeface="Cordia New"/>
+        <a:font script="Ethi" typeface="Nyala"/>
+        <a:font script="Beng" typeface="Vrinda"/>
+        <a:font script="Gujr" typeface="Shruti"/>
+        <a:font script="Khmr" typeface="DaunPenh"/>
+        <a:font script="Knda" typeface="Tunga"/>
+        <a:font script="Guru" typeface="Raavi"/>
+        <a:font script="Cans" typeface="Euphemia"/>
+        <a:font script="Cher" typeface="Plantagenet Cherokee"/>
+        <a:font script="Yiii" typeface="Microsoft Yi Baiti"/>
+        <a:font script="Tibt" typeface="Microsoft Himalaya"/>
+        <a:font script="Thaa" typeface="MV Boli"/>
+        <a:font script="Deva" typeface="Mangal"/>
+        <a:font script="Telu" typeface="Gautami"/>
+        <a:font script="Taml" typeface="Latha"/>
+        <a:font script="Syrc" typeface="Estrangelo Edessa"/>
+        <a:font script="Orya" typeface="Kalinga"/>
+        <a:font script="Mlym" typeface="Kartika"/>
+        <a:font script="Laoo" typeface="DokChampa"/>
+        <a:font script="Sinh" typeface="Iskoola Pota"/>
+        <a:font script="Mong" typeface="Mongolian Baiti"/>
+        <a:font script="Viet" typeface="Arial"/>
+        <a:font script="Uigh" typeface="Microsoft Uighur"/>
+        <a:font script="Geor" typeface="Sylfaen"/>
+        <a:font script="Armn" typeface="Arial"/>
+        <a:font script="Bugi" typeface="Leelawadee UI"/>
+        <a:font script="Bopo" typeface="Microsoft JhengHei"/>
+        <a:font script="Java" typeface="Javanese Text"/>
+        <a:font script="Lisu" typeface="Segoe UI"/>
+        <a:font script="Mymr" typeface="Myanmar Text"/>
+        <a:font script="Nkoo" typeface="Ebrima"/>
+        <a:font script="Olck" typeface="Nirmala UI"/>
+        <a:font script="Osma" typeface="Ebrima"/>
+        <a:font script="Phag" typeface="Phagspa"/>
+        <a:font script="Syrn" typeface="Estrangelo Edessa"/>
+        <a:font script="Syrj" typeface="Estrangelo Edessa"/>
+        <a:font script="Syre" typeface="Estrangelo Edessa"/>
+        <a:font script="Sora" typeface="Nirmala UI"/>
+        <a:font script="Tale" typeface="Microsoft Tai Le"/>
+        <a:font script="Talu" typeface="Microsoft New Tai Lue"/>
+        <a:font script="Tfng" typeface="Ebrima"/>
+      </a:minorFont>
+    </a:fontScheme>
+    <a:fmtScheme name="Office">
+      <a:fillStyleLst>
+        <a:solidFill>
+          <a:schemeClr val="phClr"/>
+        </a:solidFill>
+        <a:gradFill rotWithShape="1">
+          <a:gsLst>
+            <a:gs pos="0">
+              <a:schemeClr val="phClr">
+                <a:lumMod val="110000"/>
+                <a:satMod val="105000"/>
+                <a:tint val="67000"/>
+              </a:schemeClr>
+            </a:gs>
+            <a:gs pos="50000">
+              <a:schemeClr val="phClr">
+                <a:lumMod val="105000"/>
+                <a:satMod val="103000"/>
+                <a:tint val="73000"/>
+              </a:schemeClr>
+            </a:gs>
+            <a:gs pos="100000">
+              <a:schemeClr val="phClr">
+                <a:lumMod val="105000"/>
+                <a:satMod val="109000"/>
+                <a:tint val="81000"/>
+              </a:schemeClr>
+            </a:gs>
+          </a:gsLst>
+          <a:lin ang="5400000" scaled="0"/>
+        </a:gradFill>
+        <a:gradFill rotWithShape="1">
+          <a:gsLst>
+            <a:gs pos="0">
+              <a:schemeClr val="phClr">
+                <a:satMod val="103000"/>
+                <a:lumMod val="102000"/>
+                <a:tint val="94000"/>
+              </a:schemeClr>
+            </a:gs>
+            <a:gs pos="50000">
+              <a:schemeClr val="phClr">
+                <a:satMod val="110000"/>
+                <a:lumMod val="100000"/>
+                <a:shade val="100000"/>
+              </a:schemeClr>
+            </a:gs>
+            <a:gs pos="100000">
+              <a:schemeClr val="phClr">
+                <a:lumMod val="99000"/>
+                <a:satMod val="120000"/>
+                <a:shade val="78000"/>
+              </a:schemeClr>
+            </a:gs>
+          </a:gsLst>
+          <a:lin ang="5400000" scaled="0"/>
+        </a:gradFill>
+      </a:fillStyleLst>
+      <a:lnStyleLst>
+        <a:ln w="12700" cap="flat" cmpd="sng" algn="ctr">
+          <a:solidFill>
+            <a:schemeClr val="phClr"/>
+          </a:solidFill>
+          <a:prstDash val="solid"/>
+          <a:miter lim="800000"/>
+        </a:ln>
+        <a:ln w="19050" cap="flat" cmpd="sng" algn="ctr">
+          <a:solidFill>
+            <a:schemeClr val="phClr"/>
+          </a:solidFill>
+          <a:prstDash val="solid"/>
+          <a:miter lim="800000"/>
+        </a:ln>
+        <a:ln w="25400" cap="flat" cmpd="sng" algn="ctr">
+          <a:solidFill>
+            <a:schemeClr val="phClr"/>
+          </a:solidFill>
+          <a:prstDash val="solid"/>
+          <a:miter lim="800000"/>
+        </a:ln>
+      </a:lnStyleLst>
+      <a:effectStyleLst>
+        <a:effectStyle>
+          <a:effectLst/>
+        </a:effectStyle>
+        <a:effectStyle>
+          <a:effectLst/>
+        </a:effectStyle>
+        <a:effectStyle>
+          <a:effectLst>
+            <a:outerShdw blurRad="57150" dist="19050" dir="5400000" algn="ctr" rotWithShape="0">
+              <a:srgbClr val="000000">
+                <a:alpha val="63000"/>
+              </a:srgbClr>
+            </a:outerShdw>
+          </a:effectLst>
+        </a:effectStyle>
+      </a:effectStyleLst>
+      <a:bgFillStyleLst>
+        <a:solidFill>
+          <a:schemeClr val="phClr"/>
+        </a:solidFill>
+        <a:solidFill>
+          <a:schemeClr val="phClr">
+            <a:tint val="95000"/>
+            <a:satMod val="170000"/>
+          </a:schemeClr>
+        </a:solidFill>
+        <a:gradFill rotWithShape="1">
+          <a:gsLst>
+            <a:gs pos="0">
+              <a:schemeClr val="phClr">
+                <a:tint val="93000"/>
+                <a:satMod val="150000"/>
+                <a:shade val="98000"/>
+                <a:lumMod val="102000"/>
+              </a:schemeClr>
+            </a:gs>
+            <a:gs pos="50000">
+              <a:schemeClr val="phClr">
+                <a:tint val="98000"/>
+                <a:satMod val="130000"/>
+                <a:shade val="90000"/>
+                <a:lumMod val="103000"/>
+              </a:schemeClr>
+            </a:gs>
+            <a:gs pos="100000">
+              <a:schemeClr val="phClr">
+                <a:shade val="63000"/>
+                <a:satMod val="120000"/>
+              </a:schemeClr>
+            </a:gs>
+          </a:gsLst>
+          <a:lin ang="5400000" scaled="0"/>
+        </a:gradFill>
+      </a:bgFillStyleLst>
+    </a:fmtScheme>
+  </a:themeElements>
+  <a:objectDefaults>
+    <a:lnDef>
+      <a:spPr/>
+      <a:bodyPr/>
+      <a:lstStyle/>
+      <a:style>
+        <a:lnRef idx="2">
+          <a:schemeClr val="accent1"/>
+        </a:lnRef>
+        <a:fillRef idx="0">
+          <a:schemeClr val="accent1"/>
+        </a:fillRef>
+        <a:effectRef idx="1">
+          <a:schemeClr val="accent1"/>
+        </a:effectRef>
+        <a:fontRef idx="minor">
+          <a:schemeClr val="tx1"/>
+        </a:fontRef>
+      </a:style>
+    </a:lnDef>
+  </a:objectDefaults>
+  <a:extraClrSchemeLst/>
+  <a:extLst>
+    <a:ext uri="{05A4C25C-085E-4340-85A3-A5531E510DB2}">
+      <thm15:themeFamily xmlns:thm15="http://schemas.microsoft.com/office/thememl/2012/main" name="Office Theme" id="{2E142A2C-CD16-42D6-873A-C26D2A0506FA}" vid="{1BDDFF52-6CD6-40A5-AB3C-68EB2F1E4D0A}"/>
+    </a:ext>
+  </a:extLst>
+</a:theme>
 </file>
</xml_diff>

<commit_message>
added challenges stuff to the report but need to merge my pr to get pictures of challenges in slides
</commit_message>
<xml_diff>
--- a/Documentation/Weekly Report/week6/CMSC-4920-Group2-Week6.pptx
+++ b/Documentation/Weekly Report/week6/CMSC-4920-Group2-Week6.pptx
@@ -139,30 +139,6 @@
 
 <file path=ppt/changesInfos/changesInfo1.xml><?xml version="1.0" encoding="utf-8"?>
 <pc:chgInfo xmlns:a="http://schemas.openxmlformats.org/drawingml/2006/main" xmlns:r="http://schemas.openxmlformats.org/officeDocument/2006/relationships" xmlns:ac="http://schemas.microsoft.com/office/drawing/2013/main/command" xmlns:pc="http://schemas.microsoft.com/office/powerpoint/2013/main/command">
-  <pc:docChgLst>
-    <pc:chgData name="John Gerega" userId="bd3e1e46fb6a714b" providerId="LiveId" clId="{45F0C402-C550-4C82-B31D-5B32217A5E94}"/>
-    <pc:docChg chg="modSld">
-      <pc:chgData name="John Gerega" userId="bd3e1e46fb6a714b" providerId="LiveId" clId="{45F0C402-C550-4C82-B31D-5B32217A5E94}" dt="2026-02-17T12:42:35.112" v="95" actId="20577"/>
-      <pc:docMkLst>
-        <pc:docMk/>
-      </pc:docMkLst>
-      <pc:sldChg chg="modSp mod">
-        <pc:chgData name="John Gerega" userId="bd3e1e46fb6a714b" providerId="LiveId" clId="{45F0C402-C550-4C82-B31D-5B32217A5E94}" dt="2026-02-17T12:42:35.112" v="95" actId="20577"/>
-        <pc:sldMkLst>
-          <pc:docMk/>
-          <pc:sldMk cId="2428741132" sldId="265"/>
-        </pc:sldMkLst>
-        <pc:spChg chg="mod">
-          <ac:chgData name="John Gerega" userId="bd3e1e46fb6a714b" providerId="LiveId" clId="{45F0C402-C550-4C82-B31D-5B32217A5E94}" dt="2026-02-17T12:42:35.112" v="95" actId="20577"/>
-          <ac:spMkLst>
-            <pc:docMk/>
-            <pc:sldMk cId="2428741132" sldId="265"/>
-            <ac:spMk id="8" creationId="{7A067979-B2B3-BD33-28AB-42AF2BBE1977}"/>
-          </ac:spMkLst>
-        </pc:spChg>
-      </pc:sldChg>
-    </pc:docChg>
-  </pc:docChgLst>
   <pc:docChgLst>
     <pc:chgData name="Margo Bonal" userId="18c9fa0f-b53d-478b-9dc0-6ad88786c19f" providerId="ADAL" clId="{93D479E5-F67F-4B8A-A78F-A0B574A116B6}"/>
     <pc:docChg chg="undo custSel addSld modSld">
@@ -915,6 +891,30 @@
           <pc:docMk/>
           <pc:sldMk cId="3713997872" sldId="259"/>
         </pc:sldMkLst>
+      </pc:sldChg>
+    </pc:docChg>
+  </pc:docChgLst>
+  <pc:docChgLst>
+    <pc:chgData name="John Gerega" userId="bd3e1e46fb6a714b" providerId="LiveId" clId="{45F0C402-C550-4C82-B31D-5B32217A5E94}"/>
+    <pc:docChg chg="modSld">
+      <pc:chgData name="John Gerega" userId="bd3e1e46fb6a714b" providerId="LiveId" clId="{45F0C402-C550-4C82-B31D-5B32217A5E94}" dt="2026-02-17T12:42:35.112" v="95" actId="20577"/>
+      <pc:docMkLst>
+        <pc:docMk/>
+      </pc:docMkLst>
+      <pc:sldChg chg="modSp mod">
+        <pc:chgData name="John Gerega" userId="bd3e1e46fb6a714b" providerId="LiveId" clId="{45F0C402-C550-4C82-B31D-5B32217A5E94}" dt="2026-02-17T12:42:35.112" v="95" actId="20577"/>
+        <pc:sldMkLst>
+          <pc:docMk/>
+          <pc:sldMk cId="2428741132" sldId="265"/>
+        </pc:sldMkLst>
+        <pc:spChg chg="mod">
+          <ac:chgData name="John Gerega" userId="bd3e1e46fb6a714b" providerId="LiveId" clId="{45F0C402-C550-4C82-B31D-5B32217A5E94}" dt="2026-02-17T12:42:35.112" v="95" actId="20577"/>
+          <ac:spMkLst>
+            <pc:docMk/>
+            <pc:sldMk cId="2428741132" sldId="265"/>
+            <ac:spMk id="8" creationId="{7A067979-B2B3-BD33-28AB-42AF2BBE1977}"/>
+          </ac:spMkLst>
+        </pc:spChg>
       </pc:sldChg>
     </pc:docChg>
   </pc:docChgLst>

</xml_diff>

<commit_message>
added challenges page to slides
</commit_message>
<xml_diff>
--- a/Documentation/Weekly Report/week6/CMSC-4920-Group2-Week6.pptx
+++ b/Documentation/Weekly Report/week6/CMSC-4920-Group2-Week6.pptx
@@ -5,7 +5,7 @@
     <p:sldMasterId id="2147483648" r:id="rId1"/>
   </p:sldMasterIdLst>
   <p:notesMasterIdLst>
-    <p:notesMasterId r:id="rId17"/>
+    <p:notesMasterId r:id="rId18"/>
   </p:notesMasterIdLst>
   <p:sldIdLst>
     <p:sldId id="256" r:id="rId2"/>
@@ -20,9 +20,10 @@
     <p:sldId id="270" r:id="rId11"/>
     <p:sldId id="272" r:id="rId12"/>
     <p:sldId id="273" r:id="rId13"/>
-    <p:sldId id="264" r:id="rId14"/>
-    <p:sldId id="259" r:id="rId15"/>
-    <p:sldId id="260" r:id="rId16"/>
+    <p:sldId id="274" r:id="rId14"/>
+    <p:sldId id="264" r:id="rId15"/>
+    <p:sldId id="259" r:id="rId16"/>
+    <p:sldId id="260" r:id="rId17"/>
   </p:sldIdLst>
   <p:sldSz cx="12192000" cy="6858000"/>
   <p:notesSz cx="6858000" cy="9144000"/>
@@ -11986,6 +11987,425 @@
         <p:cNvPr id="1" name="">
           <a:extLst>
             <a:ext uri="{FF2B5EF4-FFF2-40B4-BE49-F238E27FC236}">
+              <a16:creationId xmlns:a16="http://schemas.microsoft.com/office/drawing/2014/main" id="{76B16E27-F8DE-4890-5E82-8F53BF2DEAC7}"/>
+            </a:ext>
+          </a:extLst>
+        </p:cNvPr>
+        <p:cNvGrpSpPr/>
+        <p:nvPr/>
+      </p:nvGrpSpPr>
+      <p:grpSpPr>
+        <a:xfrm>
+          <a:off x="0" y="0"/>
+          <a:ext cx="0" cy="0"/>
+          <a:chOff x="0" y="0"/>
+          <a:chExt cx="0" cy="0"/>
+        </a:xfrm>
+      </p:grpSpPr>
+      <p:sp useBgFill="1">
+        <p:nvSpPr>
+          <p:cNvPr id="22" name="Rectangle 21">
+            <a:extLst>
+              <a:ext uri="{FF2B5EF4-FFF2-40B4-BE49-F238E27FC236}">
+                <a16:creationId xmlns:a16="http://schemas.microsoft.com/office/drawing/2014/main" id="{D12ABA1B-63B4-AFF3-EDE0-4F5F35F89A80}"/>
+              </a:ext>
+              <a:ext uri="{C183D7F6-B498-43B3-948B-1728B52AA6E4}">
+                <adec:decorative xmlns:adec="http://schemas.microsoft.com/office/drawing/2017/decorative" val="1"/>
+              </a:ext>
+            </a:extLst>
+          </p:cNvPr>
+          <p:cNvSpPr>
+            <a:spLocks noGrp="1" noRot="1" noChangeAspect="1" noMove="1" noResize="1" noEditPoints="1" noAdjustHandles="1" noChangeArrowheads="1" noChangeShapeType="1" noTextEdit="1"/>
+          </p:cNvSpPr>
+          <p:nvPr>
+            <p:extLst>
+              <p:ext uri="{386F3935-93C4-4BCD-93E2-E3B085C9AB24}">
+                <p16:designElem xmlns:p16="http://schemas.microsoft.com/office/powerpoint/2015/main" val="1"/>
+              </p:ext>
+            </p:extLst>
+          </p:nvPr>
+        </p:nvSpPr>
+        <p:spPr>
+          <a:xfrm>
+            <a:off x="0" y="0"/>
+            <a:ext cx="12192000" cy="6858000"/>
+          </a:xfrm>
+          <a:prstGeom prst="rect">
+            <a:avLst/>
+          </a:prstGeom>
+          <a:ln w="12700" cap="flat" cmpd="sng" algn="ctr">
+            <a:noFill/>
+            <a:prstDash val="solid"/>
+            <a:miter lim="800000"/>
+          </a:ln>
+          <a:effectLst/>
+          <a:extLst>
+            <a:ext uri="{91240B29-F687-4F45-9708-019B960494DF}">
+              <a14:hiddenLine xmlns:a14="http://schemas.microsoft.com/office/drawing/2010/main" w="12700" cap="flat" cmpd="sng" algn="ctr">
+                <a:solidFill>
+                  <a:schemeClr val="accent1">
+                    <a:shade val="50000"/>
+                  </a:schemeClr>
+                </a:solidFill>
+                <a:prstDash val="solid"/>
+                <a:miter lim="800000"/>
+              </a14:hiddenLine>
+            </a:ext>
+          </a:extLst>
+        </p:spPr>
+        <p:style>
+          <a:lnRef idx="2">
+            <a:schemeClr val="accent1">
+              <a:shade val="50000"/>
+            </a:schemeClr>
+          </a:lnRef>
+          <a:fillRef idx="1">
+            <a:schemeClr val="accent1"/>
+          </a:fillRef>
+          <a:effectRef idx="0">
+            <a:schemeClr val="accent1"/>
+          </a:effectRef>
+          <a:fontRef idx="minor">
+            <a:schemeClr val="lt1"/>
+          </a:fontRef>
+        </p:style>
+        <p:txBody>
+          <a:bodyPr rtlCol="0" anchor="ctr"/>
+          <a:lstStyle/>
+          <a:p>
+            <a:pPr algn="ctr"/>
+            <a:endParaRPr lang="en-US"/>
+          </a:p>
+        </p:txBody>
+      </p:sp>
+      <p:sp>
+        <p:nvSpPr>
+          <p:cNvPr id="24" name="Rectangle 23">
+            <a:extLst>
+              <a:ext uri="{FF2B5EF4-FFF2-40B4-BE49-F238E27FC236}">
+                <a16:creationId xmlns:a16="http://schemas.microsoft.com/office/drawing/2014/main" id="{4A7C6E87-D77B-6467-A8EB-31B904E563F6}"/>
+              </a:ext>
+              <a:ext uri="{C183D7F6-B498-43B3-948B-1728B52AA6E4}">
+                <adec:decorative xmlns:adec="http://schemas.microsoft.com/office/drawing/2017/decorative" val="1"/>
+              </a:ext>
+            </a:extLst>
+          </p:cNvPr>
+          <p:cNvSpPr>
+            <a:spLocks noGrp="1" noRot="1" noChangeAspect="1" noMove="1" noResize="1" noEditPoints="1" noAdjustHandles="1" noChangeArrowheads="1" noChangeShapeType="1" noTextEdit="1"/>
+          </p:cNvSpPr>
+          <p:nvPr>
+            <p:extLst>
+              <p:ext uri="{386F3935-93C4-4BCD-93E2-E3B085C9AB24}">
+                <p16:designElem xmlns:p16="http://schemas.microsoft.com/office/powerpoint/2015/main" val="1"/>
+              </p:ext>
+            </p:extLst>
+          </p:nvPr>
+        </p:nvSpPr>
+        <p:spPr>
+          <a:xfrm rot="10800000" flipH="1">
+            <a:off x="2" y="0"/>
+            <a:ext cx="12191998" cy="1575955"/>
+          </a:xfrm>
+          <a:prstGeom prst="rect">
+            <a:avLst/>
+          </a:prstGeom>
+          <a:gradFill>
+            <a:gsLst>
+              <a:gs pos="0">
+                <a:srgbClr val="000000">
+                  <a:alpha val="96000"/>
+                </a:srgbClr>
+              </a:gs>
+              <a:gs pos="100000">
+                <a:schemeClr val="accent1">
+                  <a:lumMod val="75000"/>
+                </a:schemeClr>
+              </a:gs>
+            </a:gsLst>
+            <a:lin ang="6000000" scaled="0"/>
+          </a:gradFill>
+          <a:ln>
+            <a:noFill/>
+          </a:ln>
+        </p:spPr>
+        <p:style>
+          <a:lnRef idx="2">
+            <a:schemeClr val="accent1">
+              <a:shade val="50000"/>
+            </a:schemeClr>
+          </a:lnRef>
+          <a:fillRef idx="1">
+            <a:schemeClr val="accent1"/>
+          </a:fillRef>
+          <a:effectRef idx="0">
+            <a:schemeClr val="accent1"/>
+          </a:effectRef>
+          <a:fontRef idx="minor">
+            <a:schemeClr val="lt1"/>
+          </a:fontRef>
+        </p:style>
+        <p:txBody>
+          <a:bodyPr rtlCol="0" anchor="ctr"/>
+          <a:lstStyle/>
+          <a:p>
+            <a:pPr algn="ctr"/>
+            <a:endParaRPr lang="en-US"/>
+          </a:p>
+        </p:txBody>
+      </p:sp>
+      <p:sp>
+        <p:nvSpPr>
+          <p:cNvPr id="26" name="Rectangle 25">
+            <a:extLst>
+              <a:ext uri="{FF2B5EF4-FFF2-40B4-BE49-F238E27FC236}">
+                <a16:creationId xmlns:a16="http://schemas.microsoft.com/office/drawing/2014/main" id="{C86A6E7F-851D-810D-089C-E89A97A30BFA}"/>
+              </a:ext>
+              <a:ext uri="{C183D7F6-B498-43B3-948B-1728B52AA6E4}">
+                <adec:decorative xmlns:adec="http://schemas.microsoft.com/office/drawing/2017/decorative" val="1"/>
+              </a:ext>
+            </a:extLst>
+          </p:cNvPr>
+          <p:cNvSpPr>
+            <a:spLocks noGrp="1" noRot="1" noChangeAspect="1" noMove="1" noResize="1" noEditPoints="1" noAdjustHandles="1" noChangeArrowheads="1" noChangeShapeType="1" noTextEdit="1"/>
+          </p:cNvSpPr>
+          <p:nvPr>
+            <p:extLst>
+              <p:ext uri="{386F3935-93C4-4BCD-93E2-E3B085C9AB24}">
+                <p16:designElem xmlns:p16="http://schemas.microsoft.com/office/powerpoint/2015/main" val="1"/>
+              </p:ext>
+            </p:extLst>
+          </p:nvPr>
+        </p:nvSpPr>
+        <p:spPr>
+          <a:xfrm>
+            <a:off x="0" y="0"/>
+            <a:ext cx="8128856" cy="1575461"/>
+          </a:xfrm>
+          <a:prstGeom prst="rect">
+            <a:avLst/>
+          </a:prstGeom>
+          <a:gradFill>
+            <a:gsLst>
+              <a:gs pos="0">
+                <a:schemeClr val="accent1">
+                  <a:alpha val="41000"/>
+                </a:schemeClr>
+              </a:gs>
+              <a:gs pos="74000">
+                <a:schemeClr val="accent1">
+                  <a:lumMod val="60000"/>
+                  <a:lumOff val="40000"/>
+                  <a:alpha val="0"/>
+                </a:schemeClr>
+              </a:gs>
+            </a:gsLst>
+            <a:lin ang="8400000" scaled="0"/>
+          </a:gradFill>
+          <a:ln>
+            <a:noFill/>
+          </a:ln>
+        </p:spPr>
+        <p:style>
+          <a:lnRef idx="2">
+            <a:schemeClr val="accent1">
+              <a:shade val="50000"/>
+            </a:schemeClr>
+          </a:lnRef>
+          <a:fillRef idx="1">
+            <a:schemeClr val="accent1"/>
+          </a:fillRef>
+          <a:effectRef idx="0">
+            <a:schemeClr val="accent1"/>
+          </a:effectRef>
+          <a:fontRef idx="minor">
+            <a:schemeClr val="lt1"/>
+          </a:fontRef>
+        </p:style>
+        <p:txBody>
+          <a:bodyPr rtlCol="0" anchor="ctr"/>
+          <a:lstStyle/>
+          <a:p>
+            <a:pPr algn="ctr"/>
+            <a:endParaRPr lang="en-US"/>
+          </a:p>
+        </p:txBody>
+      </p:sp>
+      <p:sp>
+        <p:nvSpPr>
+          <p:cNvPr id="28" name="Rectangle 27">
+            <a:extLst>
+              <a:ext uri="{FF2B5EF4-FFF2-40B4-BE49-F238E27FC236}">
+                <a16:creationId xmlns:a16="http://schemas.microsoft.com/office/drawing/2014/main" id="{F860C4BB-3224-565F-C43D-838C6F73BC6C}"/>
+              </a:ext>
+              <a:ext uri="{C183D7F6-B498-43B3-948B-1728B52AA6E4}">
+                <adec:decorative xmlns:adec="http://schemas.microsoft.com/office/drawing/2017/decorative" val="1"/>
+              </a:ext>
+            </a:extLst>
+          </p:cNvPr>
+          <p:cNvSpPr>
+            <a:spLocks noGrp="1" noRot="1" noChangeAspect="1" noMove="1" noResize="1" noEditPoints="1" noAdjustHandles="1" noChangeArrowheads="1" noChangeShapeType="1" noTextEdit="1"/>
+          </p:cNvSpPr>
+          <p:nvPr>
+            <p:extLst>
+              <p:ext uri="{386F3935-93C4-4BCD-93E2-E3B085C9AB24}">
+                <p16:designElem xmlns:p16="http://schemas.microsoft.com/office/powerpoint/2015/main" val="1"/>
+              </p:ext>
+            </p:extLst>
+          </p:nvPr>
+        </p:nvSpPr>
+        <p:spPr>
+          <a:xfrm flipH="1">
+            <a:off x="-3" y="-1"/>
+            <a:ext cx="12192002" cy="1574311"/>
+          </a:xfrm>
+          <a:prstGeom prst="rect">
+            <a:avLst/>
+          </a:prstGeom>
+          <a:gradFill>
+            <a:gsLst>
+              <a:gs pos="0">
+                <a:srgbClr val="000000">
+                  <a:alpha val="63000"/>
+                </a:srgbClr>
+              </a:gs>
+              <a:gs pos="78000">
+                <a:schemeClr val="accent1">
+                  <a:alpha val="15000"/>
+                </a:schemeClr>
+              </a:gs>
+            </a:gsLst>
+            <a:lin ang="15600000" scaled="0"/>
+          </a:gradFill>
+          <a:ln>
+            <a:noFill/>
+          </a:ln>
+        </p:spPr>
+        <p:style>
+          <a:lnRef idx="2">
+            <a:schemeClr val="accent1">
+              <a:shade val="50000"/>
+            </a:schemeClr>
+          </a:lnRef>
+          <a:fillRef idx="1">
+            <a:schemeClr val="accent1"/>
+          </a:fillRef>
+          <a:effectRef idx="0">
+            <a:schemeClr val="accent1"/>
+          </a:effectRef>
+          <a:fontRef idx="minor">
+            <a:schemeClr val="lt1"/>
+          </a:fontRef>
+        </p:style>
+        <p:txBody>
+          <a:bodyPr rtlCol="0" anchor="ctr"/>
+          <a:lstStyle/>
+          <a:p>
+            <a:pPr algn="ctr"/>
+            <a:endParaRPr lang="en-US"/>
+          </a:p>
+        </p:txBody>
+      </p:sp>
+      <p:sp>
+        <p:nvSpPr>
+          <p:cNvPr id="2" name="Title 1">
+            <a:extLst>
+              <a:ext uri="{FF2B5EF4-FFF2-40B4-BE49-F238E27FC236}">
+                <a16:creationId xmlns:a16="http://schemas.microsoft.com/office/drawing/2014/main" id="{4513FBEE-3A5D-87B5-2716-8F20DEBE6D38}"/>
+              </a:ext>
+            </a:extLst>
+          </p:cNvPr>
+          <p:cNvSpPr>
+            <a:spLocks noGrp="1"/>
+          </p:cNvSpPr>
+          <p:nvPr>
+            <p:ph type="title"/>
+          </p:nvPr>
+        </p:nvSpPr>
+        <p:spPr>
+          <a:xfrm>
+            <a:off x="699713" y="248038"/>
+            <a:ext cx="7063721" cy="1159200"/>
+          </a:xfrm>
+        </p:spPr>
+        <p:txBody>
+          <a:bodyPr vert="horz" lIns="91440" tIns="45720" rIns="91440" bIns="45720" rtlCol="0" anchor="ctr">
+            <a:normAutofit/>
+          </a:bodyPr>
+          <a:lstStyle/>
+          <a:p>
+            <a:r>
+              <a:rPr lang="en-US" sz="4000" kern="1200" dirty="0">
+                <a:solidFill>
+                  <a:srgbClr val="FFFFFF"/>
+                </a:solidFill>
+                <a:latin typeface="+mj-lt"/>
+                <a:ea typeface="+mj-ea"/>
+                <a:cs typeface="+mj-cs"/>
+              </a:rPr>
+              <a:t>Challenges Page </a:t>
+            </a:r>
+          </a:p>
+        </p:txBody>
+      </p:sp>
+      <p:pic>
+        <p:nvPicPr>
+          <p:cNvPr id="5" name="Picture 4">
+            <a:extLst>
+              <a:ext uri="{FF2B5EF4-FFF2-40B4-BE49-F238E27FC236}">
+                <a16:creationId xmlns:a16="http://schemas.microsoft.com/office/drawing/2014/main" id="{C3FFBE1D-3F8F-C509-C1DD-5AD229415637}"/>
+              </a:ext>
+            </a:extLst>
+          </p:cNvPr>
+          <p:cNvPicPr>
+            <a:picLocks noChangeAspect="1"/>
+          </p:cNvPicPr>
+          <p:nvPr/>
+        </p:nvPicPr>
+        <p:blipFill>
+          <a:blip r:embed="rId2"/>
+          <a:stretch>
+            <a:fillRect/>
+          </a:stretch>
+        </p:blipFill>
+        <p:spPr>
+          <a:xfrm>
+            <a:off x="1612850" y="1574310"/>
+            <a:ext cx="8240597" cy="5116618"/>
+          </a:xfrm>
+          <a:prstGeom prst="rect">
+            <a:avLst/>
+          </a:prstGeom>
+        </p:spPr>
+      </p:pic>
+    </p:spTree>
+    <p:extLst>
+      <p:ext uri="{BB962C8B-B14F-4D97-AF65-F5344CB8AC3E}">
+        <p14:creationId xmlns:p14="http://schemas.microsoft.com/office/powerpoint/2010/main" val="2081720052"/>
+      </p:ext>
+    </p:extLst>
+  </p:cSld>
+  <p:clrMapOvr>
+    <a:masterClrMapping/>
+  </p:clrMapOvr>
+</p:sld>
+</file>
+
+<file path=ppt/slides/slide14.xml><?xml version="1.0" encoding="utf-8"?>
+<p:sld xmlns:a="http://schemas.openxmlformats.org/drawingml/2006/main" xmlns:r="http://schemas.openxmlformats.org/officeDocument/2006/relationships" xmlns:p="http://schemas.openxmlformats.org/presentationml/2006/main">
+  <p:cSld>
+    <p:bg>
+      <p:bgPr>
+        <a:solidFill>
+          <a:schemeClr val="bg1"/>
+        </a:solidFill>
+        <a:effectLst/>
+      </p:bgPr>
+    </p:bg>
+    <p:spTree>
+      <p:nvGrpSpPr>
+        <p:cNvPr id="1" name="">
+          <a:extLst>
+            <a:ext uri="{FF2B5EF4-FFF2-40B4-BE49-F238E27FC236}">
               <a16:creationId xmlns:a16="http://schemas.microsoft.com/office/drawing/2014/main" id="{38138CFD-A501-8AEC-C666-BED845111F6D}"/>
             </a:ext>
           </a:extLst>
@@ -12320,7 +12740,7 @@
 </p:sld>
 </file>
 
-<file path=ppt/slides/slide14.xml><?xml version="1.0" encoding="utf-8"?>
+<file path=ppt/slides/slide15.xml><?xml version="1.0" encoding="utf-8"?>
 <p:sld xmlns:a="http://schemas.openxmlformats.org/drawingml/2006/main" xmlns:r="http://schemas.openxmlformats.org/officeDocument/2006/relationships" xmlns:p="http://schemas.openxmlformats.org/presentationml/2006/main">
   <p:cSld>
     <p:bg>
@@ -12709,7 +13129,7 @@
 </p:sld>
 </file>
 
-<file path=ppt/slides/slide15.xml><?xml version="1.0" encoding="utf-8"?>
+<file path=ppt/slides/slide16.xml><?xml version="1.0" encoding="utf-8"?>
 <p:sld xmlns:a="http://schemas.openxmlformats.org/drawingml/2006/main" xmlns:r="http://schemas.openxmlformats.org/officeDocument/2006/relationships" xmlns:p="http://schemas.openxmlformats.org/presentationml/2006/main">
   <p:cSld>
     <p:bg>

</xml_diff>